<commit_message>
style: expand font size and add generous line spacing on 3-column slides
</commit_message>
<xml_diff>
--- a/G15-PID-17.pptx
+++ b/G15-PID-17.pptx
@@ -3576,11 +3576,11 @@
           </a:fontRef>
         </p:style>
         <p:txBody>
-          <a:bodyPr rtlCol="0" anchor="ctr" lIns="228600" rIns="228600" tIns="228600"/>
+          <a:bodyPr rtlCol="0" anchor="ctr" lIns="228600" rIns="274320" tIns="320040"/>
           <a:lstStyle/>
           <a:p>
             <a:pPr algn="ctr">
-              <a:defRPr sz="1550" b="1">
+              <a:defRPr sz="1700" b="1">
                 <a:solidFill>
                   <a:srgbClr val="3EA6FF"/>
                 </a:solidFill>
@@ -3593,9 +3593,9 @@
           <a:p>
             <a:pPr>
               <a:spcBef>
-                <a:spcPts val="800"/>
+                <a:spcPts val="1800"/>
               </a:spcBef>
-              <a:defRPr sz="1200">
+              <a:defRPr sz="1350">
                 <a:solidFill>
                   <a:srgbClr val="C8CDD7"/>
                 </a:solidFill>
@@ -3608,9 +3608,9 @@
           <a:p>
             <a:pPr>
               <a:spcBef>
-                <a:spcPts val="800"/>
+                <a:spcPts val="1800"/>
               </a:spcBef>
-              <a:defRPr sz="1200">
+              <a:defRPr sz="1350">
                 <a:solidFill>
                   <a:srgbClr val="C8CDD7"/>
                 </a:solidFill>
@@ -3623,9 +3623,9 @@
           <a:p>
             <a:pPr>
               <a:spcBef>
-                <a:spcPts val="800"/>
+                <a:spcPts val="1800"/>
               </a:spcBef>
-              <a:defRPr sz="1200">
+              <a:defRPr sz="1350">
                 <a:solidFill>
                   <a:srgbClr val="C8CDD7"/>
                 </a:solidFill>
@@ -3675,11 +3675,11 @@
           </a:fontRef>
         </p:style>
         <p:txBody>
-          <a:bodyPr rtlCol="0" anchor="ctr" lIns="228600" rIns="228600" tIns="228600"/>
+          <a:bodyPr rtlCol="0" anchor="ctr" lIns="228600" rIns="274320" tIns="320040"/>
           <a:lstStyle/>
           <a:p>
             <a:pPr algn="ctr">
-              <a:defRPr sz="1550" b="1">
+              <a:defRPr sz="1700" b="1">
                 <a:solidFill>
                   <a:srgbClr val="FF0033"/>
                 </a:solidFill>
@@ -3692,9 +3692,9 @@
           <a:p>
             <a:pPr>
               <a:spcBef>
-                <a:spcPts val="800"/>
+                <a:spcPts val="1800"/>
               </a:spcBef>
-              <a:defRPr sz="1200">
+              <a:defRPr sz="1350">
                 <a:solidFill>
                   <a:srgbClr val="C8CDD7"/>
                 </a:solidFill>
@@ -3707,9 +3707,9 @@
           <a:p>
             <a:pPr>
               <a:spcBef>
-                <a:spcPts val="800"/>
+                <a:spcPts val="1800"/>
               </a:spcBef>
-              <a:defRPr sz="1200">
+              <a:defRPr sz="1350">
                 <a:solidFill>
                   <a:srgbClr val="C8CDD7"/>
                 </a:solidFill>
@@ -3722,9 +3722,9 @@
           <a:p>
             <a:pPr>
               <a:spcBef>
-                <a:spcPts val="800"/>
+                <a:spcPts val="1800"/>
               </a:spcBef>
-              <a:defRPr sz="1200">
+              <a:defRPr sz="1350">
                 <a:solidFill>
                   <a:srgbClr val="C8CDD7"/>
                 </a:solidFill>
@@ -3737,9 +3737,9 @@
           <a:p>
             <a:pPr>
               <a:spcBef>
-                <a:spcPts val="800"/>
+                <a:spcPts val="1800"/>
               </a:spcBef>
-              <a:defRPr sz="1200">
+              <a:defRPr sz="1350">
                 <a:solidFill>
                   <a:srgbClr val="C8CDD7"/>
                 </a:solidFill>
@@ -3789,11 +3789,11 @@
           </a:fontRef>
         </p:style>
         <p:txBody>
-          <a:bodyPr rtlCol="0" anchor="ctr" lIns="228600" rIns="228600" tIns="228600"/>
+          <a:bodyPr rtlCol="0" anchor="ctr" lIns="228600" rIns="274320" tIns="320040"/>
           <a:lstStyle/>
           <a:p>
             <a:pPr algn="ctr">
-              <a:defRPr sz="1550" b="1">
+              <a:defRPr sz="1700" b="1">
                 <a:solidFill>
                   <a:srgbClr val="3EA6FF"/>
                 </a:solidFill>
@@ -3806,9 +3806,9 @@
           <a:p>
             <a:pPr>
               <a:spcBef>
-                <a:spcPts val="800"/>
+                <a:spcPts val="1800"/>
               </a:spcBef>
-              <a:defRPr sz="1200">
+              <a:defRPr sz="1350">
                 <a:solidFill>
                   <a:srgbClr val="C8CDD7"/>
                 </a:solidFill>
@@ -3821,9 +3821,9 @@
           <a:p>
             <a:pPr>
               <a:spcBef>
-                <a:spcPts val="800"/>
+                <a:spcPts val="1800"/>
               </a:spcBef>
-              <a:defRPr sz="1200">
+              <a:defRPr sz="1350">
                 <a:solidFill>
                   <a:srgbClr val="C8CDD7"/>
                 </a:solidFill>
@@ -3836,9 +3836,9 @@
           <a:p>
             <a:pPr>
               <a:spcBef>
-                <a:spcPts val="800"/>
+                <a:spcPts val="1800"/>
               </a:spcBef>
-              <a:defRPr sz="1200">
+              <a:defRPr sz="1350">
                 <a:solidFill>
                   <a:srgbClr val="C8CDD7"/>
                 </a:solidFill>
@@ -5378,30 +5378,6 @@
           </a:p>
         </p:txBody>
       </p:sp>
-      <p:pic>
-        <p:nvPicPr>
-          <p:cNvPr id="7" name="Picture 6" descr="ui_search_clean.png"/>
-          <p:cNvPicPr>
-            <a:picLocks noChangeAspect="1"/>
-          </p:cNvPicPr>
-          <p:nvPr/>
-        </p:nvPicPr>
-        <p:blipFill>
-          <a:blip r:embed="rId2"/>
-          <a:stretch>
-            <a:fillRect/>
-          </a:stretch>
-        </p:blipFill>
-        <p:spPr>
-          <a:xfrm>
-            <a:off x="6446520" y="1417320"/>
-            <a:ext cx="5010912" cy="4892040"/>
-          </a:xfrm>
-          <a:prstGeom prst="rect">
-            <a:avLst/>
-          </a:prstGeom>
-        </p:spPr>
-      </p:pic>
     </p:spTree>
   </p:cSld>
   <p:clrMapOvr>
@@ -5579,33 +5555,9 @@
           </a:p>
         </p:txBody>
       </p:sp>
-      <p:pic>
-        <p:nvPicPr>
-          <p:cNvPr id="6" name="Picture 5" descr="ui_sync_clean.png"/>
-          <p:cNvPicPr>
-            <a:picLocks noChangeAspect="1"/>
-          </p:cNvPicPr>
-          <p:nvPr/>
-        </p:nvPicPr>
-        <p:blipFill>
-          <a:blip r:embed="rId2"/>
-          <a:stretch>
-            <a:fillRect/>
-          </a:stretch>
-        </p:blipFill>
-        <p:spPr>
-          <a:xfrm>
-            <a:off x="731520" y="1417320"/>
-            <a:ext cx="5010912" cy="4892040"/>
-          </a:xfrm>
-          <a:prstGeom prst="rect">
-            <a:avLst/>
-          </a:prstGeom>
-        </p:spPr>
-      </p:pic>
-      <p:sp>
-        <p:nvSpPr>
-          <p:cNvPr id="7" name="Rounded Rectangle 6"/>
+      <p:sp>
+        <p:nvSpPr>
+          <p:cNvPr id="6" name="Rounded Rectangle 5"/>
           <p:cNvSpPr/>
           <p:nvPr/>
         </p:nvSpPr>
@@ -6700,11 +6652,11 @@
           </a:fontRef>
         </p:style>
         <p:txBody>
-          <a:bodyPr rtlCol="0" anchor="ctr" lIns="228600" rIns="228600" tIns="228600"/>
+          <a:bodyPr rtlCol="0" anchor="ctr" lIns="228600" rIns="274320" tIns="320040"/>
           <a:lstStyle/>
           <a:p>
             <a:pPr algn="ctr">
-              <a:defRPr sz="1450" b="1">
+              <a:defRPr sz="1650" b="1">
                 <a:solidFill>
                   <a:srgbClr val="3EA6FF"/>
                 </a:solidFill>
@@ -6717,9 +6669,9 @@
           <a:p>
             <a:pPr>
               <a:spcBef>
-                <a:spcPts val="800"/>
+                <a:spcPts val="2000"/>
               </a:spcBef>
-              <a:defRPr sz="1200">
+              <a:defRPr sz="1350">
                 <a:solidFill>
                   <a:srgbClr val="C8CDD7"/>
                 </a:solidFill>
@@ -6732,9 +6684,9 @@
           <a:p>
             <a:pPr>
               <a:spcBef>
-                <a:spcPts val="800"/>
+                <a:spcPts val="2000"/>
               </a:spcBef>
-              <a:defRPr sz="1200">
+              <a:defRPr sz="1350">
                 <a:solidFill>
                   <a:srgbClr val="C8CDD7"/>
                 </a:solidFill>
@@ -6784,11 +6736,11 @@
           </a:fontRef>
         </p:style>
         <p:txBody>
-          <a:bodyPr rtlCol="0" anchor="ctr" lIns="228600" rIns="228600" tIns="228600"/>
+          <a:bodyPr rtlCol="0" anchor="ctr" lIns="228600" rIns="274320" tIns="320040"/>
           <a:lstStyle/>
           <a:p>
             <a:pPr algn="ctr">
-              <a:defRPr sz="1450" b="1">
+              <a:defRPr sz="1650" b="1">
                 <a:solidFill>
                   <a:srgbClr val="FF0033"/>
                 </a:solidFill>
@@ -6801,9 +6753,9 @@
           <a:p>
             <a:pPr>
               <a:spcBef>
-                <a:spcPts val="800"/>
+                <a:spcPts val="2000"/>
               </a:spcBef>
-              <a:defRPr sz="1200">
+              <a:defRPr sz="1350">
                 <a:solidFill>
                   <a:srgbClr val="C8CDD7"/>
                 </a:solidFill>
@@ -6816,9 +6768,9 @@
           <a:p>
             <a:pPr>
               <a:spcBef>
-                <a:spcPts val="800"/>
+                <a:spcPts val="2000"/>
               </a:spcBef>
-              <a:defRPr sz="1200">
+              <a:defRPr sz="1350">
                 <a:solidFill>
                   <a:srgbClr val="C8CDD7"/>
                 </a:solidFill>
@@ -6868,11 +6820,11 @@
           </a:fontRef>
         </p:style>
         <p:txBody>
-          <a:bodyPr rtlCol="0" anchor="ctr" lIns="228600" rIns="228600" tIns="228600"/>
+          <a:bodyPr rtlCol="0" anchor="ctr" lIns="228600" rIns="274320" tIns="320040"/>
           <a:lstStyle/>
           <a:p>
             <a:pPr algn="ctr">
-              <a:defRPr sz="1450" b="1">
+              <a:defRPr sz="1650" b="1">
                 <a:solidFill>
                   <a:srgbClr val="3EA6FF"/>
                 </a:solidFill>
@@ -6885,9 +6837,9 @@
           <a:p>
             <a:pPr>
               <a:spcBef>
-                <a:spcPts val="800"/>
+                <a:spcPts val="2000"/>
               </a:spcBef>
-              <a:defRPr sz="1200">
+              <a:defRPr sz="1350">
                 <a:solidFill>
                   <a:srgbClr val="C8CDD7"/>
                 </a:solidFill>
@@ -6900,9 +6852,9 @@
           <a:p>
             <a:pPr>
               <a:spcBef>
-                <a:spcPts val="800"/>
+                <a:spcPts val="2000"/>
               </a:spcBef>
-              <a:defRPr sz="1200">
+              <a:defRPr sz="1350">
                 <a:solidFill>
                   <a:srgbClr val="C8CDD7"/>
                 </a:solidFill>
@@ -6978,30 +6930,6 @@
           </a:p>
         </p:txBody>
       </p:sp>
-      <p:pic>
-        <p:nvPicPr>
-          <p:cNvPr id="3" name="Picture 2" descr="thankyou_art.png"/>
-          <p:cNvPicPr>
-            <a:picLocks noChangeAspect="1"/>
-          </p:cNvPicPr>
-          <p:nvPr/>
-        </p:nvPicPr>
-        <p:blipFill>
-          <a:blip r:embed="rId2"/>
-          <a:stretch>
-            <a:fillRect/>
-          </a:stretch>
-        </p:blipFill>
-        <p:spPr>
-          <a:xfrm>
-            <a:off x="914400" y="838504"/>
-            <a:ext cx="10362895" cy="5180990"/>
-          </a:xfrm>
-          <a:prstGeom prst="rect">
-            <a:avLst/>
-          </a:prstGeom>
-        </p:spPr>
-      </p:pic>
     </p:spTree>
   </p:cSld>
   <p:clrMapOvr>

</xml_diff>

<commit_message>
docs: attach real project UI screenshots for search engine and state sync slides
</commit_message>
<xml_diff>
--- a/G15-PID-17.pptx
+++ b/G15-PID-17.pptx
@@ -5264,7 +5264,7 @@
           <a:p>
             <a:pPr>
               <a:spcBef>
-                <a:spcPts val="800"/>
+                <a:spcPts val="1300"/>
               </a:spcBef>
               <a:defRPr b="1" sz="1200">
                 <a:solidFill>
@@ -5287,7 +5287,7 @@
           <a:p>
             <a:pPr>
               <a:spcBef>
-                <a:spcPts val="800"/>
+                <a:spcPts val="1300"/>
               </a:spcBef>
               <a:defRPr b="1" sz="1200">
                 <a:solidFill>
@@ -5310,7 +5310,7 @@
           <a:p>
             <a:pPr>
               <a:spcBef>
-                <a:spcPts val="800"/>
+                <a:spcPts val="1300"/>
               </a:spcBef>
               <a:defRPr b="1" sz="1200">
                 <a:solidFill>
@@ -5333,7 +5333,7 @@
           <a:p>
             <a:pPr>
               <a:spcBef>
-                <a:spcPts val="800"/>
+                <a:spcPts val="1300"/>
               </a:spcBef>
               <a:defRPr b="1" sz="1200">
                 <a:solidFill>
@@ -5356,7 +5356,7 @@
           <a:p>
             <a:pPr>
               <a:spcBef>
-                <a:spcPts val="800"/>
+                <a:spcPts val="1300"/>
               </a:spcBef>
               <a:defRPr b="1" sz="1200">
                 <a:solidFill>
@@ -5378,6 +5378,30 @@
           </a:p>
         </p:txBody>
       </p:sp>
+      <p:pic>
+        <p:nvPicPr>
+          <p:cNvPr id="7" name="Picture 6" descr="ui_search_clean.png"/>
+          <p:cNvPicPr>
+            <a:picLocks noChangeAspect="1"/>
+          </p:cNvPicPr>
+          <p:nvPr/>
+        </p:nvPicPr>
+        <p:blipFill>
+          <a:blip r:embed="rId2"/>
+          <a:stretch>
+            <a:fillRect/>
+          </a:stretch>
+        </p:blipFill>
+        <p:spPr>
+          <a:xfrm>
+            <a:off x="6446520" y="1417320"/>
+            <a:ext cx="5010912" cy="4892040"/>
+          </a:xfrm>
+          <a:prstGeom prst="rect">
+            <a:avLst/>
+          </a:prstGeom>
+        </p:spPr>
+      </p:pic>
     </p:spTree>
   </p:cSld>
   <p:clrMapOvr>
@@ -5555,9 +5579,33 @@
           </a:p>
         </p:txBody>
       </p:sp>
-      <p:sp>
-        <p:nvSpPr>
-          <p:cNvPr id="6" name="Rounded Rectangle 5"/>
+      <p:pic>
+        <p:nvPicPr>
+          <p:cNvPr id="6" name="Picture 5" descr="ui_sync_clean.png"/>
+          <p:cNvPicPr>
+            <a:picLocks noChangeAspect="1"/>
+          </p:cNvPicPr>
+          <p:nvPr/>
+        </p:nvPicPr>
+        <p:blipFill>
+          <a:blip r:embed="rId2"/>
+          <a:stretch>
+            <a:fillRect/>
+          </a:stretch>
+        </p:blipFill>
+        <p:spPr>
+          <a:xfrm>
+            <a:off x="731520" y="1417320"/>
+            <a:ext cx="5010912" cy="4892040"/>
+          </a:xfrm>
+          <a:prstGeom prst="rect">
+            <a:avLst/>
+          </a:prstGeom>
+        </p:spPr>
+      </p:pic>
+      <p:sp>
+        <p:nvSpPr>
+          <p:cNvPr id="7" name="Rounded Rectangle 6"/>
           <p:cNvSpPr/>
           <p:nvPr/>
         </p:nvSpPr>
@@ -5610,7 +5658,7 @@
           <a:p>
             <a:pPr>
               <a:spcBef>
-                <a:spcPts val="800"/>
+                <a:spcPts val="1300"/>
               </a:spcBef>
               <a:defRPr b="1" sz="1200">
                 <a:solidFill>
@@ -5633,7 +5681,7 @@
           <a:p>
             <a:pPr>
               <a:spcBef>
-                <a:spcPts val="800"/>
+                <a:spcPts val="1300"/>
               </a:spcBef>
               <a:defRPr b="1" sz="1200">
                 <a:solidFill>
@@ -5656,7 +5704,7 @@
           <a:p>
             <a:pPr>
               <a:spcBef>
-                <a:spcPts val="800"/>
+                <a:spcPts val="1300"/>
               </a:spcBef>
               <a:defRPr b="1" sz="1200">
                 <a:solidFill>
@@ -5679,7 +5727,7 @@
           <a:p>
             <a:pPr>
               <a:spcBef>
-                <a:spcPts val="800"/>
+                <a:spcPts val="1300"/>
               </a:spcBef>
               <a:defRPr b="1" sz="1200">
                 <a:solidFill>
@@ -5702,7 +5750,7 @@
           <a:p>
             <a:pPr>
               <a:spcBef>
-                <a:spcPts val="800"/>
+                <a:spcPts val="1300"/>
               </a:spcBef>
               <a:defRPr b="1" sz="1200">
                 <a:solidFill>

</xml_diff>

<commit_message>
Remove Chitkara logo from slide 1 of PPT and update master PDF
</commit_message>
<xml_diff>
--- a/G15-PID-17.pptx
+++ b/G15-PID-17.pptx
@@ -3195,7 +3195,7 @@
         <p:spPr>
           <a:xfrm>
             <a:off x="731520" y="1097280"/>
-            <a:ext cx="8686800" cy="1645920"/>
+            <a:ext cx="10728655" cy="1645920"/>
           </a:xfrm>
           <a:prstGeom prst="rect">
             <a:avLst/>
@@ -3251,33 +3251,9 @@
           </a:p>
         </p:txBody>
       </p:sp>
-      <p:pic>
-        <p:nvPicPr>
-          <p:cNvPr id="5" name="Picture 4" descr="chitkara_logo.png"/>
-          <p:cNvPicPr>
-            <a:picLocks noChangeAspect="1"/>
-          </p:cNvPicPr>
-          <p:nvPr/>
-        </p:nvPicPr>
-        <p:blipFill>
-          <a:blip r:embed="rId2"/>
-          <a:stretch>
-            <a:fillRect/>
-          </a:stretch>
-        </p:blipFill>
-        <p:spPr>
-          <a:xfrm>
-            <a:off x="9326880" y="1097280"/>
-            <a:ext cx="2103120" cy="393441"/>
-          </a:xfrm>
-          <a:prstGeom prst="rect">
-            <a:avLst/>
-          </a:prstGeom>
-        </p:spPr>
-      </p:pic>
-      <p:sp>
-        <p:nvSpPr>
-          <p:cNvPr id="6" name="Rounded Rectangle 5"/>
+      <p:sp>
+        <p:nvSpPr>
+          <p:cNvPr id="5" name="Rounded Rectangle 4"/>
           <p:cNvSpPr/>
           <p:nvPr/>
         </p:nvSpPr>
@@ -3322,7 +3298,7 @@
       </p:sp>
       <p:sp>
         <p:nvSpPr>
-          <p:cNvPr id="7" name="TextBox 6"/>
+          <p:cNvPr id="6" name="TextBox 5"/>
           <p:cNvSpPr txBox="1"/>
           <p:nvPr/>
         </p:nvSpPr>
@@ -3391,7 +3367,7 @@
       </p:sp>
       <p:sp>
         <p:nvSpPr>
-          <p:cNvPr id="8" name="TextBox 7"/>
+          <p:cNvPr id="7" name="TextBox 6"/>
           <p:cNvSpPr txBox="1"/>
           <p:nvPr/>
         </p:nvSpPr>

</xml_diff>

<commit_message>
Remove Table of Content slide from PPT and update master PDF
</commit_message>
<xml_diff>
--- a/G15-PID-17.pptx
+++ b/G15-PID-17.pptx
@@ -17,7 +17,6 @@
     <p:sldId id="265" r:id="rId16"/>
     <p:sldId id="266" r:id="rId17"/>
     <p:sldId id="267" r:id="rId18"/>
-    <p:sldId id="268" r:id="rId19"/>
   </p:sldIdLst>
   <p:sldSz cx="12191695" cy="6858000" type="screen4x3"/>
   <p:notesSz cx="6858000" cy="9144000"/>
@@ -3635,7 +3634,7 @@
               </a:defRPr>
             </a:pPr>
             <a:r>
-              <a:t>Infinite Scroll Feed &amp; YouTube Data API v3 Engine</a:t>
+              <a:t>Multi-Device Responsive Design &amp; Modern UI/UX Layer</a:t>
             </a:r>
           </a:p>
         </p:txBody>
@@ -3753,7 +3752,7 @@
               </a:defRPr>
             </a:pPr>
             <a:r>
-              <a:t>Infinite Scroll Feed Pagination</a:t>
+              <a:t>Viewport Adaptations &amp; Layout Hierarchy</a:t>
             </a:r>
           </a:p>
           <a:p>
@@ -3768,7 +3767,7 @@
                   <a:srgbClr val="FFFFFF"/>
                 </a:solidFill>
               </a:rPr>
-              <a:t>• react-infinite-scroll-component: </a:t>
+              <a:t>• Desktop (1440px+): </a:t>
             </a:r>
             <a:r>
               <a:rPr sz="1150">
@@ -3776,7 +3775,7 @@
                   <a:srgbClr val="CDD2DC"/>
                 </a:solidFill>
               </a:rPr>
-              <a:t>Continuous feed pagination dynamically fetching video batches as user scrolls down.</a:t>
+              <a:t>Full widescreen layout with expanded 240px sidebar, 4-column video feed, and watch player with up-next rail.</a:t>
             </a:r>
           </a:p>
           <a:p>
@@ -3791,7 +3790,7 @@
                   <a:srgbClr val="FFFFFF"/>
                 </a:solidFill>
               </a:rPr>
-              <a:t>• Zero Churn Reconciliation: </a:t>
+              <a:t>• Tablet / iPad Mini (1024px &amp; 768px): </a:t>
             </a:r>
             <a:r>
               <a:rPr sz="1150">
@@ -3799,7 +3798,7 @@
                   <a:srgbClr val="CDD2DC"/>
                 </a:solidFill>
               </a:rPr>
-              <a:t>Slicing and appending next batches isolates new cards without re-rendering existing items.</a:t>
+              <a:t>Compact collapsed mini-rail sidebar with 2-3 column responsive video card grid.</a:t>
             </a:r>
           </a:p>
           <a:p>
@@ -3814,7 +3813,7 @@
                   <a:srgbClr val="FFFFFF"/>
                 </a:solidFill>
               </a:rPr>
-              <a:t>• Scroll Trigger Geometry: </a:t>
+              <a:t>• Mobile (375px - 480px): </a:t>
             </a:r>
             <a:r>
               <a:rPr sz="1150">
@@ -3822,7 +3821,7 @@
                   <a:srgbClr val="CDD2DC"/>
                 </a:solidFill>
               </a:rPr>
-              <a:t>Viewport intersection thresholds trigger data fetching before reaching bottom of page.</a:t>
+              <a:t>Single-column video stream with bottom drawer navigation and touch-optimized action targets.</a:t>
             </a:r>
           </a:p>
         </p:txBody>
@@ -3900,12 +3899,12 @@
               </a:spcAft>
               <a:defRPr sz="1350" b="1">
                 <a:solidFill>
-                  <a:srgbClr val="A855F7"/>
+                  <a:srgbClr val="2BA640"/>
                 </a:solidFill>
               </a:defRPr>
             </a:pPr>
             <a:r>
-              <a:t>YouTube Data API v3 Live Integration</a:t>
+              <a:t>Design Systems &amp; Visual Feedback</a:t>
             </a:r>
           </a:p>
           <a:p>
@@ -3920,7 +3919,7 @@
                   <a:srgbClr val="FFFFFF"/>
                 </a:solidFill>
               </a:rPr>
-              <a:t>• Google Cloud YouTube API v3: </a:t>
+              <a:t>• Tailwind Fluid Breakpoints: </a:t>
             </a:r>
             <a:r>
               <a:rPr sz="1150">
@@ -3928,7 +3927,7 @@
                   <a:srgbClr val="CDD2DC"/>
                 </a:solidFill>
               </a:rPr>
-              <a:t>Direct RESTful integration querying live YouTube video metadata, thumbnails, and views.</a:t>
+              <a:t>Standardized responsive classes (sm, md, lg, xl) ensuring zero horizontal scrollbars.</a:t>
             </a:r>
           </a:p>
           <a:p>
@@ -3943,7 +3942,7 @@
                   <a:srgbClr val="FFFFFF"/>
                 </a:solidFill>
               </a:rPr>
-              <a:t>• Live Key Manager: </a:t>
+              <a:t>• Glassmorphic Modals: </a:t>
             </a:r>
             <a:r>
               <a:rPr sz="1150">
@@ -3951,7 +3950,7 @@
                   <a:srgbClr val="CDD2DC"/>
                 </a:solidFill>
               </a:rPr>
-              <a:t>In-app settings switch allows entering custom Google Cloud API key to toggle live YouTube data.</a:t>
+              <a:t>High-z-index overlays with backdrop-filter: blur(8px) for Auth and Settings modals.</a:t>
             </a:r>
           </a:p>
           <a:p>
@@ -3966,7 +3965,7 @@
                   <a:srgbClr val="FFFFFF"/>
                 </a:solidFill>
               </a:rPr>
-              <a:t>• Resilient Offline Fallback: </a:t>
+              <a:t>• Micro-Interactions: </a:t>
             </a:r>
             <a:r>
               <a:rPr sz="1150">
@@ -3974,7 +3973,7 @@
                   <a:srgbClr val="CDD2DC"/>
                 </a:solidFill>
               </a:rPr>
-              <a:t>Gracefully falls back to high-fidelity curated mock dataset (youtubeData.js) on quota exhaustion.</a:t>
+              <a:t>Active scale animations, soundwave mic pulse, and hover elevations across all interactive cards.</a:t>
             </a:r>
           </a:p>
         </p:txBody>
@@ -4151,7 +4150,7 @@
               </a:defRPr>
             </a:pPr>
             <a:r>
-              <a:t>Multi-Device Responsive Design &amp; Modern UI/UX Layer</a:t>
+              <a:t>Summary, Live Demonstration &amp; Viva Voce Defense</a:t>
             </a:r>
           </a:p>
         </p:txBody>
@@ -4264,12 +4263,12 @@
               </a:spcAft>
               <a:defRPr sz="1350" b="1">
                 <a:solidFill>
-                  <a:srgbClr val="3EA6FF"/>
+                  <a:srgbClr val="FF0033"/>
                 </a:solidFill>
               </a:defRPr>
             </a:pPr>
             <a:r>
-              <a:t>Viewport Adaptations &amp; Layout Hierarchy</a:t>
+              <a:t>Viva Defense &amp; 1-Minute Pitch</a:t>
             </a:r>
           </a:p>
           <a:p>
@@ -4284,7 +4283,7 @@
                   <a:srgbClr val="FFFFFF"/>
                 </a:solidFill>
               </a:rPr>
-              <a:t>• Desktop (1440px+): </a:t>
+              <a:t>• Viva Title Justification: </a:t>
             </a:r>
             <a:r>
               <a:rPr sz="1150">
@@ -4292,7 +4291,7 @@
                   <a:srgbClr val="CDD2DC"/>
                 </a:solidFill>
               </a:rPr>
-              <a:t>Full widescreen layout with expanded 240px sidebar, 4-column video feed, and watch player with up-next rail.</a:t>
+              <a:t>PheW TuBe represents an ad-free, high-speed streaming platform with 100% in-app media rendering.</a:t>
             </a:r>
           </a:p>
           <a:p>
@@ -4307,7 +4306,7 @@
                   <a:srgbClr val="FFFFFF"/>
                 </a:solidFill>
               </a:rPr>
-              <a:t>• Tablet / iPad Mini (1024px &amp; 768px): </a:t>
+              <a:t>• Core Gap Solved: </a:t>
             </a:r>
             <a:r>
               <a:rPr sz="1150">
@@ -4315,7 +4314,7 @@
                   <a:srgbClr val="CDD2DC"/>
                 </a:solidFill>
               </a:rPr>
-              <a:t>Compact collapsed mini-rail sidebar with 2-3 column responsive video card grid.</a:t>
+              <a:t>Eliminates disruptive external site redirects, offers hands-free Web Speech API search, and provides full YouTube settings.</a:t>
             </a:r>
           </a:p>
           <a:p>
@@ -4330,7 +4329,7 @@
                   <a:srgbClr val="FFFFFF"/>
                 </a:solidFill>
               </a:rPr>
-              <a:t>• Mobile (375px - 480px): </a:t>
+              <a:t>• Target Users: </a:t>
             </a:r>
             <a:r>
               <a:rPr sz="1150">
@@ -4338,7 +4337,7 @@
                   <a:srgbClr val="CDD2DC"/>
                 </a:solidFill>
               </a:rPr>
-              <a:t>Single-column video stream with bottom drawer navigation and touch-optimized action targets.</a:t>
+              <a:t>Students, programmers, and tech enthusiasts requiring distraction-free educational video viewing.</a:t>
             </a:r>
           </a:p>
         </p:txBody>
@@ -4416,12 +4415,12 @@
               </a:spcAft>
               <a:defRPr sz="1350" b="1">
                 <a:solidFill>
-                  <a:srgbClr val="2BA640"/>
+                  <a:srgbClr val="3EA6FF"/>
                 </a:solidFill>
               </a:defRPr>
             </a:pPr>
             <a:r>
-              <a:t>Design Systems &amp; Visual Feedback</a:t>
+              <a:t>Technical Merit &amp; Demonstration Roadmap</a:t>
             </a:r>
           </a:p>
           <a:p>
@@ -4436,7 +4435,7 @@
                   <a:srgbClr val="FFFFFF"/>
                 </a:solidFill>
               </a:rPr>
-              <a:t>• Tailwind Fluid Breakpoints: </a:t>
+              <a:t>• Key Engineering Highlight: </a:t>
             </a:r>
             <a:r>
               <a:rPr sz="1150">
@@ -4444,7 +4443,7 @@
                   <a:srgbClr val="CDD2DC"/>
                 </a:solidFill>
               </a:rPr>
-              <a:t>Standardized responsive classes (sm, md, lg, xl) ensuring zero horizontal scrollbars.</a:t>
+              <a:t>React 18 component composition + Context API eliminating full-tree re-renders.</a:t>
             </a:r>
           </a:p>
           <a:p>
@@ -4459,7 +4458,7 @@
                   <a:srgbClr val="FFFFFF"/>
                 </a:solidFill>
               </a:rPr>
-              <a:t>• Glassmorphic Modals: </a:t>
+              <a:t>• Live Demonstration Flow: </a:t>
             </a:r>
             <a:r>
               <a:rPr sz="1150">
@@ -4467,7 +4466,7 @@
                   <a:srgbClr val="CDD2DC"/>
                 </a:solidFill>
               </a:rPr>
-              <a:t>High-z-index overlays with backdrop-filter: blur(8px) for Auth and Settings modals.</a:t>
+              <a:t>1) Home feed &amp; Infinite Scroll -&gt; 2) Voice Search &amp; Filter -&gt; 3) In-Site Watch Player &amp; Likes -&gt; 4) Protected Route Lock -&gt; 5) Settings Modal.</a:t>
             </a:r>
           </a:p>
           <a:p>
@@ -4482,7 +4481,7 @@
                   <a:srgbClr val="FFFFFF"/>
                 </a:solidFill>
               </a:rPr>
-              <a:t>• Micro-Interactions: </a:t>
+              <a:t>• Evaluation Status: </a:t>
             </a:r>
             <a:r>
               <a:rPr sz="1150">
@@ -4490,7 +4489,7 @@
                   <a:srgbClr val="CDD2DC"/>
                 </a:solidFill>
               </a:rPr>
-              <a:t>Active scale animations, soundwave mic pulse, and hover elevations across all interactive cards.</a:t>
+              <a:t>100% feature-complete, zero console errors, passing Vite production build in 1.16s.</a:t>
             </a:r>
           </a:p>
         </p:txBody>
@@ -4561,522 +4560,6 @@
       </p:sp>
       <p:sp>
         <p:nvSpPr>
-          <p:cNvPr id="3" name="Rectangle 2"/>
-          <p:cNvSpPr/>
-          <p:nvPr/>
-        </p:nvSpPr>
-        <p:spPr>
-          <a:xfrm>
-            <a:off x="731520" y="365760"/>
-            <a:ext cx="365760" cy="54864"/>
-          </a:xfrm>
-          <a:prstGeom prst="rect">
-            <a:avLst/>
-          </a:prstGeom>
-          <a:solidFill>
-            <a:srgbClr val="FF0033"/>
-          </a:solidFill>
-          <a:ln>
-            <a:noFill/>
-          </a:ln>
-        </p:spPr>
-        <p:style>
-          <a:lnRef idx="1">
-            <a:schemeClr val="accent1"/>
-          </a:lnRef>
-          <a:fillRef idx="3">
-            <a:schemeClr val="accent1"/>
-          </a:fillRef>
-          <a:effectRef idx="2">
-            <a:schemeClr val="accent1"/>
-          </a:effectRef>
-          <a:fontRef idx="minor">
-            <a:schemeClr val="lt1"/>
-          </a:fontRef>
-        </p:style>
-        <p:txBody>
-          <a:bodyPr rtlCol="0" anchor="ctr"/>
-          <a:lstStyle/>
-          <a:p>
-            <a:pPr algn="ctr"/>
-          </a:p>
-        </p:txBody>
-      </p:sp>
-      <p:sp>
-        <p:nvSpPr>
-          <p:cNvPr id="4" name="TextBox 3"/>
-          <p:cNvSpPr txBox="1"/>
-          <p:nvPr/>
-        </p:nvSpPr>
-        <p:spPr>
-          <a:xfrm>
-            <a:off x="1188720" y="292608"/>
-            <a:ext cx="10241280" cy="274320"/>
-          </a:xfrm>
-          <a:prstGeom prst="rect">
-            <a:avLst/>
-          </a:prstGeom>
-          <a:noFill/>
-        </p:spPr>
-        <p:txBody>
-          <a:bodyPr wrap="none">
-            <a:spAutoFit/>
-          </a:bodyPr>
-          <a:lstStyle/>
-          <a:p>
-            <a:pPr>
-              <a:defRPr sz="1150" b="1">
-                <a:solidFill>
-                  <a:srgbClr val="3EA6FF"/>
-                </a:solidFill>
-              </a:defRPr>
-            </a:pPr>
-            <a:r>
-              <a:t>GROUP G15  •  PROJECT ID: G15-PID-17 (P-17)  •  EVALUATION-II (PHASE 2)</a:t>
-            </a:r>
-          </a:p>
-        </p:txBody>
-      </p:sp>
-      <p:sp>
-        <p:nvSpPr>
-          <p:cNvPr id="5" name="TextBox 4"/>
-          <p:cNvSpPr txBox="1"/>
-          <p:nvPr/>
-        </p:nvSpPr>
-        <p:spPr>
-          <a:xfrm>
-            <a:off x="731520" y="621792"/>
-            <a:ext cx="10728655" cy="594360"/>
-          </a:xfrm>
-          <a:prstGeom prst="rect">
-            <a:avLst/>
-          </a:prstGeom>
-          <a:noFill/>
-        </p:spPr>
-        <p:txBody>
-          <a:bodyPr wrap="square">
-            <a:spAutoFit/>
-          </a:bodyPr>
-          <a:lstStyle/>
-          <a:p>
-            <a:pPr>
-              <a:defRPr sz="2300" b="1">
-                <a:solidFill>
-                  <a:srgbClr val="FFFFFF"/>
-                </a:solidFill>
-              </a:defRPr>
-            </a:pPr>
-            <a:r>
-              <a:t>Summary, Live Demonstration &amp; Viva Voce Defense</a:t>
-            </a:r>
-          </a:p>
-        </p:txBody>
-      </p:sp>
-      <p:sp>
-        <p:nvSpPr>
-          <p:cNvPr id="6" name="TextBox 5"/>
-          <p:cNvSpPr txBox="1"/>
-          <p:nvPr/>
-        </p:nvSpPr>
-        <p:spPr>
-          <a:xfrm>
-            <a:off x="731520" y="6327648"/>
-            <a:ext cx="10728655" cy="274320"/>
-          </a:xfrm>
-          <a:prstGeom prst="rect">
-            <a:avLst/>
-          </a:prstGeom>
-          <a:noFill/>
-        </p:spPr>
-        <p:txBody>
-          <a:bodyPr wrap="none">
-            <a:spAutoFit/>
-          </a:bodyPr>
-          <a:lstStyle/>
-          <a:p>
-            <a:pPr>
-              <a:defRPr sz="1000">
-                <a:solidFill>
-                  <a:srgbClr val="8C94A5"/>
-                </a:solidFill>
-              </a:defRPr>
-            </a:pPr>
-            <a:r>
-              <a:t>PheW TuBe: Video Streaming Platform (G15-PID-17)  |  Chitkara University FEE-II  |  Page 12</a:t>
-            </a:r>
-          </a:p>
-        </p:txBody>
-      </p:sp>
-      <p:sp>
-        <p:nvSpPr>
-          <p:cNvPr id="7" name="Rounded Rectangle 6"/>
-          <p:cNvSpPr/>
-          <p:nvPr/>
-        </p:nvSpPr>
-        <p:spPr>
-          <a:xfrm>
-            <a:off x="731520" y="1325880"/>
-            <a:ext cx="5212080" cy="4663440"/>
-          </a:xfrm>
-          <a:prstGeom prst="roundRect">
-            <a:avLst/>
-          </a:prstGeom>
-          <a:solidFill>
-            <a:srgbClr val="161922"/>
-          </a:solidFill>
-          <a:ln w="16510">
-            <a:solidFill>
-              <a:srgbClr val="2E3445"/>
-            </a:solidFill>
-          </a:ln>
-        </p:spPr>
-        <p:style>
-          <a:lnRef idx="1">
-            <a:schemeClr val="accent1"/>
-          </a:lnRef>
-          <a:fillRef idx="3">
-            <a:schemeClr val="accent1"/>
-          </a:fillRef>
-          <a:effectRef idx="2">
-            <a:schemeClr val="accent1"/>
-          </a:effectRef>
-          <a:fontRef idx="minor">
-            <a:schemeClr val="lt1"/>
-          </a:fontRef>
-        </p:style>
-        <p:txBody>
-          <a:bodyPr rtlCol="0" anchor="ctr"/>
-          <a:lstStyle/>
-          <a:p>
-            <a:pPr algn="ctr"/>
-          </a:p>
-        </p:txBody>
-      </p:sp>
-      <p:sp>
-        <p:nvSpPr>
-          <p:cNvPr id="8" name="TextBox 7"/>
-          <p:cNvSpPr txBox="1"/>
-          <p:nvPr/>
-        </p:nvSpPr>
-        <p:spPr>
-          <a:xfrm>
-            <a:off x="932688" y="1490472"/>
-            <a:ext cx="4809744" cy="4334255"/>
-          </a:xfrm>
-          <a:prstGeom prst="rect">
-            <a:avLst/>
-          </a:prstGeom>
-          <a:noFill/>
-        </p:spPr>
-        <p:txBody>
-          <a:bodyPr wrap="square" tIns="0" bIns="0" lIns="0" rIns="0">
-            <a:spAutoFit/>
-          </a:bodyPr>
-          <a:lstStyle/>
-          <a:p>
-            <a:pPr>
-              <a:spcAft>
-                <a:spcPts val="1000"/>
-              </a:spcAft>
-              <a:defRPr sz="1350" b="1">
-                <a:solidFill>
-                  <a:srgbClr val="FF0033"/>
-                </a:solidFill>
-              </a:defRPr>
-            </a:pPr>
-            <a:r>
-              <a:t>Viva Defense &amp; 1-Minute Pitch</a:t>
-            </a:r>
-          </a:p>
-          <a:p>
-            <a:pPr>
-              <a:spcAft>
-                <a:spcPts val="800"/>
-              </a:spcAft>
-            </a:pPr>
-            <a:r>
-              <a:rPr sz="1150" b="1">
-                <a:solidFill>
-                  <a:srgbClr val="FFFFFF"/>
-                </a:solidFill>
-              </a:rPr>
-              <a:t>• Viva Title Justification: </a:t>
-            </a:r>
-            <a:r>
-              <a:rPr sz="1150">
-                <a:solidFill>
-                  <a:srgbClr val="CDD2DC"/>
-                </a:solidFill>
-              </a:rPr>
-              <a:t>PheW TuBe represents an ad-free, high-speed streaming platform with 100% in-app media rendering.</a:t>
-            </a:r>
-          </a:p>
-          <a:p>
-            <a:pPr>
-              <a:spcAft>
-                <a:spcPts val="800"/>
-              </a:spcAft>
-            </a:pPr>
-            <a:r>
-              <a:rPr sz="1150" b="1">
-                <a:solidFill>
-                  <a:srgbClr val="FFFFFF"/>
-                </a:solidFill>
-              </a:rPr>
-              <a:t>• Core Gap Solved: </a:t>
-            </a:r>
-            <a:r>
-              <a:rPr sz="1150">
-                <a:solidFill>
-                  <a:srgbClr val="CDD2DC"/>
-                </a:solidFill>
-              </a:rPr>
-              <a:t>Eliminates disruptive external site redirects, offers hands-free Web Speech API search, and provides full YouTube settings.</a:t>
-            </a:r>
-          </a:p>
-          <a:p>
-            <a:pPr>
-              <a:spcAft>
-                <a:spcPts val="800"/>
-              </a:spcAft>
-            </a:pPr>
-            <a:r>
-              <a:rPr sz="1150" b="1">
-                <a:solidFill>
-                  <a:srgbClr val="FFFFFF"/>
-                </a:solidFill>
-              </a:rPr>
-              <a:t>• Target Users: </a:t>
-            </a:r>
-            <a:r>
-              <a:rPr sz="1150">
-                <a:solidFill>
-                  <a:srgbClr val="CDD2DC"/>
-                </a:solidFill>
-              </a:rPr>
-              <a:t>Students, programmers, and tech enthusiasts requiring distraction-free educational video viewing.</a:t>
-            </a:r>
-          </a:p>
-        </p:txBody>
-      </p:sp>
-      <p:sp>
-        <p:nvSpPr>
-          <p:cNvPr id="9" name="Rounded Rectangle 8"/>
-          <p:cNvSpPr/>
-          <p:nvPr/>
-        </p:nvSpPr>
-        <p:spPr>
-          <a:xfrm>
-            <a:off x="6248095" y="1325880"/>
-            <a:ext cx="5212080" cy="4663440"/>
-          </a:xfrm>
-          <a:prstGeom prst="roundRect">
-            <a:avLst/>
-          </a:prstGeom>
-          <a:solidFill>
-            <a:srgbClr val="161922"/>
-          </a:solidFill>
-          <a:ln w="16510">
-            <a:solidFill>
-              <a:srgbClr val="2E3445"/>
-            </a:solidFill>
-          </a:ln>
-        </p:spPr>
-        <p:style>
-          <a:lnRef idx="1">
-            <a:schemeClr val="accent1"/>
-          </a:lnRef>
-          <a:fillRef idx="3">
-            <a:schemeClr val="accent1"/>
-          </a:fillRef>
-          <a:effectRef idx="2">
-            <a:schemeClr val="accent1"/>
-          </a:effectRef>
-          <a:fontRef idx="minor">
-            <a:schemeClr val="lt1"/>
-          </a:fontRef>
-        </p:style>
-        <p:txBody>
-          <a:bodyPr rtlCol="0" anchor="ctr"/>
-          <a:lstStyle/>
-          <a:p>
-            <a:pPr algn="ctr"/>
-          </a:p>
-        </p:txBody>
-      </p:sp>
-      <p:sp>
-        <p:nvSpPr>
-          <p:cNvPr id="10" name="TextBox 9"/>
-          <p:cNvSpPr txBox="1"/>
-          <p:nvPr/>
-        </p:nvSpPr>
-        <p:spPr>
-          <a:xfrm>
-            <a:off x="6449263" y="1490472"/>
-            <a:ext cx="4809744" cy="4334255"/>
-          </a:xfrm>
-          <a:prstGeom prst="rect">
-            <a:avLst/>
-          </a:prstGeom>
-          <a:noFill/>
-        </p:spPr>
-        <p:txBody>
-          <a:bodyPr wrap="square" tIns="0" bIns="0" lIns="0" rIns="0">
-            <a:spAutoFit/>
-          </a:bodyPr>
-          <a:lstStyle/>
-          <a:p>
-            <a:pPr>
-              <a:spcAft>
-                <a:spcPts val="1000"/>
-              </a:spcAft>
-              <a:defRPr sz="1350" b="1">
-                <a:solidFill>
-                  <a:srgbClr val="3EA6FF"/>
-                </a:solidFill>
-              </a:defRPr>
-            </a:pPr>
-            <a:r>
-              <a:t>Technical Merit &amp; Demonstration Roadmap</a:t>
-            </a:r>
-          </a:p>
-          <a:p>
-            <a:pPr>
-              <a:spcAft>
-                <a:spcPts val="800"/>
-              </a:spcAft>
-            </a:pPr>
-            <a:r>
-              <a:rPr sz="1150" b="1">
-                <a:solidFill>
-                  <a:srgbClr val="FFFFFF"/>
-                </a:solidFill>
-              </a:rPr>
-              <a:t>• Key Engineering Highlight: </a:t>
-            </a:r>
-            <a:r>
-              <a:rPr sz="1150">
-                <a:solidFill>
-                  <a:srgbClr val="CDD2DC"/>
-                </a:solidFill>
-              </a:rPr>
-              <a:t>React 18 component composition + Context API eliminating full-tree re-renders.</a:t>
-            </a:r>
-          </a:p>
-          <a:p>
-            <a:pPr>
-              <a:spcAft>
-                <a:spcPts val="800"/>
-              </a:spcAft>
-            </a:pPr>
-            <a:r>
-              <a:rPr sz="1150" b="1">
-                <a:solidFill>
-                  <a:srgbClr val="FFFFFF"/>
-                </a:solidFill>
-              </a:rPr>
-              <a:t>• Live Demonstration Flow: </a:t>
-            </a:r>
-            <a:r>
-              <a:rPr sz="1150">
-                <a:solidFill>
-                  <a:srgbClr val="CDD2DC"/>
-                </a:solidFill>
-              </a:rPr>
-              <a:t>1) Home feed &amp; Infinite Scroll -&gt; 2) Voice Search &amp; Filter -&gt; 3) In-Site Watch Player &amp; Likes -&gt; 4) Protected Route Lock -&gt; 5) Settings Modal.</a:t>
-            </a:r>
-          </a:p>
-          <a:p>
-            <a:pPr>
-              <a:spcAft>
-                <a:spcPts val="800"/>
-              </a:spcAft>
-            </a:pPr>
-            <a:r>
-              <a:rPr sz="1150" b="1">
-                <a:solidFill>
-                  <a:srgbClr val="FFFFFF"/>
-                </a:solidFill>
-              </a:rPr>
-              <a:t>• Evaluation Status: </a:t>
-            </a:r>
-            <a:r>
-              <a:rPr sz="1150">
-                <a:solidFill>
-                  <a:srgbClr val="CDD2DC"/>
-                </a:solidFill>
-              </a:rPr>
-              <a:t>100% feature-complete, zero console errors, passing Vite production build in 1.16s.</a:t>
-            </a:r>
-          </a:p>
-        </p:txBody>
-      </p:sp>
-    </p:spTree>
-  </p:cSld>
-  <p:clrMapOvr>
-    <a:masterClrMapping/>
-  </p:clrMapOvr>
-  <p:transition spd="fast">
-    <p:push dir="l"/>
-  </p:transition>
-</p:sld>
-</file>
-
-<file path=ppt/slides/slide13.xml><?xml version="1.0" encoding="utf-8"?>
-<p:sld xmlns:a="http://schemas.openxmlformats.org/drawingml/2006/main" xmlns:p="http://schemas.openxmlformats.org/presentationml/2006/main" xmlns:r="http://schemas.openxmlformats.org/officeDocument/2006/relationships">
-  <p:cSld>
-    <p:spTree>
-      <p:nvGrpSpPr>
-        <p:cNvPr id="1" name=""/>
-        <p:cNvGrpSpPr/>
-        <p:nvPr/>
-      </p:nvGrpSpPr>
-      <p:grpSpPr/>
-      <p:sp>
-        <p:nvSpPr>
-          <p:cNvPr id="2" name="Rectangle 1"/>
-          <p:cNvSpPr/>
-          <p:nvPr/>
-        </p:nvSpPr>
-        <p:spPr>
-          <a:xfrm>
-            <a:off x="0" y="0"/>
-            <a:ext cx="12191695" cy="6858000"/>
-          </a:xfrm>
-          <a:prstGeom prst="rect">
-            <a:avLst/>
-          </a:prstGeom>
-          <a:solidFill>
-            <a:srgbClr val="0B0C10"/>
-          </a:solidFill>
-          <a:ln>
-            <a:noFill/>
-          </a:ln>
-        </p:spPr>
-        <p:style>
-          <a:lnRef idx="1">
-            <a:schemeClr val="accent1"/>
-          </a:lnRef>
-          <a:fillRef idx="3">
-            <a:schemeClr val="accent1"/>
-          </a:fillRef>
-          <a:effectRef idx="2">
-            <a:schemeClr val="accent1"/>
-          </a:effectRef>
-          <a:fontRef idx="minor">
-            <a:schemeClr val="lt1"/>
-          </a:fontRef>
-        </p:style>
-        <p:txBody>
-          <a:bodyPr rtlCol="0" anchor="ctr"/>
-          <a:lstStyle/>
-          <a:p>
-            <a:pPr algn="ctr"/>
-          </a:p>
-        </p:txBody>
-      </p:sp>
-      <p:sp>
-        <p:nvSpPr>
           <p:cNvPr id="3" name="Rounded Rectangle 2"/>
           <p:cNvSpPr/>
           <p:nvPr/>
@@ -5372,7 +4855,7 @@
               </a:defRPr>
             </a:pPr>
             <a:r>
-              <a:t>Table of Content</a:t>
+              <a:t>Evaluation-II Vision &amp; Milestone Objectives</a:t>
             </a:r>
           </a:p>
         </p:txBody>
@@ -5421,7 +4904,7 @@
         <p:spPr>
           <a:xfrm>
             <a:off x="731520" y="1325880"/>
-            <a:ext cx="5212080" cy="4663440"/>
+            <a:ext cx="3383280" cy="4663440"/>
           </a:xfrm>
           <a:prstGeom prst="roundRect">
             <a:avLst/>
@@ -5465,8 +4948,8 @@
         </p:nvSpPr>
         <p:spPr>
           <a:xfrm>
-            <a:off x="1005840" y="1554480"/>
-            <a:ext cx="4663440" cy="4206240"/>
+            <a:off x="932688" y="1490472"/>
+            <a:ext cx="2980944" cy="4334255"/>
           </a:xfrm>
           <a:prstGeom prst="rect">
             <a:avLst/>
@@ -5474,123 +4957,92 @@
           <a:noFill/>
         </p:spPr>
         <p:txBody>
-          <a:bodyPr wrap="square">
+          <a:bodyPr wrap="square" tIns="0" bIns="0" lIns="0" rIns="0">
             <a:spAutoFit/>
           </a:bodyPr>
           <a:lstStyle/>
           <a:p>
             <a:pPr>
               <a:spcAft>
-                <a:spcPts val="1600"/>
-              </a:spcAft>
-            </a:pPr>
-            <a:r>
-              <a:rPr sz="1300" b="1">
+                <a:spcPts val="1000"/>
+              </a:spcAft>
+              <a:defRPr sz="1350" b="1">
                 <a:solidFill>
                   <a:srgbClr val="FF0033"/>
                 </a:solidFill>
-              </a:rPr>
-              <a:t>01. </a:t>
-            </a:r>
-            <a:r>
-              <a:rPr sz="1200" b="1">
+              </a:defRPr>
+            </a:pPr>
+            <a:r>
+              <a:t>Phase 1 vs Phase 2 Focus</a:t>
+            </a:r>
+          </a:p>
+          <a:p>
+            <a:pPr>
+              <a:spcAft>
+                <a:spcPts val="800"/>
+              </a:spcAft>
+            </a:pPr>
+            <a:r>
+              <a:rPr sz="1150" b="1">
                 <a:solidFill>
                   <a:srgbClr val="FFFFFF"/>
                 </a:solidFill>
               </a:rPr>
-              <a:t>Evaluation-II Vision &amp; Milestone Objectives (Page 03)</a:t>
-            </a:r>
-          </a:p>
-          <a:p>
-            <a:pPr>
-              <a:spcAft>
-                <a:spcPts val="1600"/>
-              </a:spcAft>
-            </a:pPr>
-            <a:r>
-              <a:rPr sz="1300" b="1">
-                <a:solidFill>
-                  <a:srgbClr val="3EA6FF"/>
-                </a:solidFill>
-              </a:rPr>
-              <a:t>02. </a:t>
-            </a:r>
-            <a:r>
-              <a:rPr sz="1200" b="1">
+              <a:t>• Phase 1 Foundation: </a:t>
+            </a:r>
+            <a:r>
+              <a:rPr sz="1150">
+                <a:solidFill>
+                  <a:srgbClr val="CDD2DC"/>
+                </a:solidFill>
+              </a:rPr>
+              <a:t>Established responsive video card grids, category chips, and external links.</a:t>
+            </a:r>
+          </a:p>
+          <a:p>
+            <a:pPr>
+              <a:spcAft>
+                <a:spcPts val="800"/>
+              </a:spcAft>
+            </a:pPr>
+            <a:r>
+              <a:rPr sz="1150" b="1">
                 <a:solidFill>
                   <a:srgbClr val="FFFFFF"/>
                 </a:solidFill>
               </a:rPr>
-              <a:t>Syllabus-Aligned Technology Stack &amp; Architecture (Page 04)</a:t>
-            </a:r>
-          </a:p>
-          <a:p>
-            <a:pPr>
-              <a:spcAft>
-                <a:spcPts val="1600"/>
-              </a:spcAft>
-            </a:pPr>
-            <a:r>
-              <a:rPr sz="1300" b="1">
-                <a:solidFill>
-                  <a:srgbClr val="FF0033"/>
-                </a:solidFill>
-              </a:rPr>
-              <a:t>03. </a:t>
-            </a:r>
-            <a:r>
-              <a:rPr sz="1200" b="1">
+              <a:t>• Phase 2 Transition: </a:t>
+            </a:r>
+            <a:r>
+              <a:rPr sz="1150">
+                <a:solidFill>
+                  <a:srgbClr val="CDD2DC"/>
+                </a:solidFill>
+              </a:rPr>
+              <a:t>Elevated PheW TuBe into an authentic, stateful Single Page Application (SPA).</a:t>
+            </a:r>
+          </a:p>
+          <a:p>
+            <a:pPr>
+              <a:spcAft>
+                <a:spcPts val="800"/>
+              </a:spcAft>
+            </a:pPr>
+            <a:r>
+              <a:rPr sz="1150" b="1">
                 <a:solidFill>
                   <a:srgbClr val="FFFFFF"/>
                 </a:solidFill>
               </a:rPr>
-              <a:t>Core Component Architecture &amp; Modularity (Page 05)</a:t>
-            </a:r>
-          </a:p>
-          <a:p>
-            <a:pPr>
-              <a:spcAft>
-                <a:spcPts val="1600"/>
-              </a:spcAft>
-            </a:pPr>
-            <a:r>
-              <a:rPr sz="1300" b="1">
-                <a:solidFill>
-                  <a:srgbClr val="3EA6FF"/>
-                </a:solidFill>
-              </a:rPr>
-              <a:t>04. </a:t>
-            </a:r>
-            <a:r>
-              <a:rPr sz="1200" b="1">
-                <a:solidFill>
-                  <a:srgbClr val="FFFFFF"/>
-                </a:solidFill>
-              </a:rPr>
-              <a:t>In-Site Video Streaming Engine (No Redirecting) (Page 06)</a:t>
-            </a:r>
-          </a:p>
-          <a:p>
-            <a:pPr>
-              <a:spcAft>
-                <a:spcPts val="1600"/>
-              </a:spcAft>
-            </a:pPr>
-            <a:r>
-              <a:rPr sz="1300" b="1">
-                <a:solidFill>
-                  <a:srgbClr val="FF0033"/>
-                </a:solidFill>
-              </a:rPr>
-              <a:t>05. </a:t>
-            </a:r>
-            <a:r>
-              <a:rPr sz="1200" b="1">
-                <a:solidFill>
-                  <a:srgbClr val="FFFFFF"/>
-                </a:solidFill>
-              </a:rPr>
-              <a:t>Interactive Comments System with useRef &amp; Speech API (Page 07)</a:t>
+              <a:t>• Zero Page Reloads: </a:t>
+            </a:r>
+            <a:r>
+              <a:rPr sz="1150">
+                <a:solidFill>
+                  <a:srgbClr val="CDD2DC"/>
+                </a:solidFill>
+              </a:rPr>
+              <a:t>Client-side routing via React Router DOM ensures instant state reactivity without full flushes.</a:t>
             </a:r>
           </a:p>
         </p:txBody>
@@ -5603,8 +5055,8 @@
         </p:nvSpPr>
         <p:spPr>
           <a:xfrm>
-            <a:off x="6248095" y="1325880"/>
-            <a:ext cx="5212080" cy="4663440"/>
+            <a:off x="4403750" y="1325880"/>
+            <a:ext cx="3383280" cy="4663440"/>
           </a:xfrm>
           <a:prstGeom prst="roundRect">
             <a:avLst/>
@@ -5648,8 +5100,8 @@
         </p:nvSpPr>
         <p:spPr>
           <a:xfrm>
-            <a:off x="6522415" y="1554480"/>
-            <a:ext cx="4663440" cy="4206240"/>
+            <a:off x="4604918" y="1490472"/>
+            <a:ext cx="2980944" cy="4334255"/>
           </a:xfrm>
           <a:prstGeom prst="rect">
             <a:avLst/>
@@ -5657,123 +5109,244 @@
           <a:noFill/>
         </p:spPr>
         <p:txBody>
-          <a:bodyPr wrap="square">
+          <a:bodyPr wrap="square" tIns="0" bIns="0" lIns="0" rIns="0">
             <a:spAutoFit/>
           </a:bodyPr>
           <a:lstStyle/>
           <a:p>
             <a:pPr>
               <a:spcAft>
-                <a:spcPts val="1600"/>
-              </a:spcAft>
-            </a:pPr>
-            <a:r>
-              <a:rPr sz="1300" b="1">
-                <a:solidFill>
-                  <a:srgbClr val="FF0033"/>
-                </a:solidFill>
-              </a:rPr>
-              <a:t>06. </a:t>
-            </a:r>
-            <a:r>
-              <a:rPr sz="1200" b="1">
+                <a:spcPts val="1000"/>
+              </a:spcAft>
+              <a:defRPr sz="1350" b="1">
+                <a:solidFill>
+                  <a:srgbClr val="3EA6FF"/>
+                </a:solidFill>
+              </a:defRPr>
+            </a:pPr>
+            <a:r>
+              <a:t>Core Technical Objectives</a:t>
+            </a:r>
+          </a:p>
+          <a:p>
+            <a:pPr>
+              <a:spcAft>
+                <a:spcPts val="800"/>
+              </a:spcAft>
+            </a:pPr>
+            <a:r>
+              <a:rPr sz="1150" b="1">
                 <a:solidFill>
                   <a:srgbClr val="FFFFFF"/>
                 </a:solidFill>
               </a:rPr>
-              <a:t>Protected Routing &amp; Auth Guard Architecture (Page 08)</a:t>
-            </a:r>
-          </a:p>
-          <a:p>
-            <a:pPr>
-              <a:spcAft>
-                <a:spcPts val="1600"/>
-              </a:spcAft>
-            </a:pPr>
-            <a:r>
-              <a:rPr sz="1300" b="1">
-                <a:solidFill>
-                  <a:srgbClr val="3EA6FF"/>
-                </a:solidFill>
-              </a:rPr>
-              <a:t>07. </a:t>
-            </a:r>
-            <a:r>
-              <a:rPr sz="1200" b="1">
+              <a:t>• In-Site Streaming: </a:t>
+            </a:r>
+            <a:r>
+              <a:rPr sz="1150">
+                <a:solidFill>
+                  <a:srgbClr val="CDD2DC"/>
+                </a:solidFill>
+              </a:rPr>
+              <a:t>Deep link /watch/:id powered by useParams() with embedded 16:9 streaming.</a:t>
+            </a:r>
+          </a:p>
+          <a:p>
+            <a:pPr>
+              <a:spcAft>
+                <a:spcPts val="800"/>
+              </a:spcAft>
+            </a:pPr>
+            <a:r>
+              <a:rPr sz="1150" b="1">
                 <a:solidFill>
                   <a:srgbClr val="FFFFFF"/>
                 </a:solidFill>
               </a:rPr>
-              <a:t>Infinite Scroll Feed &amp; YouTube Data API v3 (Page 09)</a:t>
-            </a:r>
-          </a:p>
-          <a:p>
-            <a:pPr>
-              <a:spcAft>
-                <a:spcPts val="1600"/>
-              </a:spcAft>
-            </a:pPr>
-            <a:r>
-              <a:rPr sz="1300" b="1">
-                <a:solidFill>
-                  <a:srgbClr val="FF0033"/>
-                </a:solidFill>
-              </a:rPr>
-              <a:t>08. </a:t>
-            </a:r>
-            <a:r>
-              <a:rPr sz="1200" b="1">
+              <a:t>• DOM Control via useRef: </a:t>
+            </a:r>
+            <a:r>
+              <a:rPr sz="1150">
+                <a:solidFill>
+                  <a:srgbClr val="CDD2DC"/>
+                </a:solidFill>
+              </a:rPr>
+              <a:t>Direct focus on comment inputs and auto-scroll control without synthetic re-renders.</a:t>
+            </a:r>
+          </a:p>
+          <a:p>
+            <a:pPr>
+              <a:spcAft>
+                <a:spcPts val="800"/>
+              </a:spcAft>
+            </a:pPr>
+            <a:r>
+              <a:rPr sz="1150" b="1">
                 <a:solidFill>
                   <a:srgbClr val="FFFFFF"/>
                 </a:solidFill>
               </a:rPr>
-              <a:t>Real YouTube Settings Panel (Theme, Autoplay, HD) (Page 10)</a:t>
-            </a:r>
-          </a:p>
-          <a:p>
-            <a:pPr>
-              <a:spcAft>
-                <a:spcPts val="1600"/>
-              </a:spcAft>
-            </a:pPr>
-            <a:r>
-              <a:rPr sz="1300" b="1">
-                <a:solidFill>
-                  <a:srgbClr val="3EA6FF"/>
-                </a:solidFill>
-              </a:rPr>
-              <a:t>09. </a:t>
-            </a:r>
-            <a:r>
-              <a:rPr sz="1200" b="1">
+              <a:t>• Global Context API: </a:t>
+            </a:r>
+            <a:r>
+              <a:rPr sz="1150">
+                <a:solidFill>
+                  <a:srgbClr val="CDD2DC"/>
+                </a:solidFill>
+              </a:rPr>
+              <a:t>Centralized multi-state bus eliminating prop drilling across nested component trees.</a:t>
+            </a:r>
+          </a:p>
+        </p:txBody>
+      </p:sp>
+      <p:sp>
+        <p:nvSpPr>
+          <p:cNvPr id="11" name="Rounded Rectangle 10"/>
+          <p:cNvSpPr/>
+          <p:nvPr/>
+        </p:nvSpPr>
+        <p:spPr>
+          <a:xfrm>
+            <a:off x="8076895" y="1325880"/>
+            <a:ext cx="3383280" cy="4663440"/>
+          </a:xfrm>
+          <a:prstGeom prst="roundRect">
+            <a:avLst/>
+          </a:prstGeom>
+          <a:solidFill>
+            <a:srgbClr val="161922"/>
+          </a:solidFill>
+          <a:ln w="16510">
+            <a:solidFill>
+              <a:srgbClr val="2E3445"/>
+            </a:solidFill>
+          </a:ln>
+        </p:spPr>
+        <p:style>
+          <a:lnRef idx="1">
+            <a:schemeClr val="accent1"/>
+          </a:lnRef>
+          <a:fillRef idx="3">
+            <a:schemeClr val="accent1"/>
+          </a:fillRef>
+          <a:effectRef idx="2">
+            <a:schemeClr val="accent1"/>
+          </a:effectRef>
+          <a:fontRef idx="minor">
+            <a:schemeClr val="lt1"/>
+          </a:fontRef>
+        </p:style>
+        <p:txBody>
+          <a:bodyPr rtlCol="0" anchor="ctr"/>
+          <a:lstStyle/>
+          <a:p>
+            <a:pPr algn="ctr"/>
+          </a:p>
+        </p:txBody>
+      </p:sp>
+      <p:sp>
+        <p:nvSpPr>
+          <p:cNvPr id="12" name="TextBox 11"/>
+          <p:cNvSpPr txBox="1"/>
+          <p:nvPr/>
+        </p:nvSpPr>
+        <p:spPr>
+          <a:xfrm>
+            <a:off x="8278063" y="1490472"/>
+            <a:ext cx="2980944" cy="4334255"/>
+          </a:xfrm>
+          <a:prstGeom prst="rect">
+            <a:avLst/>
+          </a:prstGeom>
+          <a:noFill/>
+        </p:spPr>
+        <p:txBody>
+          <a:bodyPr wrap="square" tIns="0" bIns="0" lIns="0" rIns="0">
+            <a:spAutoFit/>
+          </a:bodyPr>
+          <a:lstStyle/>
+          <a:p>
+            <a:pPr>
+              <a:spcAft>
+                <a:spcPts val="1000"/>
+              </a:spcAft>
+              <a:defRPr sz="1350" b="1">
+                <a:solidFill>
+                  <a:srgbClr val="2BA640"/>
+                </a:solidFill>
+              </a:defRPr>
+            </a:pPr>
+            <a:r>
+              <a:t>User Experience &amp; Realism</a:t>
+            </a:r>
+          </a:p>
+          <a:p>
+            <a:pPr>
+              <a:spcAft>
+                <a:spcPts val="800"/>
+              </a:spcAft>
+            </a:pPr>
+            <a:r>
+              <a:rPr sz="1150" b="1">
                 <a:solidFill>
                   <a:srgbClr val="FFFFFF"/>
                 </a:solidFill>
               </a:rPr>
-              <a:t>Multi-Device Responsive Design &amp; Modern UI/UX (Page 11)</a:t>
-            </a:r>
-          </a:p>
-          <a:p>
-            <a:pPr>
-              <a:spcAft>
-                <a:spcPts val="1600"/>
-              </a:spcAft>
-            </a:pPr>
-            <a:r>
-              <a:rPr sz="1300" b="1">
-                <a:solidFill>
-                  <a:srgbClr val="FF0033"/>
-                </a:solidFill>
-              </a:rPr>
-              <a:t>10. </a:t>
-            </a:r>
-            <a:r>
-              <a:rPr sz="1200" b="1">
+              <a:t>• Up-Next Queue: </a:t>
+            </a:r>
+            <a:r>
+              <a:rPr sz="1150">
+                <a:solidFill>
+                  <a:srgbClr val="CDD2DC"/>
+                </a:solidFill>
+              </a:rPr>
+              <a:t>Dynamic video swapping via useNavigate() with synchronized channel metadata.</a:t>
+            </a:r>
+          </a:p>
+          <a:p>
+            <a:pPr>
+              <a:spcAft>
+                <a:spcPts val="800"/>
+              </a:spcAft>
+            </a:pPr>
+            <a:r>
+              <a:rPr sz="1150" b="1">
                 <a:solidFill>
                   <a:srgbClr val="FFFFFF"/>
                 </a:solidFill>
               </a:rPr>
-              <a:t>Summary, Live Demonstration &amp; Viva Readiness (Page 12)</a:t>
+              <a:t>• Working Action Controls: </a:t>
+            </a:r>
+            <a:r>
+              <a:rPr sz="1150">
+                <a:solidFill>
+                  <a:srgbClr val="CDD2DC"/>
+                </a:solidFill>
+              </a:rPr>
+              <a:t>Real Like increments, Share link copier, and Watch Later bookmarking.</a:t>
+            </a:r>
+          </a:p>
+          <a:p>
+            <a:pPr>
+              <a:spcAft>
+                <a:spcPts val="800"/>
+              </a:spcAft>
+            </a:pPr>
+            <a:r>
+              <a:rPr sz="1150" b="1">
+                <a:solidFill>
+                  <a:srgbClr val="FFFFFF"/>
+                </a:solidFill>
+              </a:rPr>
+              <a:t>• Responsive Parity: </a:t>
+            </a:r>
+            <a:r>
+              <a:rPr sz="1150">
+                <a:solidFill>
+                  <a:srgbClr val="CDD2DC"/>
+                </a:solidFill>
+              </a:rPr>
+              <a:t>Fluid scaling across 375px mobile, 768px/1024px tablet, and 1440px desktop screens.</a:t>
             </a:r>
           </a:p>
         </p:txBody>
@@ -5950,7 +5523,7 @@
               </a:defRPr>
             </a:pPr>
             <a:r>
-              <a:t>Evaluation-II Vision &amp; Milestone Objectives</a:t>
+              <a:t>Syllabus-Aligned Technology Stack &amp; Architecture</a:t>
             </a:r>
           </a:p>
         </p:txBody>
@@ -5999,7 +5572,7 @@
         <p:spPr>
           <a:xfrm>
             <a:off x="731520" y="1325880"/>
-            <a:ext cx="3383280" cy="4663440"/>
+            <a:ext cx="3429000" cy="2240280"/>
           </a:xfrm>
           <a:prstGeom prst="roundRect">
             <a:avLst/>
@@ -6044,7 +5617,7 @@
         <p:spPr>
           <a:xfrm>
             <a:off x="932688" y="1490472"/>
-            <a:ext cx="2980944" cy="4334255"/>
+            <a:ext cx="3026664" cy="1911096"/>
           </a:xfrm>
           <a:prstGeom prst="rect">
             <a:avLst/>
@@ -6061,14 +5634,14 @@
               <a:spcAft>
                 <a:spcPts val="1000"/>
               </a:spcAft>
-              <a:defRPr sz="1350" b="1">
-                <a:solidFill>
-                  <a:srgbClr val="FF0033"/>
+              <a:defRPr sz="1250" b="1">
+                <a:solidFill>
+                  <a:srgbClr val="3EA6FF"/>
                 </a:solidFill>
               </a:defRPr>
             </a:pPr>
             <a:r>
-              <a:t>Phase 1 vs Phase 2 Focus</a:t>
+              <a:t>React 18 (Core SPA Engine)</a:t>
             </a:r>
           </a:p>
           <a:p>
@@ -6078,66 +5651,65 @@
               </a:spcAft>
             </a:pPr>
             <a:r>
-              <a:rPr sz="1150" b="1">
+              <a:rPr sz="1050">
+                <a:solidFill>
+                  <a:srgbClr val="CDD2DC"/>
+                </a:solidFill>
+              </a:rPr>
+              <a:t>• Declarative UI components.</a:t>
+            </a:r>
+          </a:p>
+          <a:p>
+            <a:pPr>
+              <a:spcAft>
+                <a:spcPts val="800"/>
+              </a:spcAft>
+            </a:pPr>
+            <a:r>
+              <a:rPr sz="1050">
+                <a:solidFill>
+                  <a:srgbClr val="CDD2DC"/>
+                </a:solidFill>
+              </a:rPr>
+              <a:t>• Virtual DOM fiber reconciliation.</a:t>
+            </a:r>
+          </a:p>
+          <a:p>
+            <a:pPr>
+              <a:spcAft>
+                <a:spcPts val="800"/>
+              </a:spcAft>
+            </a:pPr>
+            <a:r>
+              <a:rPr sz="1050">
+                <a:solidFill>
+                  <a:srgbClr val="CDD2DC"/>
+                </a:solidFill>
+              </a:rPr>
+              <a:t>• Concurrent state batching.</a:t>
+            </a:r>
+          </a:p>
+          <a:p>
+            <a:pPr>
+              <a:spcAft>
+                <a:spcPts val="800"/>
+              </a:spcAft>
+            </a:pPr>
+            <a:r>
+              <a:rPr sz="1050" b="1">
                 <a:solidFill>
                   <a:srgbClr val="FFFFFF"/>
                 </a:solidFill>
               </a:rPr>
-              <a:t>• Phase 1 Foundation: </a:t>
-            </a:r>
-            <a:r>
-              <a:rPr sz="1150">
+              <a:t>• Hooks: </a:t>
+            </a:r>
+            <a:r>
+              <a:rPr sz="1050">
                 <a:solidFill>
                   <a:srgbClr val="CDD2DC"/>
                 </a:solidFill>
               </a:rPr>
-              <a:t>Established responsive video card grids, category chips, and external links.</a:t>
-            </a:r>
-          </a:p>
-          <a:p>
-            <a:pPr>
-              <a:spcAft>
-                <a:spcPts val="800"/>
-              </a:spcAft>
-            </a:pPr>
-            <a:r>
-              <a:rPr sz="1150" b="1">
-                <a:solidFill>
-                  <a:srgbClr val="FFFFFF"/>
-                </a:solidFill>
-              </a:rPr>
-              <a:t>• Phase 2 Transition: </a:t>
-            </a:r>
-            <a:r>
-              <a:rPr sz="1150">
-                <a:solidFill>
-                  <a:srgbClr val="CDD2DC"/>
-                </a:solidFill>
-              </a:rPr>
-              <a:t>Elevated PheW TuBe into an authentic, stateful Single Page Application (SPA).</a:t>
-            </a:r>
-          </a:p>
-          <a:p>
-            <a:pPr>
-              <a:spcAft>
-                <a:spcPts val="800"/>
-              </a:spcAft>
-            </a:pPr>
-            <a:r>
-              <a:rPr sz="1150" b="1">
-                <a:solidFill>
-                  <a:srgbClr val="FFFFFF"/>
-                </a:solidFill>
-              </a:rPr>
-              <a:t>• Zero Page Reloads: </a:t>
-            </a:r>
-            <a:r>
-              <a:rPr sz="1150">
-                <a:solidFill>
-                  <a:srgbClr val="CDD2DC"/>
-                </a:solidFill>
-              </a:rPr>
-              <a:t>Client-side routing via React Router DOM ensures instant state reactivity without full flushes.</a:t>
+              <a:t>useState, useEffect, useRef.</a:t>
             </a:r>
           </a:p>
         </p:txBody>
@@ -6150,8 +5722,8 @@
         </p:nvSpPr>
         <p:spPr>
           <a:xfrm>
-            <a:off x="4403750" y="1325880"/>
-            <a:ext cx="3383280" cy="4663440"/>
+            <a:off x="4370832" y="1325880"/>
+            <a:ext cx="3429000" cy="2240280"/>
           </a:xfrm>
           <a:prstGeom prst="roundRect">
             <a:avLst/>
@@ -6195,8 +5767,8 @@
         </p:nvSpPr>
         <p:spPr>
           <a:xfrm>
-            <a:off x="4604918" y="1490472"/>
-            <a:ext cx="2980944" cy="4334255"/>
+            <a:off x="4572000" y="1490472"/>
+            <a:ext cx="3026664" cy="1911096"/>
           </a:xfrm>
           <a:prstGeom prst="rect">
             <a:avLst/>
@@ -6213,14 +5785,14 @@
               <a:spcAft>
                 <a:spcPts val="1000"/>
               </a:spcAft>
-              <a:defRPr sz="1350" b="1">
-                <a:solidFill>
-                  <a:srgbClr val="3EA6FF"/>
+              <a:defRPr sz="1250" b="1">
+                <a:solidFill>
+                  <a:srgbClr val="FF0033"/>
                 </a:solidFill>
               </a:defRPr>
             </a:pPr>
             <a:r>
-              <a:t>Core Technical Objectives</a:t>
+              <a:t>React Router v6</a:t>
             </a:r>
           </a:p>
           <a:p>
@@ -6230,20 +5802,12 @@
               </a:spcAft>
             </a:pPr>
             <a:r>
-              <a:rPr sz="1150" b="1">
-                <a:solidFill>
-                  <a:srgbClr val="FFFFFF"/>
-                </a:solidFill>
-              </a:rPr>
-              <a:t>• In-Site Streaming: </a:t>
-            </a:r>
-            <a:r>
-              <a:rPr sz="1150">
+              <a:rPr sz="1050">
                 <a:solidFill>
                   <a:srgbClr val="CDD2DC"/>
                 </a:solidFill>
               </a:rPr>
-              <a:t>Deep link /watch/:id powered by useParams() with embedded 16:9 streaming.</a:t>
+              <a:t>• Client-side routing engine.</a:t>
             </a:r>
           </a:p>
           <a:p>
@@ -6253,20 +5817,12 @@
               </a:spcAft>
             </a:pPr>
             <a:r>
-              <a:rPr sz="1150" b="1">
-                <a:solidFill>
-                  <a:srgbClr val="FFFFFF"/>
-                </a:solidFill>
-              </a:rPr>
-              <a:t>• DOM Control via useRef: </a:t>
-            </a:r>
-            <a:r>
-              <a:rPr sz="1150">
+              <a:rPr sz="1050">
                 <a:solidFill>
                   <a:srgbClr val="CDD2DC"/>
                 </a:solidFill>
               </a:rPr>
-              <a:t>Direct focus on comment inputs and auto-scroll control without synthetic re-renders.</a:t>
+              <a:t>• Dynamic URL parameters (/watch/:id).</a:t>
             </a:r>
           </a:p>
           <a:p>
@@ -6276,20 +5832,27 @@
               </a:spcAft>
             </a:pPr>
             <a:r>
-              <a:rPr sz="1150" b="1">
-                <a:solidFill>
-                  <a:srgbClr val="FFFFFF"/>
-                </a:solidFill>
-              </a:rPr>
-              <a:t>• Global Context API: </a:t>
-            </a:r>
-            <a:r>
-              <a:rPr sz="1150">
+              <a:rPr sz="1050">
                 <a:solidFill>
                   <a:srgbClr val="CDD2DC"/>
                 </a:solidFill>
               </a:rPr>
-              <a:t>Centralized multi-state bus eliminating prop drilling across nested component trees.</a:t>
+              <a:t>• Declarative &lt;ProtectedRoute /&gt; security.</a:t>
+            </a:r>
+          </a:p>
+          <a:p>
+            <a:pPr>
+              <a:spcAft>
+                <a:spcPts val="800"/>
+              </a:spcAft>
+            </a:pPr>
+            <a:r>
+              <a:rPr sz="1050">
+                <a:solidFill>
+                  <a:srgbClr val="CDD2DC"/>
+                </a:solidFill>
+              </a:rPr>
+              <a:t>• Seamless useNavigate() transitions.</a:t>
             </a:r>
           </a:p>
         </p:txBody>
@@ -6302,8 +5865,8 @@
         </p:nvSpPr>
         <p:spPr>
           <a:xfrm>
-            <a:off x="8076895" y="1325880"/>
-            <a:ext cx="3383280" cy="4663440"/>
+            <a:off x="8010144" y="1325880"/>
+            <a:ext cx="3429000" cy="2240280"/>
           </a:xfrm>
           <a:prstGeom prst="roundRect">
             <a:avLst/>
@@ -6347,8 +5910,8 @@
         </p:nvSpPr>
         <p:spPr>
           <a:xfrm>
-            <a:off x="8278063" y="1490472"/>
-            <a:ext cx="2980944" cy="4334255"/>
+            <a:off x="8211312" y="1490472"/>
+            <a:ext cx="3026664" cy="1911096"/>
           </a:xfrm>
           <a:prstGeom prst="rect">
             <a:avLst/>
@@ -6365,14 +5928,157 @@
               <a:spcAft>
                 <a:spcPts val="1000"/>
               </a:spcAft>
-              <a:defRPr sz="1350" b="1">
+              <a:defRPr sz="1250" b="1">
+                <a:solidFill>
+                  <a:srgbClr val="3EA6FF"/>
+                </a:solidFill>
+              </a:defRPr>
+            </a:pPr>
+            <a:r>
+              <a:t>Tailwind CSS 3</a:t>
+            </a:r>
+          </a:p>
+          <a:p>
+            <a:pPr>
+              <a:spcAft>
+                <a:spcPts val="800"/>
+              </a:spcAft>
+            </a:pPr>
+            <a:r>
+              <a:rPr sz="1050">
+                <a:solidFill>
+                  <a:srgbClr val="CDD2DC"/>
+                </a:solidFill>
+              </a:rPr>
+              <a:t>• Utility-first responsive framework.</a:t>
+            </a:r>
+          </a:p>
+          <a:p>
+            <a:pPr>
+              <a:spcAft>
+                <a:spcPts val="800"/>
+              </a:spcAft>
+            </a:pPr>
+            <a:r>
+              <a:rPr sz="1050">
+                <a:solidFill>
+                  <a:srgbClr val="CDD2DC"/>
+                </a:solidFill>
+              </a:rPr>
+              <a:t>• Dark/Light theme CSS variables.</a:t>
+            </a:r>
+          </a:p>
+          <a:p>
+            <a:pPr>
+              <a:spcAft>
+                <a:spcPts val="800"/>
+              </a:spcAft>
+            </a:pPr>
+            <a:r>
+              <a:rPr sz="1050">
+                <a:solidFill>
+                  <a:srgbClr val="CDD2DC"/>
+                </a:solidFill>
+              </a:rPr>
+              <a:t>• Custom micro-interactions &amp; pulse.</a:t>
+            </a:r>
+          </a:p>
+          <a:p>
+            <a:pPr>
+              <a:spcAft>
+                <a:spcPts val="800"/>
+              </a:spcAft>
+            </a:pPr>
+            <a:r>
+              <a:rPr sz="1050">
+                <a:solidFill>
+                  <a:srgbClr val="CDD2DC"/>
+                </a:solidFill>
+              </a:rPr>
+              <a:t>• Strict YouTube aesthetics alignment.</a:t>
+            </a:r>
+          </a:p>
+        </p:txBody>
+      </p:sp>
+      <p:sp>
+        <p:nvSpPr>
+          <p:cNvPr id="13" name="Rounded Rectangle 12"/>
+          <p:cNvSpPr/>
+          <p:nvPr/>
+        </p:nvSpPr>
+        <p:spPr>
+          <a:xfrm>
+            <a:off x="731520" y="3749039"/>
+            <a:ext cx="3429000" cy="2240280"/>
+          </a:xfrm>
+          <a:prstGeom prst="roundRect">
+            <a:avLst/>
+          </a:prstGeom>
+          <a:solidFill>
+            <a:srgbClr val="161922"/>
+          </a:solidFill>
+          <a:ln w="16510">
+            <a:solidFill>
+              <a:srgbClr val="2E3445"/>
+            </a:solidFill>
+          </a:ln>
+        </p:spPr>
+        <p:style>
+          <a:lnRef idx="1">
+            <a:schemeClr val="accent1"/>
+          </a:lnRef>
+          <a:fillRef idx="3">
+            <a:schemeClr val="accent1"/>
+          </a:fillRef>
+          <a:effectRef idx="2">
+            <a:schemeClr val="accent1"/>
+          </a:effectRef>
+          <a:fontRef idx="minor">
+            <a:schemeClr val="lt1"/>
+          </a:fontRef>
+        </p:style>
+        <p:txBody>
+          <a:bodyPr rtlCol="0" anchor="ctr"/>
+          <a:lstStyle/>
+          <a:p>
+            <a:pPr algn="ctr"/>
+          </a:p>
+        </p:txBody>
+      </p:sp>
+      <p:sp>
+        <p:nvSpPr>
+          <p:cNvPr id="14" name="TextBox 13"/>
+          <p:cNvSpPr txBox="1"/>
+          <p:nvPr/>
+        </p:nvSpPr>
+        <p:spPr>
+          <a:xfrm>
+            <a:off x="932688" y="3913631"/>
+            <a:ext cx="3026664" cy="1911096"/>
+          </a:xfrm>
+          <a:prstGeom prst="rect">
+            <a:avLst/>
+          </a:prstGeom>
+          <a:noFill/>
+        </p:spPr>
+        <p:txBody>
+          <a:bodyPr wrap="square" tIns="0" bIns="0" lIns="0" rIns="0">
+            <a:spAutoFit/>
+          </a:bodyPr>
+          <a:lstStyle/>
+          <a:p>
+            <a:pPr>
+              <a:spcAft>
+                <a:spcPts val="1000"/>
+              </a:spcAft>
+              <a:defRPr sz="1250" b="1">
                 <a:solidFill>
                   <a:srgbClr val="2BA640"/>
                 </a:solidFill>
               </a:defRPr>
             </a:pPr>
             <a:r>
-              <a:t>User Experience &amp; Realism</a:t>
+              <a:t>Context API &amp; LocalStorage</a:t>
             </a:r>
           </a:p>
           <a:p>
@@ -6382,20 +6088,12 @@
               </a:spcAft>
             </a:pPr>
             <a:r>
-              <a:rPr sz="1150" b="1">
-                <a:solidFill>
-                  <a:srgbClr val="FFFFFF"/>
-                </a:solidFill>
-              </a:rPr>
-              <a:t>• Up-Next Queue: </a:t>
-            </a:r>
-            <a:r>
-              <a:rPr sz="1150">
+              <a:rPr sz="1050">
                 <a:solidFill>
                   <a:srgbClr val="CDD2DC"/>
                 </a:solidFill>
               </a:rPr>
-              <a:t>Dynamic video swapping via useNavigate() with synchronized channel metadata.</a:t>
+              <a:t>• Centralized global AppContext bus.</a:t>
             </a:r>
           </a:p>
           <a:p>
@@ -6405,20 +6103,12 @@
               </a:spcAft>
             </a:pPr>
             <a:r>
-              <a:rPr sz="1150" b="1">
-                <a:solidFill>
-                  <a:srgbClr val="FFFFFF"/>
-                </a:solidFill>
-              </a:rPr>
-              <a:t>• Working Action Controls: </a:t>
-            </a:r>
-            <a:r>
-              <a:rPr sz="1150">
+              <a:rPr sz="1050">
                 <a:solidFill>
                   <a:srgbClr val="CDD2DC"/>
                 </a:solidFill>
               </a:rPr>
-              <a:t>Real Like increments, Share link copier, and Watch Later bookmarking.</a:t>
+              <a:t>• Syncs Likes, Playlists, &amp; Watch Later.</a:t>
             </a:r>
           </a:p>
           <a:p>
@@ -6428,20 +6118,313 @@
               </a:spcAft>
             </a:pPr>
             <a:r>
-              <a:rPr sz="1150" b="1">
-                <a:solidFill>
-                  <a:srgbClr val="FFFFFF"/>
-                </a:solidFill>
-              </a:rPr>
-              <a:t>• Responsive Parity: </a:t>
-            </a:r>
-            <a:r>
-              <a:rPr sz="1150">
+              <a:rPr sz="1050">
                 <a:solidFill>
                   <a:srgbClr val="CDD2DC"/>
                 </a:solidFill>
               </a:rPr>
-              <a:t>Fluid scaling across 375px mobile, 768px/1024px tablet, and 1440px desktop screens.</a:t>
+              <a:t>• Persistent auth token storage.</a:t>
+            </a:r>
+          </a:p>
+          <a:p>
+            <a:pPr>
+              <a:spcAft>
+                <a:spcPts val="800"/>
+              </a:spcAft>
+            </a:pPr>
+            <a:r>
+              <a:rPr sz="1050">
+                <a:solidFill>
+                  <a:srgbClr val="CDD2DC"/>
+                </a:solidFill>
+              </a:rPr>
+              <a:t>• Optimistic UI state updates.</a:t>
+            </a:r>
+          </a:p>
+        </p:txBody>
+      </p:sp>
+      <p:sp>
+        <p:nvSpPr>
+          <p:cNvPr id="15" name="Rounded Rectangle 14"/>
+          <p:cNvSpPr/>
+          <p:nvPr/>
+        </p:nvSpPr>
+        <p:spPr>
+          <a:xfrm>
+            <a:off x="4370832" y="3749039"/>
+            <a:ext cx="3429000" cy="2240280"/>
+          </a:xfrm>
+          <a:prstGeom prst="roundRect">
+            <a:avLst/>
+          </a:prstGeom>
+          <a:solidFill>
+            <a:srgbClr val="161922"/>
+          </a:solidFill>
+          <a:ln w="16510">
+            <a:solidFill>
+              <a:srgbClr val="2E3445"/>
+            </a:solidFill>
+          </a:ln>
+        </p:spPr>
+        <p:style>
+          <a:lnRef idx="1">
+            <a:schemeClr val="accent1"/>
+          </a:lnRef>
+          <a:fillRef idx="3">
+            <a:schemeClr val="accent1"/>
+          </a:fillRef>
+          <a:effectRef idx="2">
+            <a:schemeClr val="accent1"/>
+          </a:effectRef>
+          <a:fontRef idx="minor">
+            <a:schemeClr val="lt1"/>
+          </a:fontRef>
+        </p:style>
+        <p:txBody>
+          <a:bodyPr rtlCol="0" anchor="ctr"/>
+          <a:lstStyle/>
+          <a:p>
+            <a:pPr algn="ctr"/>
+          </a:p>
+        </p:txBody>
+      </p:sp>
+      <p:sp>
+        <p:nvSpPr>
+          <p:cNvPr id="16" name="TextBox 15"/>
+          <p:cNvSpPr txBox="1"/>
+          <p:nvPr/>
+        </p:nvSpPr>
+        <p:spPr>
+          <a:xfrm>
+            <a:off x="4572000" y="3913631"/>
+            <a:ext cx="3026664" cy="1911096"/>
+          </a:xfrm>
+          <a:prstGeom prst="rect">
+            <a:avLst/>
+          </a:prstGeom>
+          <a:noFill/>
+        </p:spPr>
+        <p:txBody>
+          <a:bodyPr wrap="square" tIns="0" bIns="0" lIns="0" rIns="0">
+            <a:spAutoFit/>
+          </a:bodyPr>
+          <a:lstStyle/>
+          <a:p>
+            <a:pPr>
+              <a:spcAft>
+                <a:spcPts val="1000"/>
+              </a:spcAft>
+              <a:defRPr sz="1250" b="1">
+                <a:solidFill>
+                  <a:srgbClr val="A855F7"/>
+                </a:solidFill>
+              </a:defRPr>
+            </a:pPr>
+            <a:r>
+              <a:t>YouTube Data API v3</a:t>
+            </a:r>
+          </a:p>
+          <a:p>
+            <a:pPr>
+              <a:spcAft>
+                <a:spcPts val="800"/>
+              </a:spcAft>
+            </a:pPr>
+            <a:r>
+              <a:rPr sz="1050">
+                <a:solidFill>
+                  <a:srgbClr val="CDD2DC"/>
+                </a:solidFill>
+              </a:rPr>
+              <a:t>• RESTful Google Cloud API integration.</a:t>
+            </a:r>
+          </a:p>
+          <a:p>
+            <a:pPr>
+              <a:spcAft>
+                <a:spcPts val="800"/>
+              </a:spcAft>
+            </a:pPr>
+            <a:r>
+              <a:rPr sz="1050">
+                <a:solidFill>
+                  <a:srgbClr val="CDD2DC"/>
+                </a:solidFill>
+              </a:rPr>
+              <a:t>• Dynamic live search &amp; channel fetch.</a:t>
+            </a:r>
+          </a:p>
+          <a:p>
+            <a:pPr>
+              <a:spcAft>
+                <a:spcPts val="800"/>
+              </a:spcAft>
+            </a:pPr>
+            <a:r>
+              <a:rPr sz="1050">
+                <a:solidFill>
+                  <a:srgbClr val="CDD2DC"/>
+                </a:solidFill>
+              </a:rPr>
+              <a:t>• Resilient offline mock fallback.</a:t>
+            </a:r>
+          </a:p>
+          <a:p>
+            <a:pPr>
+              <a:spcAft>
+                <a:spcPts val="800"/>
+              </a:spcAft>
+            </a:pPr>
+            <a:r>
+              <a:rPr sz="1050">
+                <a:solidFill>
+                  <a:srgbClr val="CDD2DC"/>
+                </a:solidFill>
+              </a:rPr>
+              <a:t>• In-app toggle for custom API keys.</a:t>
+            </a:r>
+          </a:p>
+        </p:txBody>
+      </p:sp>
+      <p:sp>
+        <p:nvSpPr>
+          <p:cNvPr id="17" name="Rounded Rectangle 16"/>
+          <p:cNvSpPr/>
+          <p:nvPr/>
+        </p:nvSpPr>
+        <p:spPr>
+          <a:xfrm>
+            <a:off x="8010144" y="3749039"/>
+            <a:ext cx="3429000" cy="2240280"/>
+          </a:xfrm>
+          <a:prstGeom prst="roundRect">
+            <a:avLst/>
+          </a:prstGeom>
+          <a:solidFill>
+            <a:srgbClr val="161922"/>
+          </a:solidFill>
+          <a:ln w="16510">
+            <a:solidFill>
+              <a:srgbClr val="2E3445"/>
+            </a:solidFill>
+          </a:ln>
+        </p:spPr>
+        <p:style>
+          <a:lnRef idx="1">
+            <a:schemeClr val="accent1"/>
+          </a:lnRef>
+          <a:fillRef idx="3">
+            <a:schemeClr val="accent1"/>
+          </a:fillRef>
+          <a:effectRef idx="2">
+            <a:schemeClr val="accent1"/>
+          </a:effectRef>
+          <a:fontRef idx="minor">
+            <a:schemeClr val="lt1"/>
+          </a:fontRef>
+        </p:style>
+        <p:txBody>
+          <a:bodyPr rtlCol="0" anchor="ctr"/>
+          <a:lstStyle/>
+          <a:p>
+            <a:pPr algn="ctr"/>
+          </a:p>
+        </p:txBody>
+      </p:sp>
+      <p:sp>
+        <p:nvSpPr>
+          <p:cNvPr id="18" name="TextBox 17"/>
+          <p:cNvSpPr txBox="1"/>
+          <p:nvPr/>
+        </p:nvSpPr>
+        <p:spPr>
+          <a:xfrm>
+            <a:off x="8211312" y="3913631"/>
+            <a:ext cx="3026664" cy="1911096"/>
+          </a:xfrm>
+          <a:prstGeom prst="rect">
+            <a:avLst/>
+          </a:prstGeom>
+          <a:noFill/>
+        </p:spPr>
+        <p:txBody>
+          <a:bodyPr wrap="square" tIns="0" bIns="0" lIns="0" rIns="0">
+            <a:spAutoFit/>
+          </a:bodyPr>
+          <a:lstStyle/>
+          <a:p>
+            <a:pPr>
+              <a:spcAft>
+                <a:spcPts val="1000"/>
+              </a:spcAft>
+              <a:defRPr sz="1250" b="1">
+                <a:solidFill>
+                  <a:srgbClr val="3EA6FF"/>
+                </a:solidFill>
+              </a:defRPr>
+            </a:pPr>
+            <a:r>
+              <a:t>Vite 5 (Build Tool)</a:t>
+            </a:r>
+          </a:p>
+          <a:p>
+            <a:pPr>
+              <a:spcAft>
+                <a:spcPts val="800"/>
+              </a:spcAft>
+            </a:pPr>
+            <a:r>
+              <a:rPr sz="1050">
+                <a:solidFill>
+                  <a:srgbClr val="CDD2DC"/>
+                </a:solidFill>
+              </a:rPr>
+              <a:t>• Lightning-fast Hot Module Replacement.</a:t>
+            </a:r>
+          </a:p>
+          <a:p>
+            <a:pPr>
+              <a:spcAft>
+                <a:spcPts val="800"/>
+              </a:spcAft>
+            </a:pPr>
+            <a:r>
+              <a:rPr sz="1050">
+                <a:solidFill>
+                  <a:srgbClr val="CDD2DC"/>
+                </a:solidFill>
+              </a:rPr>
+              <a:t>• Native ES Module development server.</a:t>
+            </a:r>
+          </a:p>
+          <a:p>
+            <a:pPr>
+              <a:spcAft>
+                <a:spcPts val="800"/>
+              </a:spcAft>
+            </a:pPr>
+            <a:r>
+              <a:rPr sz="1050">
+                <a:solidFill>
+                  <a:srgbClr val="CDD2DC"/>
+                </a:solidFill>
+              </a:rPr>
+              <a:t>• Sub-1.2s production Rollup bundling.</a:t>
+            </a:r>
+          </a:p>
+          <a:p>
+            <a:pPr>
+              <a:spcAft>
+                <a:spcPts val="800"/>
+              </a:spcAft>
+            </a:pPr>
+            <a:r>
+              <a:rPr sz="1050">
+                <a:solidFill>
+                  <a:srgbClr val="CDD2DC"/>
+                </a:solidFill>
+              </a:rPr>
+              <a:t>• Zero-config optimized asset pipeline.</a:t>
             </a:r>
           </a:p>
         </p:txBody>
@@ -6618,7 +6601,7 @@
               </a:defRPr>
             </a:pPr>
             <a:r>
-              <a:t>Syllabus-Aligned Technology Stack &amp; Architecture</a:t>
+              <a:t>Core Component Architecture &amp; Modularity</a:t>
             </a:r>
           </a:p>
         </p:txBody>
@@ -6731,12 +6714,12 @@
               </a:spcAft>
               <a:defRPr sz="1250" b="1">
                 <a:solidFill>
-                  <a:srgbClr val="3EA6FF"/>
+                  <a:srgbClr val="FF0033"/>
                 </a:solidFill>
               </a:defRPr>
             </a:pPr>
             <a:r>
-              <a:t>React 18 (Core SPA Engine)</a:t>
+              <a:t>Navbar.jsx</a:t>
             </a:r>
           </a:p>
           <a:p>
@@ -6751,7 +6734,7 @@
                   <a:srgbClr val="CDD2DC"/>
                 </a:solidFill>
               </a:rPr>
-              <a:t>• Declarative UI components.</a:t>
+              <a:t>• Search bar with live autocomplete.</a:t>
             </a:r>
           </a:p>
           <a:p>
@@ -6766,7 +6749,7 @@
                   <a:srgbClr val="CDD2DC"/>
                 </a:solidFill>
               </a:rPr>
-              <a:t>• Virtual DOM fiber reconciliation.</a:t>
+              <a:t>• Native Web Speech API mic pulse.</a:t>
             </a:r>
           </a:p>
           <a:p>
@@ -6781,7 +6764,7 @@
                   <a:srgbClr val="CDD2DC"/>
                 </a:solidFill>
               </a:rPr>
-              <a:t>• Concurrent state batching.</a:t>
+              <a:t>• Theme switcher &amp; User avatar menu.</a:t>
             </a:r>
           </a:p>
           <a:p>
@@ -6791,20 +6774,12 @@
               </a:spcAft>
             </a:pPr>
             <a:r>
-              <a:rPr sz="1050" b="1">
-                <a:solidFill>
-                  <a:srgbClr val="FFFFFF"/>
-                </a:solidFill>
-              </a:rPr>
-              <a:t>• Hooks: </a:t>
-            </a:r>
-            <a:r>
               <a:rPr sz="1050">
                 <a:solidFill>
                   <a:srgbClr val="CDD2DC"/>
                 </a:solidFill>
               </a:rPr>
-              <a:t>useState, useEffect, useRef.</a:t>
+              <a:t>• Collapsible hamburger drawer toggle.</a:t>
             </a:r>
           </a:p>
         </p:txBody>
@@ -6882,12 +6857,12 @@
               </a:spcAft>
               <a:defRPr sz="1250" b="1">
                 <a:solidFill>
-                  <a:srgbClr val="FF0033"/>
+                  <a:srgbClr val="3EA6FF"/>
                 </a:solidFill>
               </a:defRPr>
             </a:pPr>
             <a:r>
-              <a:t>React Router v6</a:t>
+              <a:t>Sidebar.jsx</a:t>
             </a:r>
           </a:p>
           <a:p>
@@ -6897,12 +6872,20 @@
               </a:spcAft>
             </a:pPr>
             <a:r>
+              <a:rPr sz="1050" b="1">
+                <a:solidFill>
+                  <a:srgbClr val="FFFFFF"/>
+                </a:solidFill>
+              </a:rPr>
+              <a:t>• Main routes: </a:t>
+            </a:r>
+            <a:r>
               <a:rPr sz="1050">
                 <a:solidFill>
                   <a:srgbClr val="CDD2DC"/>
                 </a:solidFill>
               </a:rPr>
-              <a:t>• Client-side routing engine.</a:t>
+              <a:t>Home, Shorts, Subscriptions.</a:t>
             </a:r>
           </a:p>
           <a:p>
@@ -6912,12 +6895,20 @@
               </a:spcAft>
             </a:pPr>
             <a:r>
+              <a:rPr sz="1050" b="1">
+                <a:solidFill>
+                  <a:srgbClr val="FFFFFF"/>
+                </a:solidFill>
+              </a:rPr>
+              <a:t>• Protected: </a:t>
+            </a:r>
+            <a:r>
               <a:rPr sz="1050">
                 <a:solidFill>
                   <a:srgbClr val="CDD2DC"/>
                 </a:solidFill>
               </a:rPr>
-              <a:t>• Dynamic URL parameters (/watch/:id).</a:t>
+              <a:t>History, Playlists, Liked.</a:t>
             </a:r>
           </a:p>
           <a:p>
@@ -6932,7 +6923,7 @@
                   <a:srgbClr val="CDD2DC"/>
                 </a:solidFill>
               </a:rPr>
-              <a:t>• Declarative &lt;ProtectedRoute /&gt; security.</a:t>
+              <a:t>• Subscribed channels live indicators.</a:t>
             </a:r>
           </a:p>
           <a:p>
@@ -6947,7 +6938,7 @@
                   <a:srgbClr val="CDD2DC"/>
                 </a:solidFill>
               </a:rPr>
-              <a:t>• Seamless useNavigate() transitions.</a:t>
+              <a:t>• Responsive collapsed mini-rail mode.</a:t>
             </a:r>
           </a:p>
         </p:txBody>
@@ -7025,12 +7016,12 @@
               </a:spcAft>
               <a:defRPr sz="1250" b="1">
                 <a:solidFill>
-                  <a:srgbClr val="3EA6FF"/>
+                  <a:srgbClr val="2BA640"/>
                 </a:solidFill>
               </a:defRPr>
             </a:pPr>
             <a:r>
-              <a:t>Tailwind CSS 3</a:t>
+              <a:t>VideoCard.jsx</a:t>
             </a:r>
           </a:p>
           <a:p>
@@ -7045,7 +7036,7 @@
                   <a:srgbClr val="CDD2DC"/>
                 </a:solidFill>
               </a:rPr>
-              <a:t>• Utility-first responsive framework.</a:t>
+              <a:t>• 16:9 thumbnail with timestamp badge.</a:t>
             </a:r>
           </a:p>
           <a:p>
@@ -7060,7 +7051,7 @@
                   <a:srgbClr val="CDD2DC"/>
                 </a:solidFill>
               </a:rPr>
-              <a:t>• Dark/Light theme CSS variables.</a:t>
+              <a:t>• Channel avatar &amp; verified checkmark.</a:t>
             </a:r>
           </a:p>
           <a:p>
@@ -7075,7 +7066,7 @@
                   <a:srgbClr val="CDD2DC"/>
                 </a:solidFill>
               </a:rPr>
-              <a:t>• Custom micro-interactions &amp; pulse.</a:t>
+              <a:t>• Hover scale micro-interactions.</a:t>
             </a:r>
           </a:p>
           <a:p>
@@ -7090,7 +7081,7 @@
                   <a:srgbClr val="CDD2DC"/>
                 </a:solidFill>
               </a:rPr>
-              <a:t>• Strict YouTube aesthetics alignment.</a:t>
+              <a:t>• Integrated infinite scroll pagination.</a:t>
             </a:r>
           </a:p>
         </p:txBody>
@@ -7168,12 +7159,12 @@
               </a:spcAft>
               <a:defRPr sz="1250" b="1">
                 <a:solidFill>
-                  <a:srgbClr val="2BA640"/>
+                  <a:srgbClr val="A855F7"/>
                 </a:solidFill>
               </a:defRPr>
             </a:pPr>
             <a:r>
-              <a:t>Context API &amp; LocalStorage</a:t>
+              <a:t>WatchPage.jsx</a:t>
             </a:r>
           </a:p>
           <a:p>
@@ -7188,7 +7179,7 @@
                   <a:srgbClr val="CDD2DC"/>
                 </a:solidFill>
               </a:rPr>
-              <a:t>• Centralized global AppContext bus.</a:t>
+              <a:t>• 100% In-Site Video Player (No Redirects).</a:t>
             </a:r>
           </a:p>
           <a:p>
@@ -7198,12 +7189,20 @@
               </a:spcAft>
             </a:pPr>
             <a:r>
+              <a:rPr sz="1050" b="1">
+                <a:solidFill>
+                  <a:srgbClr val="FFFFFF"/>
+                </a:solidFill>
+              </a:rPr>
+              <a:t>• Action controls: </a:t>
+            </a:r>
+            <a:r>
               <a:rPr sz="1050">
                 <a:solidFill>
                   <a:srgbClr val="CDD2DC"/>
                 </a:solidFill>
               </a:rPr>
-              <a:t>• Syncs Likes, Playlists, &amp; Watch Later.</a:t>
+              <a:t>Like, Share, Save.</a:t>
             </a:r>
           </a:p>
           <a:p>
@@ -7218,7 +7217,7 @@
                   <a:srgbClr val="CDD2DC"/>
                 </a:solidFill>
               </a:rPr>
-              <a:t>• Persistent auth token storage.</a:t>
+              <a:t>• Dynamic Subscribe button &amp; counter.</a:t>
             </a:r>
           </a:p>
           <a:p>
@@ -7233,7 +7232,7 @@
                   <a:srgbClr val="CDD2DC"/>
                 </a:solidFill>
               </a:rPr>
-              <a:t>• Optimistic UI state updates.</a:t>
+              <a:t>• Real-time useRef comment thread.</a:t>
             </a:r>
           </a:p>
         </p:txBody>
@@ -7311,12 +7310,12 @@
               </a:spcAft>
               <a:defRPr sz="1250" b="1">
                 <a:solidFill>
-                  <a:srgbClr val="A855F7"/>
+                  <a:srgbClr val="FF0033"/>
                 </a:solidFill>
               </a:defRPr>
             </a:pPr>
             <a:r>
-              <a:t>YouTube Data API v3</a:t>
+              <a:t>AuthModal.jsx</a:t>
             </a:r>
           </a:p>
           <a:p>
@@ -7331,7 +7330,7 @@
                   <a:srgbClr val="CDD2DC"/>
                 </a:solidFill>
               </a:rPr>
-              <a:t>• RESTful Google Cloud API integration.</a:t>
+              <a:t>• Tabbed interface (Sign In &amp; Sign Up).</a:t>
             </a:r>
           </a:p>
           <a:p>
@@ -7346,7 +7345,7 @@
                   <a:srgbClr val="CDD2DC"/>
                 </a:solidFill>
               </a:rPr>
-              <a:t>• Dynamic live search &amp; channel fetch.</a:t>
+              <a:t>• Client-side credentials validation.</a:t>
             </a:r>
           </a:p>
           <a:p>
@@ -7361,7 +7360,7 @@
                   <a:srgbClr val="CDD2DC"/>
                 </a:solidFill>
               </a:rPr>
-              <a:t>• Resilient offline mock fallback.</a:t>
+              <a:t>• Automatic guest login on registration.</a:t>
             </a:r>
           </a:p>
           <a:p>
@@ -7376,7 +7375,7 @@
                   <a:srgbClr val="CDD2DC"/>
                 </a:solidFill>
               </a:rPr>
-              <a:t>• In-app toggle for custom API keys.</a:t>
+              <a:t>• Session persistence via LocalStorage.</a:t>
             </a:r>
           </a:p>
         </p:txBody>
@@ -7459,7 +7458,7 @@
               </a:defRPr>
             </a:pPr>
             <a:r>
-              <a:t>Vite 5 (Build Tool)</a:t>
+              <a:t>SettingsModal.jsx</a:t>
             </a:r>
           </a:p>
           <a:p>
@@ -7474,7 +7473,7 @@
                   <a:srgbClr val="CDD2DC"/>
                 </a:solidFill>
               </a:rPr>
-              <a:t>• Lightning-fast Hot Module Replacement.</a:t>
+              <a:t>• Genuine YouTube settings interface.</a:t>
             </a:r>
           </a:p>
           <a:p>
@@ -7489,7 +7488,7 @@
                   <a:srgbClr val="CDD2DC"/>
                 </a:solidFill>
               </a:rPr>
-              <a:t>• Native ES Module development server.</a:t>
+              <a:t>• Display Theme (Dark/Light Mode).</a:t>
             </a:r>
           </a:p>
           <a:p>
@@ -7504,7 +7503,7 @@
                   <a:srgbClr val="CDD2DC"/>
                 </a:solidFill>
               </a:rPr>
-              <a:t>• Sub-1.2s production Rollup bundling.</a:t>
+              <a:t>• Autoplay &amp; HD 1080p stream toggles.</a:t>
             </a:r>
           </a:p>
           <a:p>
@@ -7519,7 +7518,7 @@
                   <a:srgbClr val="CDD2DC"/>
                 </a:solidFill>
               </a:rPr>
-              <a:t>• Zero-config optimized asset pipeline.</a:t>
+              <a:t>• YouTube Data API v3 live key manager.</a:t>
             </a:r>
           </a:p>
         </p:txBody>
@@ -7696,7 +7695,7 @@
               </a:defRPr>
             </a:pPr>
             <a:r>
-              <a:t>Core Component Architecture &amp; Modularity</a:t>
+              <a:t>In-Site Video Streaming Engine (/watch/:id) — No Redirecting</a:t>
             </a:r>
           </a:p>
         </p:txBody>
@@ -7745,7 +7744,7 @@
         <p:spPr>
           <a:xfrm>
             <a:off x="731520" y="1325880"/>
-            <a:ext cx="3429000" cy="2240280"/>
+            <a:ext cx="5303520" cy="4663440"/>
           </a:xfrm>
           <a:prstGeom prst="roundRect">
             <a:avLst/>
@@ -7781,104 +7780,30 @@
           </a:p>
         </p:txBody>
       </p:sp>
-      <p:sp>
-        <p:nvSpPr>
-          <p:cNvPr id="8" name="TextBox 7"/>
-          <p:cNvSpPr txBox="1"/>
-          <p:nvPr/>
-        </p:nvSpPr>
-        <p:spPr>
-          <a:xfrm>
-            <a:off x="932688" y="1490472"/>
-            <a:ext cx="3026664" cy="1911096"/>
+      <p:pic>
+        <p:nvPicPr>
+          <p:cNvPr id="8" name="Picture 7" descr="feat_watch_player.png"/>
+          <p:cNvPicPr>
+            <a:picLocks noChangeAspect="1"/>
+          </p:cNvPicPr>
+          <p:nvPr/>
+        </p:nvPicPr>
+        <p:blipFill>
+          <a:blip r:embed="rId2"/>
+          <a:stretch>
+            <a:fillRect/>
+          </a:stretch>
+        </p:blipFill>
+        <p:spPr>
+          <a:xfrm>
+            <a:off x="868680" y="1508760"/>
+            <a:ext cx="5029200" cy="3143250"/>
           </a:xfrm>
           <a:prstGeom prst="rect">
             <a:avLst/>
           </a:prstGeom>
-          <a:noFill/>
-        </p:spPr>
-        <p:txBody>
-          <a:bodyPr wrap="square" tIns="0" bIns="0" lIns="0" rIns="0">
-            <a:spAutoFit/>
-          </a:bodyPr>
-          <a:lstStyle/>
-          <a:p>
-            <a:pPr>
-              <a:spcAft>
-                <a:spcPts val="1000"/>
-              </a:spcAft>
-              <a:defRPr sz="1250" b="1">
-                <a:solidFill>
-                  <a:srgbClr val="FF0033"/>
-                </a:solidFill>
-              </a:defRPr>
-            </a:pPr>
-            <a:r>
-              <a:t>Navbar.jsx</a:t>
-            </a:r>
-          </a:p>
-          <a:p>
-            <a:pPr>
-              <a:spcAft>
-                <a:spcPts val="800"/>
-              </a:spcAft>
-            </a:pPr>
-            <a:r>
-              <a:rPr sz="1050">
-                <a:solidFill>
-                  <a:srgbClr val="CDD2DC"/>
-                </a:solidFill>
-              </a:rPr>
-              <a:t>• Search bar with live autocomplete.</a:t>
-            </a:r>
-          </a:p>
-          <a:p>
-            <a:pPr>
-              <a:spcAft>
-                <a:spcPts val="800"/>
-              </a:spcAft>
-            </a:pPr>
-            <a:r>
-              <a:rPr sz="1050">
-                <a:solidFill>
-                  <a:srgbClr val="CDD2DC"/>
-                </a:solidFill>
-              </a:rPr>
-              <a:t>• Native Web Speech API mic pulse.</a:t>
-            </a:r>
-          </a:p>
-          <a:p>
-            <a:pPr>
-              <a:spcAft>
-                <a:spcPts val="800"/>
-              </a:spcAft>
-            </a:pPr>
-            <a:r>
-              <a:rPr sz="1050">
-                <a:solidFill>
-                  <a:srgbClr val="CDD2DC"/>
-                </a:solidFill>
-              </a:rPr>
-              <a:t>• Theme switcher &amp; User avatar menu.</a:t>
-            </a:r>
-          </a:p>
-          <a:p>
-            <a:pPr>
-              <a:spcAft>
-                <a:spcPts val="800"/>
-              </a:spcAft>
-            </a:pPr>
-            <a:r>
-              <a:rPr sz="1050">
-                <a:solidFill>
-                  <a:srgbClr val="CDD2DC"/>
-                </a:solidFill>
-              </a:rPr>
-              <a:t>• Collapsible hamburger drawer toggle.</a:t>
-            </a:r>
-          </a:p>
-        </p:txBody>
-      </p:sp>
+        </p:spPr>
+      </p:pic>
       <p:sp>
         <p:nvSpPr>
           <p:cNvPr id="9" name="Rounded Rectangle 8"/>
@@ -7887,8 +7812,8 @@
         </p:nvSpPr>
         <p:spPr>
           <a:xfrm>
-            <a:off x="4370832" y="1325880"/>
-            <a:ext cx="3429000" cy="2240280"/>
+            <a:off x="6248095" y="1325880"/>
+            <a:ext cx="5212080" cy="4663440"/>
           </a:xfrm>
           <a:prstGeom prst="roundRect">
             <a:avLst/>
@@ -7932,8 +7857,8 @@
         </p:nvSpPr>
         <p:spPr>
           <a:xfrm>
-            <a:off x="4572000" y="1490472"/>
-            <a:ext cx="3026664" cy="1911096"/>
+            <a:off x="6449263" y="1490472"/>
+            <a:ext cx="4809744" cy="4334255"/>
           </a:xfrm>
           <a:prstGeom prst="rect">
             <a:avLst/>
@@ -7950,14 +7875,14 @@
               <a:spcAft>
                 <a:spcPts val="1000"/>
               </a:spcAft>
-              <a:defRPr sz="1250" b="1">
-                <a:solidFill>
-                  <a:srgbClr val="3EA6FF"/>
+              <a:defRPr sz="1300" b="1">
+                <a:solidFill>
+                  <a:srgbClr val="FF0033"/>
                 </a:solidFill>
               </a:defRPr>
             </a:pPr>
             <a:r>
-              <a:t>Sidebar.jsx</a:t>
+              <a:t>In-Site Streaming &amp; Action Controls</a:t>
             </a:r>
           </a:p>
           <a:p>
@@ -7967,20 +7892,20 @@
               </a:spcAft>
             </a:pPr>
             <a:r>
-              <a:rPr sz="1050" b="1">
+              <a:rPr sz="1100" b="1">
                 <a:solidFill>
                   <a:srgbClr val="FFFFFF"/>
                 </a:solidFill>
               </a:rPr>
-              <a:t>• Main routes: </a:t>
-            </a:r>
-            <a:r>
-              <a:rPr sz="1050">
+              <a:t>• 100% In-Site Video Playback: </a:t>
+            </a:r>
+            <a:r>
+              <a:rPr sz="1100">
                 <a:solidFill>
                   <a:srgbClr val="CDD2DC"/>
                 </a:solidFill>
               </a:rPr>
-              <a:t>Home, Shorts, Subscriptions.</a:t>
+              <a:t>Media streams directly inside PheW TuBe on the /watch/:id route with zero external redirects to YouTube.</a:t>
             </a:r>
           </a:p>
           <a:p>
@@ -7990,20 +7915,20 @@
               </a:spcAft>
             </a:pPr>
             <a:r>
-              <a:rPr sz="1050" b="1">
+              <a:rPr sz="1100" b="1">
                 <a:solidFill>
                   <a:srgbClr val="FFFFFF"/>
                 </a:solidFill>
               </a:rPr>
-              <a:t>• Protected: </a:t>
-            </a:r>
-            <a:r>
-              <a:rPr sz="1050">
+              <a:t>• Working Interactive Controls: </a:t>
+            </a:r>
+            <a:r>
+              <a:rPr sz="1100">
                 <a:solidFill>
                   <a:srgbClr val="CDD2DC"/>
                 </a:solidFill>
               </a:rPr>
-              <a:t>History, Playlists, Liked.</a:t>
+              <a:t>Functional Like counter with active state highlighting, Share link copier, and Watch Later bookmarking.</a:t>
             </a:r>
           </a:p>
           <a:p>
@@ -8013,12 +7938,20 @@
               </a:spcAft>
             </a:pPr>
             <a:r>
-              <a:rPr sz="1050">
+              <a:rPr sz="1100" b="1">
+                <a:solidFill>
+                  <a:srgbClr val="FFFFFF"/>
+                </a:solidFill>
+              </a:rPr>
+              <a:t>• Channel Subscription Engine: </a:t>
+            </a:r>
+            <a:r>
+              <a:rPr sz="1100">
                 <a:solidFill>
                   <a:srgbClr val="CDD2DC"/>
                 </a:solidFill>
               </a:rPr>
-              <a:t>• Subscribed channels live indicators.</a:t>
+              <a:t>One-click Subscribe / Unsubscribe toggle dynamically synchronizing channel subscriber counts.</a:t>
             </a:r>
           </a:p>
           <a:p>
@@ -8028,95 +7961,20 @@
               </a:spcAft>
             </a:pPr>
             <a:r>
-              <a:rPr sz="1050">
+              <a:rPr sz="1100" b="1">
+                <a:solidFill>
+                  <a:srgbClr val="FFFFFF"/>
+                </a:solidFill>
+              </a:rPr>
+              <a:t>• Up-Next Recommendation Sidebar: </a:t>
+            </a:r>
+            <a:r>
+              <a:rPr sz="1100">
                 <a:solidFill>
                   <a:srgbClr val="CDD2DC"/>
                 </a:solidFill>
               </a:rPr>
-              <a:t>• Responsive collapsed mini-rail mode.</a:t>
-            </a:r>
-          </a:p>
-        </p:txBody>
-      </p:sp>
-      <p:sp>
-        <p:nvSpPr>
-          <p:cNvPr id="11" name="Rounded Rectangle 10"/>
-          <p:cNvSpPr/>
-          <p:nvPr/>
-        </p:nvSpPr>
-        <p:spPr>
-          <a:xfrm>
-            <a:off x="8010144" y="1325880"/>
-            <a:ext cx="3429000" cy="2240280"/>
-          </a:xfrm>
-          <a:prstGeom prst="roundRect">
-            <a:avLst/>
-          </a:prstGeom>
-          <a:solidFill>
-            <a:srgbClr val="161922"/>
-          </a:solidFill>
-          <a:ln w="16510">
-            <a:solidFill>
-              <a:srgbClr val="2E3445"/>
-            </a:solidFill>
-          </a:ln>
-        </p:spPr>
-        <p:style>
-          <a:lnRef idx="1">
-            <a:schemeClr val="accent1"/>
-          </a:lnRef>
-          <a:fillRef idx="3">
-            <a:schemeClr val="accent1"/>
-          </a:fillRef>
-          <a:effectRef idx="2">
-            <a:schemeClr val="accent1"/>
-          </a:effectRef>
-          <a:fontRef idx="minor">
-            <a:schemeClr val="lt1"/>
-          </a:fontRef>
-        </p:style>
-        <p:txBody>
-          <a:bodyPr rtlCol="0" anchor="ctr"/>
-          <a:lstStyle/>
-          <a:p>
-            <a:pPr algn="ctr"/>
-          </a:p>
-        </p:txBody>
-      </p:sp>
-      <p:sp>
-        <p:nvSpPr>
-          <p:cNvPr id="12" name="TextBox 11"/>
-          <p:cNvSpPr txBox="1"/>
-          <p:nvPr/>
-        </p:nvSpPr>
-        <p:spPr>
-          <a:xfrm>
-            <a:off x="8211312" y="1490472"/>
-            <a:ext cx="3026664" cy="1911096"/>
-          </a:xfrm>
-          <a:prstGeom prst="rect">
-            <a:avLst/>
-          </a:prstGeom>
-          <a:noFill/>
-        </p:spPr>
-        <p:txBody>
-          <a:bodyPr wrap="square" tIns="0" bIns="0" lIns="0" rIns="0">
-            <a:spAutoFit/>
-          </a:bodyPr>
-          <a:lstStyle/>
-          <a:p>
-            <a:pPr>
-              <a:spcAft>
-                <a:spcPts val="1000"/>
-              </a:spcAft>
-              <a:defRPr sz="1250" b="1">
-                <a:solidFill>
-                  <a:srgbClr val="2BA640"/>
-                </a:solidFill>
-              </a:defRPr>
-            </a:pPr>
-            <a:r>
-              <a:t>VideoCard.jsx</a:t>
+              <a:t>Seamless client-side navigation dynamically loading next video without tearing down DOM.</a:t>
             </a:r>
           </a:p>
           <a:p>
@@ -8126,494 +7984,20 @@
               </a:spcAft>
             </a:pPr>
             <a:r>
-              <a:rPr sz="1050">
+              <a:rPr sz="1100" b="1">
+                <a:solidFill>
+                  <a:srgbClr val="FFFFFF"/>
+                </a:solidFill>
+              </a:rPr>
+              <a:t>• Full Video Metadata: </a:t>
+            </a:r>
+            <a:r>
+              <a:rPr sz="1100">
                 <a:solidFill>
                   <a:srgbClr val="CDD2DC"/>
                 </a:solidFill>
               </a:rPr>
-              <a:t>• 16:9 thumbnail with timestamp badge.</a:t>
-            </a:r>
-          </a:p>
-          <a:p>
-            <a:pPr>
-              <a:spcAft>
-                <a:spcPts val="800"/>
-              </a:spcAft>
-            </a:pPr>
-            <a:r>
-              <a:rPr sz="1050">
-                <a:solidFill>
-                  <a:srgbClr val="CDD2DC"/>
-                </a:solidFill>
-              </a:rPr>
-              <a:t>• Channel avatar &amp; verified checkmark.</a:t>
-            </a:r>
-          </a:p>
-          <a:p>
-            <a:pPr>
-              <a:spcAft>
-                <a:spcPts val="800"/>
-              </a:spcAft>
-            </a:pPr>
-            <a:r>
-              <a:rPr sz="1050">
-                <a:solidFill>
-                  <a:srgbClr val="CDD2DC"/>
-                </a:solidFill>
-              </a:rPr>
-              <a:t>• Hover scale micro-interactions.</a:t>
-            </a:r>
-          </a:p>
-          <a:p>
-            <a:pPr>
-              <a:spcAft>
-                <a:spcPts val="800"/>
-              </a:spcAft>
-            </a:pPr>
-            <a:r>
-              <a:rPr sz="1050">
-                <a:solidFill>
-                  <a:srgbClr val="CDD2DC"/>
-                </a:solidFill>
-              </a:rPr>
-              <a:t>• Integrated infinite scroll pagination.</a:t>
-            </a:r>
-          </a:p>
-        </p:txBody>
-      </p:sp>
-      <p:sp>
-        <p:nvSpPr>
-          <p:cNvPr id="13" name="Rounded Rectangle 12"/>
-          <p:cNvSpPr/>
-          <p:nvPr/>
-        </p:nvSpPr>
-        <p:spPr>
-          <a:xfrm>
-            <a:off x="731520" y="3749039"/>
-            <a:ext cx="3429000" cy="2240280"/>
-          </a:xfrm>
-          <a:prstGeom prst="roundRect">
-            <a:avLst/>
-          </a:prstGeom>
-          <a:solidFill>
-            <a:srgbClr val="161922"/>
-          </a:solidFill>
-          <a:ln w="16510">
-            <a:solidFill>
-              <a:srgbClr val="2E3445"/>
-            </a:solidFill>
-          </a:ln>
-        </p:spPr>
-        <p:style>
-          <a:lnRef idx="1">
-            <a:schemeClr val="accent1"/>
-          </a:lnRef>
-          <a:fillRef idx="3">
-            <a:schemeClr val="accent1"/>
-          </a:fillRef>
-          <a:effectRef idx="2">
-            <a:schemeClr val="accent1"/>
-          </a:effectRef>
-          <a:fontRef idx="minor">
-            <a:schemeClr val="lt1"/>
-          </a:fontRef>
-        </p:style>
-        <p:txBody>
-          <a:bodyPr rtlCol="0" anchor="ctr"/>
-          <a:lstStyle/>
-          <a:p>
-            <a:pPr algn="ctr"/>
-          </a:p>
-        </p:txBody>
-      </p:sp>
-      <p:sp>
-        <p:nvSpPr>
-          <p:cNvPr id="14" name="TextBox 13"/>
-          <p:cNvSpPr txBox="1"/>
-          <p:nvPr/>
-        </p:nvSpPr>
-        <p:spPr>
-          <a:xfrm>
-            <a:off x="932688" y="3913631"/>
-            <a:ext cx="3026664" cy="1911096"/>
-          </a:xfrm>
-          <a:prstGeom prst="rect">
-            <a:avLst/>
-          </a:prstGeom>
-          <a:noFill/>
-        </p:spPr>
-        <p:txBody>
-          <a:bodyPr wrap="square" tIns="0" bIns="0" lIns="0" rIns="0">
-            <a:spAutoFit/>
-          </a:bodyPr>
-          <a:lstStyle/>
-          <a:p>
-            <a:pPr>
-              <a:spcAft>
-                <a:spcPts val="1000"/>
-              </a:spcAft>
-              <a:defRPr sz="1250" b="1">
-                <a:solidFill>
-                  <a:srgbClr val="A855F7"/>
-                </a:solidFill>
-              </a:defRPr>
-            </a:pPr>
-            <a:r>
-              <a:t>WatchPage.jsx</a:t>
-            </a:r>
-          </a:p>
-          <a:p>
-            <a:pPr>
-              <a:spcAft>
-                <a:spcPts val="800"/>
-              </a:spcAft>
-            </a:pPr>
-            <a:r>
-              <a:rPr sz="1050">
-                <a:solidFill>
-                  <a:srgbClr val="CDD2DC"/>
-                </a:solidFill>
-              </a:rPr>
-              <a:t>• 100% In-Site Video Player (No Redirects).</a:t>
-            </a:r>
-          </a:p>
-          <a:p>
-            <a:pPr>
-              <a:spcAft>
-                <a:spcPts val="800"/>
-              </a:spcAft>
-            </a:pPr>
-            <a:r>
-              <a:rPr sz="1050" b="1">
-                <a:solidFill>
-                  <a:srgbClr val="FFFFFF"/>
-                </a:solidFill>
-              </a:rPr>
-              <a:t>• Action controls: </a:t>
-            </a:r>
-            <a:r>
-              <a:rPr sz="1050">
-                <a:solidFill>
-                  <a:srgbClr val="CDD2DC"/>
-                </a:solidFill>
-              </a:rPr>
-              <a:t>Like, Share, Save.</a:t>
-            </a:r>
-          </a:p>
-          <a:p>
-            <a:pPr>
-              <a:spcAft>
-                <a:spcPts val="800"/>
-              </a:spcAft>
-            </a:pPr>
-            <a:r>
-              <a:rPr sz="1050">
-                <a:solidFill>
-                  <a:srgbClr val="CDD2DC"/>
-                </a:solidFill>
-              </a:rPr>
-              <a:t>• Dynamic Subscribe button &amp; counter.</a:t>
-            </a:r>
-          </a:p>
-          <a:p>
-            <a:pPr>
-              <a:spcAft>
-                <a:spcPts val="800"/>
-              </a:spcAft>
-            </a:pPr>
-            <a:r>
-              <a:rPr sz="1050">
-                <a:solidFill>
-                  <a:srgbClr val="CDD2DC"/>
-                </a:solidFill>
-              </a:rPr>
-              <a:t>• Real-time useRef comment thread.</a:t>
-            </a:r>
-          </a:p>
-        </p:txBody>
-      </p:sp>
-      <p:sp>
-        <p:nvSpPr>
-          <p:cNvPr id="15" name="Rounded Rectangle 14"/>
-          <p:cNvSpPr/>
-          <p:nvPr/>
-        </p:nvSpPr>
-        <p:spPr>
-          <a:xfrm>
-            <a:off x="4370832" y="3749039"/>
-            <a:ext cx="3429000" cy="2240280"/>
-          </a:xfrm>
-          <a:prstGeom prst="roundRect">
-            <a:avLst/>
-          </a:prstGeom>
-          <a:solidFill>
-            <a:srgbClr val="161922"/>
-          </a:solidFill>
-          <a:ln w="16510">
-            <a:solidFill>
-              <a:srgbClr val="2E3445"/>
-            </a:solidFill>
-          </a:ln>
-        </p:spPr>
-        <p:style>
-          <a:lnRef idx="1">
-            <a:schemeClr val="accent1"/>
-          </a:lnRef>
-          <a:fillRef idx="3">
-            <a:schemeClr val="accent1"/>
-          </a:fillRef>
-          <a:effectRef idx="2">
-            <a:schemeClr val="accent1"/>
-          </a:effectRef>
-          <a:fontRef idx="minor">
-            <a:schemeClr val="lt1"/>
-          </a:fontRef>
-        </p:style>
-        <p:txBody>
-          <a:bodyPr rtlCol="0" anchor="ctr"/>
-          <a:lstStyle/>
-          <a:p>
-            <a:pPr algn="ctr"/>
-          </a:p>
-        </p:txBody>
-      </p:sp>
-      <p:sp>
-        <p:nvSpPr>
-          <p:cNvPr id="16" name="TextBox 15"/>
-          <p:cNvSpPr txBox="1"/>
-          <p:nvPr/>
-        </p:nvSpPr>
-        <p:spPr>
-          <a:xfrm>
-            <a:off x="4572000" y="3913631"/>
-            <a:ext cx="3026664" cy="1911096"/>
-          </a:xfrm>
-          <a:prstGeom prst="rect">
-            <a:avLst/>
-          </a:prstGeom>
-          <a:noFill/>
-        </p:spPr>
-        <p:txBody>
-          <a:bodyPr wrap="square" tIns="0" bIns="0" lIns="0" rIns="0">
-            <a:spAutoFit/>
-          </a:bodyPr>
-          <a:lstStyle/>
-          <a:p>
-            <a:pPr>
-              <a:spcAft>
-                <a:spcPts val="1000"/>
-              </a:spcAft>
-              <a:defRPr sz="1250" b="1">
-                <a:solidFill>
-                  <a:srgbClr val="FF0033"/>
-                </a:solidFill>
-              </a:defRPr>
-            </a:pPr>
-            <a:r>
-              <a:t>AuthModal.jsx</a:t>
-            </a:r>
-          </a:p>
-          <a:p>
-            <a:pPr>
-              <a:spcAft>
-                <a:spcPts val="800"/>
-              </a:spcAft>
-            </a:pPr>
-            <a:r>
-              <a:rPr sz="1050">
-                <a:solidFill>
-                  <a:srgbClr val="CDD2DC"/>
-                </a:solidFill>
-              </a:rPr>
-              <a:t>• Tabbed interface (Sign In &amp; Sign Up).</a:t>
-            </a:r>
-          </a:p>
-          <a:p>
-            <a:pPr>
-              <a:spcAft>
-                <a:spcPts val="800"/>
-              </a:spcAft>
-            </a:pPr>
-            <a:r>
-              <a:rPr sz="1050">
-                <a:solidFill>
-                  <a:srgbClr val="CDD2DC"/>
-                </a:solidFill>
-              </a:rPr>
-              <a:t>• Client-side credentials validation.</a:t>
-            </a:r>
-          </a:p>
-          <a:p>
-            <a:pPr>
-              <a:spcAft>
-                <a:spcPts val="800"/>
-              </a:spcAft>
-            </a:pPr>
-            <a:r>
-              <a:rPr sz="1050">
-                <a:solidFill>
-                  <a:srgbClr val="CDD2DC"/>
-                </a:solidFill>
-              </a:rPr>
-              <a:t>• Automatic guest login on registration.</a:t>
-            </a:r>
-          </a:p>
-          <a:p>
-            <a:pPr>
-              <a:spcAft>
-                <a:spcPts val="800"/>
-              </a:spcAft>
-            </a:pPr>
-            <a:r>
-              <a:rPr sz="1050">
-                <a:solidFill>
-                  <a:srgbClr val="CDD2DC"/>
-                </a:solidFill>
-              </a:rPr>
-              <a:t>• Session persistence via LocalStorage.</a:t>
-            </a:r>
-          </a:p>
-        </p:txBody>
-      </p:sp>
-      <p:sp>
-        <p:nvSpPr>
-          <p:cNvPr id="17" name="Rounded Rectangle 16"/>
-          <p:cNvSpPr/>
-          <p:nvPr/>
-        </p:nvSpPr>
-        <p:spPr>
-          <a:xfrm>
-            <a:off x="8010144" y="3749039"/>
-            <a:ext cx="3429000" cy="2240280"/>
-          </a:xfrm>
-          <a:prstGeom prst="roundRect">
-            <a:avLst/>
-          </a:prstGeom>
-          <a:solidFill>
-            <a:srgbClr val="161922"/>
-          </a:solidFill>
-          <a:ln w="16510">
-            <a:solidFill>
-              <a:srgbClr val="2E3445"/>
-            </a:solidFill>
-          </a:ln>
-        </p:spPr>
-        <p:style>
-          <a:lnRef idx="1">
-            <a:schemeClr val="accent1"/>
-          </a:lnRef>
-          <a:fillRef idx="3">
-            <a:schemeClr val="accent1"/>
-          </a:fillRef>
-          <a:effectRef idx="2">
-            <a:schemeClr val="accent1"/>
-          </a:effectRef>
-          <a:fontRef idx="minor">
-            <a:schemeClr val="lt1"/>
-          </a:fontRef>
-        </p:style>
-        <p:txBody>
-          <a:bodyPr rtlCol="0" anchor="ctr"/>
-          <a:lstStyle/>
-          <a:p>
-            <a:pPr algn="ctr"/>
-          </a:p>
-        </p:txBody>
-      </p:sp>
-      <p:sp>
-        <p:nvSpPr>
-          <p:cNvPr id="18" name="TextBox 17"/>
-          <p:cNvSpPr txBox="1"/>
-          <p:nvPr/>
-        </p:nvSpPr>
-        <p:spPr>
-          <a:xfrm>
-            <a:off x="8211312" y="3913631"/>
-            <a:ext cx="3026664" cy="1911096"/>
-          </a:xfrm>
-          <a:prstGeom prst="rect">
-            <a:avLst/>
-          </a:prstGeom>
-          <a:noFill/>
-        </p:spPr>
-        <p:txBody>
-          <a:bodyPr wrap="square" tIns="0" bIns="0" lIns="0" rIns="0">
-            <a:spAutoFit/>
-          </a:bodyPr>
-          <a:lstStyle/>
-          <a:p>
-            <a:pPr>
-              <a:spcAft>
-                <a:spcPts val="1000"/>
-              </a:spcAft>
-              <a:defRPr sz="1250" b="1">
-                <a:solidFill>
-                  <a:srgbClr val="3EA6FF"/>
-                </a:solidFill>
-              </a:defRPr>
-            </a:pPr>
-            <a:r>
-              <a:t>SettingsModal.jsx</a:t>
-            </a:r>
-          </a:p>
-          <a:p>
-            <a:pPr>
-              <a:spcAft>
-                <a:spcPts val="800"/>
-              </a:spcAft>
-            </a:pPr>
-            <a:r>
-              <a:rPr sz="1050">
-                <a:solidFill>
-                  <a:srgbClr val="CDD2DC"/>
-                </a:solidFill>
-              </a:rPr>
-              <a:t>• Genuine YouTube settings interface.</a:t>
-            </a:r>
-          </a:p>
-          <a:p>
-            <a:pPr>
-              <a:spcAft>
-                <a:spcPts val="800"/>
-              </a:spcAft>
-            </a:pPr>
-            <a:r>
-              <a:rPr sz="1050">
-                <a:solidFill>
-                  <a:srgbClr val="CDD2DC"/>
-                </a:solidFill>
-              </a:rPr>
-              <a:t>• Display Theme (Dark/Light Mode).</a:t>
-            </a:r>
-          </a:p>
-          <a:p>
-            <a:pPr>
-              <a:spcAft>
-                <a:spcPts val="800"/>
-              </a:spcAft>
-            </a:pPr>
-            <a:r>
-              <a:rPr sz="1050">
-                <a:solidFill>
-                  <a:srgbClr val="CDD2DC"/>
-                </a:solidFill>
-              </a:rPr>
-              <a:t>• Autoplay &amp; HD 1080p stream toggles.</a:t>
-            </a:r>
-          </a:p>
-          <a:p>
-            <a:pPr>
-              <a:spcAft>
-                <a:spcPts val="800"/>
-              </a:spcAft>
-            </a:pPr>
-            <a:r>
-              <a:rPr sz="1050">
-                <a:solidFill>
-                  <a:srgbClr val="CDD2DC"/>
-                </a:solidFill>
-              </a:rPr>
-              <a:t>• YouTube Data API v3 live key manager.</a:t>
+              <a:t>Comprehensive description drawer with tags, view counts, and publication timestamps.</a:t>
             </a:r>
           </a:p>
         </p:txBody>
@@ -8790,7 +8174,7 @@
               </a:defRPr>
             </a:pPr>
             <a:r>
-              <a:t>In-Site Video Streaming Engine (/watch/:id) — No Redirecting</a:t>
+              <a:t>Interactive Comments with useRef &amp; Voice Search Pulse</a:t>
             </a:r>
           </a:p>
         </p:txBody>
@@ -8877,7 +8261,7 @@
       </p:sp>
       <p:pic>
         <p:nvPicPr>
-          <p:cNvPr id="8" name="Picture 7" descr="feat_watch_player.png"/>
+          <p:cNvPr id="8" name="Picture 7" descr="ui_search_clean.png"/>
           <p:cNvPicPr>
             <a:picLocks noChangeAspect="1"/>
           </p:cNvPicPr>
@@ -8892,7 +8276,7 @@
         <p:spPr>
           <a:xfrm>
             <a:off x="868680" y="1508760"/>
-            <a:ext cx="5029200" cy="3143250"/>
+            <a:ext cx="5029200" cy="4701209"/>
           </a:xfrm>
           <a:prstGeom prst="rect">
             <a:avLst/>
@@ -8972,12 +8356,12 @@
               </a:spcAft>
               <a:defRPr sz="1300" b="1">
                 <a:solidFill>
-                  <a:srgbClr val="FF0033"/>
+                  <a:srgbClr val="3EA6FF"/>
                 </a:solidFill>
               </a:defRPr>
             </a:pPr>
             <a:r>
-              <a:t>In-Site Streaming &amp; Action Controls</a:t>
+              <a:t>Comments Thread &amp; Speech API Specs</a:t>
             </a:r>
           </a:p>
           <a:p>
@@ -8992,7 +8376,7 @@
                   <a:srgbClr val="FFFFFF"/>
                 </a:solidFill>
               </a:rPr>
-              <a:t>• 100% In-Site Video Playback: </a:t>
+              <a:t>• Native Web Speech API Mic: </a:t>
             </a:r>
             <a:r>
               <a:rPr sz="1100">
@@ -9000,7 +8384,7 @@
                   <a:srgbClr val="CDD2DC"/>
                 </a:solidFill>
               </a:rPr>
-              <a:t>Media streams directly inside PheW TuBe on the /watch/:id route with zero external redirects to YouTube.</a:t>
+              <a:t>Hands-free voice recognition with an animated listening pulse overlay and auto query search.</a:t>
             </a:r>
           </a:p>
           <a:p>
@@ -9015,7 +8399,7 @@
                   <a:srgbClr val="FFFFFF"/>
                 </a:solidFill>
               </a:rPr>
-              <a:t>• Working Interactive Controls: </a:t>
+              <a:t>• DOM Control via useRef: </a:t>
             </a:r>
             <a:r>
               <a:rPr sz="1100">
@@ -9023,7 +8407,7 @@
                   <a:srgbClr val="CDD2DC"/>
                 </a:solidFill>
               </a:rPr>
-              <a:t>Functional Like counter with active state highlighting, Share link copier, and Watch Later bookmarking.</a:t>
+              <a:t>Direct programmatic input focus when user engages with comments, eliminating synthetic re-renders.</a:t>
             </a:r>
           </a:p>
           <a:p>
@@ -9038,7 +8422,7 @@
                   <a:srgbClr val="FFFFFF"/>
                 </a:solidFill>
               </a:rPr>
-              <a:t>• Channel Subscription Engine: </a:t>
+              <a:t>• Real-Time Discussion Thread: </a:t>
             </a:r>
             <a:r>
               <a:rPr sz="1100">
@@ -9046,7 +8430,7 @@
                   <a:srgbClr val="CDD2DC"/>
                 </a:solidFill>
               </a:rPr>
-              <a:t>One-click Subscribe / Unsubscribe toggle dynamically synchronizing channel subscriber counts.</a:t>
+              <a:t>Allows posting instant user comments with dynamic avatar attachment and optimistic UI commits.</a:t>
             </a:r>
           </a:p>
           <a:p>
@@ -9061,7 +8445,7 @@
                   <a:srgbClr val="FFFFFF"/>
                 </a:solidFill>
               </a:rPr>
-              <a:t>• Up-Next Recommendation Sidebar: </a:t>
+              <a:t>• Sorting &amp; Filtering Engine: </a:t>
             </a:r>
             <a:r>
               <a:rPr sz="1100">
@@ -9069,7 +8453,7 @@
                   <a:srgbClr val="CDD2DC"/>
                 </a:solidFill>
               </a:rPr>
-              <a:t>Seamless client-side navigation dynamically loading next video without tearing down DOM.</a:t>
+              <a:t>Interactive sort dropdown toggling between 'Top Comments' and 'Newest First'.</a:t>
             </a:r>
           </a:p>
           <a:p>
@@ -9084,7 +8468,7 @@
                   <a:srgbClr val="FFFFFF"/>
                 </a:solidFill>
               </a:rPr>
-              <a:t>• Full Video Metadata: </a:t>
+              <a:t>• Comment Engagement Metrics: </a:t>
             </a:r>
             <a:r>
               <a:rPr sz="1100">
@@ -9092,7 +8476,7 @@
                   <a:srgbClr val="CDD2DC"/>
                 </a:solidFill>
               </a:rPr>
-              <a:t>Comprehensive description drawer with tags, view counts, and publication timestamps.</a:t>
+              <a:t>Independent like counter and interactive reply toggles per discussion node.</a:t>
             </a:r>
           </a:p>
         </p:txBody>
@@ -9269,7 +8653,7 @@
               </a:defRPr>
             </a:pPr>
             <a:r>
-              <a:t>Interactive Comments with useRef &amp; Voice Search Pulse</a:t>
+              <a:t>Protected Routing &amp; Guest Authentication Gatekeeper</a:t>
             </a:r>
           </a:p>
         </p:txBody>
@@ -9356,7 +8740,7 @@
       </p:sp>
       <p:pic>
         <p:nvPicPr>
-          <p:cNvPr id="8" name="Picture 7" descr="ui_search_clean.png"/>
+          <p:cNvPr id="8" name="Picture 7" descr="crop_auth_modal.png"/>
           <p:cNvPicPr>
             <a:picLocks noChangeAspect="1"/>
           </p:cNvPicPr>
@@ -9370,8 +8754,8 @@
         </p:blipFill>
         <p:spPr>
           <a:xfrm>
-            <a:off x="868680" y="1508760"/>
-            <a:ext cx="5029200" cy="4701209"/>
+            <a:off x="1280160" y="1508760"/>
+            <a:ext cx="4206240" cy="3720905"/>
           </a:xfrm>
           <a:prstGeom prst="rect">
             <a:avLst/>
@@ -9451,12 +8835,12 @@
               </a:spcAft>
               <a:defRPr sz="1300" b="1">
                 <a:solidFill>
-                  <a:srgbClr val="3EA6FF"/>
+                  <a:srgbClr val="FF0033"/>
                 </a:solidFill>
               </a:defRPr>
             </a:pPr>
             <a:r>
-              <a:t>Comments Thread &amp; Speech API Specs</a:t>
+              <a:t>Protected Routing &amp; Session Specs</a:t>
             </a:r>
           </a:p>
           <a:p>
@@ -9471,7 +8855,7 @@
                   <a:srgbClr val="FFFFFF"/>
                 </a:solidFill>
               </a:rPr>
-              <a:t>• Native Web Speech API Mic: </a:t>
+              <a:t>• Dedicated Auth Modal: </a:t>
             </a:r>
             <a:r>
               <a:rPr sz="1100">
@@ -9479,7 +8863,7 @@
                   <a:srgbClr val="CDD2DC"/>
                 </a:solidFill>
               </a:rPr>
-              <a:t>Hands-free voice recognition with an animated listening pulse overlay and auto query search.</a:t>
+              <a:t>Tabbed modal interface supporting both Sign In and Sign Up with live form validation.</a:t>
             </a:r>
           </a:p>
           <a:p>
@@ -9494,7 +8878,7 @@
                   <a:srgbClr val="FFFFFF"/>
                 </a:solidFill>
               </a:rPr>
-              <a:t>• DOM Control via useRef: </a:t>
+              <a:t>• Strict Protected Route Gatekeeper: </a:t>
             </a:r>
             <a:r>
               <a:rPr sz="1100">
@@ -9502,7 +8886,7 @@
                   <a:srgbClr val="CDD2DC"/>
                 </a:solidFill>
               </a:rPr>
-              <a:t>Direct programmatic input focus when user engages with comments, eliminating synthetic re-renders.</a:t>
+              <a:t>Subscriptions, Playlists, Liked Videos, and History remain locked for unauthenticated guests.</a:t>
             </a:r>
           </a:p>
           <a:p>
@@ -9517,7 +8901,7 @@
                   <a:srgbClr val="FFFFFF"/>
                 </a:solidFill>
               </a:rPr>
-              <a:t>• Real-Time Discussion Thread: </a:t>
+              <a:t>• Non-Disruptive Interception: </a:t>
             </a:r>
             <a:r>
               <a:rPr sz="1100">
@@ -9525,7 +8909,7 @@
                   <a:srgbClr val="CDD2DC"/>
                 </a:solidFill>
               </a:rPr>
-              <a:t>Allows posting instant user comments with dynamic avatar attachment and optimistic UI commits.</a:t>
+              <a:t>Clicking locked features displays an informative gatekeeper screen prompting Sign In.</a:t>
             </a:r>
           </a:p>
           <a:p>
@@ -9540,7 +8924,7 @@
                   <a:srgbClr val="FFFFFF"/>
                 </a:solidFill>
               </a:rPr>
-              <a:t>• Sorting &amp; Filtering Engine: </a:t>
+              <a:t>• Automatic Session Hydration: </a:t>
             </a:r>
             <a:r>
               <a:rPr sz="1100">
@@ -9548,7 +8932,7 @@
                   <a:srgbClr val="CDD2DC"/>
                 </a:solidFill>
               </a:rPr>
-              <a:t>Interactive sort dropdown toggling between 'Top Comments' and 'Newest First'.</a:t>
+              <a:t>Successfully registering or signing in instantly authenticates the user without losing current route.</a:t>
             </a:r>
           </a:p>
           <a:p>
@@ -9563,7 +8947,7 @@
                   <a:srgbClr val="FFFFFF"/>
                 </a:solidFill>
               </a:rPr>
-              <a:t>• Comment Engagement Metrics: </a:t>
+              <a:t>• Session Persistence: </a:t>
             </a:r>
             <a:r>
               <a:rPr sz="1100">
@@ -9571,7 +8955,7 @@
                   <a:srgbClr val="CDD2DC"/>
                 </a:solidFill>
               </a:rPr>
-              <a:t>Independent like counter and interactive reply toggles per discussion node.</a:t>
+              <a:t>Stores encrypted session state in LocalStorage, preserving login across browser reloads.</a:t>
             </a:r>
           </a:p>
         </p:txBody>
@@ -9748,7 +9132,7 @@
               </a:defRPr>
             </a:pPr>
             <a:r>
-              <a:t>Protected Routing &amp; Guest Authentication Gatekeeper</a:t>
+              <a:t>Real YouTube Settings Panel &amp; Playback Preferences</a:t>
             </a:r>
           </a:p>
         </p:txBody>
@@ -9835,7 +9219,7 @@
       </p:sp>
       <p:pic>
         <p:nvPicPr>
-          <p:cNvPr id="8" name="Picture 7" descr="crop_auth_modal.png"/>
+          <p:cNvPr id="8" name="Picture 7" descr="crop_settings_modal.png"/>
           <p:cNvPicPr>
             <a:picLocks noChangeAspect="1"/>
           </p:cNvPicPr>
@@ -9849,8 +9233,8 @@
         </p:blipFill>
         <p:spPr>
           <a:xfrm>
-            <a:off x="1280160" y="1508760"/>
-            <a:ext cx="4206240" cy="3720905"/>
+            <a:off x="1920240" y="1417320"/>
+            <a:ext cx="3106522" cy="4480560"/>
           </a:xfrm>
           <a:prstGeom prst="rect">
             <a:avLst/>
@@ -9930,12 +9314,12 @@
               </a:spcAft>
               <a:defRPr sz="1300" b="1">
                 <a:solidFill>
-                  <a:srgbClr val="FF0033"/>
+                  <a:srgbClr val="2BA640"/>
                 </a:solidFill>
               </a:defRPr>
             </a:pPr>
             <a:r>
-              <a:t>Protected Routing &amp; Session Specs</a:t>
+              <a:t>Settings Architecture &amp; Controls</a:t>
             </a:r>
           </a:p>
           <a:p>
@@ -9950,7 +9334,7 @@
                   <a:srgbClr val="FFFFFF"/>
                 </a:solidFill>
               </a:rPr>
-              <a:t>• Dedicated Auth Modal: </a:t>
+              <a:t>• Authentic YouTube Settings UI: </a:t>
             </a:r>
             <a:r>
               <a:rPr sz="1100">
@@ -9958,7 +9342,7 @@
                   <a:srgbClr val="CDD2DC"/>
                 </a:solidFill>
               </a:rPr>
-              <a:t>Tabbed modal interface supporting both Sign In and Sign Up with live form validation.</a:t>
+              <a:t>Replicates genuine YouTube preferences dialog with backdrop blur and smooth exit.</a:t>
             </a:r>
           </a:p>
           <a:p>
@@ -9973,7 +9357,7 @@
                   <a:srgbClr val="FFFFFF"/>
                 </a:solidFill>
               </a:rPr>
-              <a:t>• Strict Protected Route Gatekeeper: </a:t>
+              <a:t>• Display Theme Engine: </a:t>
             </a:r>
             <a:r>
               <a:rPr sz="1100">
@@ -9981,7 +9365,7 @@
                   <a:srgbClr val="CDD2DC"/>
                 </a:solidFill>
               </a:rPr>
-              <a:t>Subscriptions, Playlists, Liked Videos, and History remain locked for unauthenticated guests.</a:t>
+              <a:t>Instant toggle between Dark Mode and Light Mode with CSS variables updating all UI elements.</a:t>
             </a:r>
           </a:p>
           <a:p>
@@ -9996,7 +9380,7 @@
                   <a:srgbClr val="FFFFFF"/>
                 </a:solidFill>
               </a:rPr>
-              <a:t>• Non-Disruptive Interception: </a:t>
+              <a:t>• Autoplay Next Video: </a:t>
             </a:r>
             <a:r>
               <a:rPr sz="1100">
@@ -10004,7 +9388,7 @@
                   <a:srgbClr val="CDD2DC"/>
                 </a:solidFill>
               </a:rPr>
-              <a:t>Clicking locked features displays an informative gatekeeper screen prompting Sign In.</a:t>
+              <a:t>Automated continuous playback queue seamlessly transitioning to next video upon finish.</a:t>
             </a:r>
           </a:p>
           <a:p>
@@ -10019,7 +9403,7 @@
                   <a:srgbClr val="FFFFFF"/>
                 </a:solidFill>
               </a:rPr>
-              <a:t>• Automatic Session Hydration: </a:t>
+              <a:t>• HD 1080p Stream Quality: </a:t>
             </a:r>
             <a:r>
               <a:rPr sz="1100">
@@ -10027,7 +9411,7 @@
                   <a:srgbClr val="CDD2DC"/>
                 </a:solidFill>
               </a:rPr>
-              <a:t>Successfully registering or signing in instantly authenticates the user without losing current route.</a:t>
+              <a:t>High-bitrate default stream resolution preference enforcement.</a:t>
             </a:r>
           </a:p>
           <a:p>
@@ -10042,7 +9426,7 @@
                   <a:srgbClr val="FFFFFF"/>
                 </a:solidFill>
               </a:rPr>
-              <a:t>• Session Persistence: </a:t>
+              <a:t>• Storage &amp; Cache Controls: </a:t>
             </a:r>
             <a:r>
               <a:rPr sz="1100">
@@ -10050,7 +9434,7 @@
                   <a:srgbClr val="CDD2DC"/>
                 </a:solidFill>
               </a:rPr>
-              <a:t>Stores encrypted session state in LocalStorage, preserving login across browser reloads.</a:t>
+              <a:t>Dedicated 'Clear Watch History' and 'Reset All App Storage' buttons for evaluation testing.</a:t>
             </a:r>
           </a:p>
         </p:txBody>
@@ -10227,7 +9611,7 @@
               </a:defRPr>
             </a:pPr>
             <a:r>
-              <a:t>Real YouTube Settings Panel &amp; Playback Preferences</a:t>
+              <a:t>Infinite Scroll Feed &amp; YouTube Data API v3 Engine</a:t>
             </a:r>
           </a:p>
         </p:txBody>
@@ -10276,7 +9660,7 @@
         <p:spPr>
           <a:xfrm>
             <a:off x="731520" y="1325880"/>
-            <a:ext cx="5303520" cy="4663440"/>
+            <a:ext cx="5212080" cy="4663440"/>
           </a:xfrm>
           <a:prstGeom prst="roundRect">
             <a:avLst/>
@@ -10312,30 +9696,113 @@
           </a:p>
         </p:txBody>
       </p:sp>
-      <p:pic>
-        <p:nvPicPr>
-          <p:cNvPr id="8" name="Picture 7" descr="crop_settings_modal.png"/>
-          <p:cNvPicPr>
-            <a:picLocks noChangeAspect="1"/>
-          </p:cNvPicPr>
-          <p:nvPr/>
-        </p:nvPicPr>
-        <p:blipFill>
-          <a:blip r:embed="rId2"/>
-          <a:stretch>
-            <a:fillRect/>
-          </a:stretch>
-        </p:blipFill>
-        <p:spPr>
-          <a:xfrm>
-            <a:off x="1920240" y="1417320"/>
-            <a:ext cx="3106522" cy="4480560"/>
+      <p:sp>
+        <p:nvSpPr>
+          <p:cNvPr id="8" name="TextBox 7"/>
+          <p:cNvSpPr txBox="1"/>
+          <p:nvPr/>
+        </p:nvSpPr>
+        <p:spPr>
+          <a:xfrm>
+            <a:off x="932688" y="1490472"/>
+            <a:ext cx="4809744" cy="4334255"/>
           </a:xfrm>
           <a:prstGeom prst="rect">
             <a:avLst/>
           </a:prstGeom>
-        </p:spPr>
-      </p:pic>
+          <a:noFill/>
+        </p:spPr>
+        <p:txBody>
+          <a:bodyPr wrap="square" tIns="0" bIns="0" lIns="0" rIns="0">
+            <a:spAutoFit/>
+          </a:bodyPr>
+          <a:lstStyle/>
+          <a:p>
+            <a:pPr>
+              <a:spcAft>
+                <a:spcPts val="1000"/>
+              </a:spcAft>
+              <a:defRPr sz="1350" b="1">
+                <a:solidFill>
+                  <a:srgbClr val="3EA6FF"/>
+                </a:solidFill>
+              </a:defRPr>
+            </a:pPr>
+            <a:r>
+              <a:t>Infinite Scroll Feed Pagination</a:t>
+            </a:r>
+          </a:p>
+          <a:p>
+            <a:pPr>
+              <a:spcAft>
+                <a:spcPts val="800"/>
+              </a:spcAft>
+            </a:pPr>
+            <a:r>
+              <a:rPr sz="1150" b="1">
+                <a:solidFill>
+                  <a:srgbClr val="FFFFFF"/>
+                </a:solidFill>
+              </a:rPr>
+              <a:t>• react-infinite-scroll-component: </a:t>
+            </a:r>
+            <a:r>
+              <a:rPr sz="1150">
+                <a:solidFill>
+                  <a:srgbClr val="CDD2DC"/>
+                </a:solidFill>
+              </a:rPr>
+              <a:t>Continuous feed pagination dynamically fetching video batches as user scrolls down.</a:t>
+            </a:r>
+          </a:p>
+          <a:p>
+            <a:pPr>
+              <a:spcAft>
+                <a:spcPts val="800"/>
+              </a:spcAft>
+            </a:pPr>
+            <a:r>
+              <a:rPr sz="1150" b="1">
+                <a:solidFill>
+                  <a:srgbClr val="FFFFFF"/>
+                </a:solidFill>
+              </a:rPr>
+              <a:t>• Zero Churn Reconciliation: </a:t>
+            </a:r>
+            <a:r>
+              <a:rPr sz="1150">
+                <a:solidFill>
+                  <a:srgbClr val="CDD2DC"/>
+                </a:solidFill>
+              </a:rPr>
+              <a:t>Slicing and appending next batches isolates new cards without re-rendering existing items.</a:t>
+            </a:r>
+          </a:p>
+          <a:p>
+            <a:pPr>
+              <a:spcAft>
+                <a:spcPts val="800"/>
+              </a:spcAft>
+            </a:pPr>
+            <a:r>
+              <a:rPr sz="1150" b="1">
+                <a:solidFill>
+                  <a:srgbClr val="FFFFFF"/>
+                </a:solidFill>
+              </a:rPr>
+              <a:t>• Scroll Trigger Geometry: </a:t>
+            </a:r>
+            <a:r>
+              <a:rPr sz="1150">
+                <a:solidFill>
+                  <a:srgbClr val="CDD2DC"/>
+                </a:solidFill>
+              </a:rPr>
+              <a:t>Viewport intersection thresholds trigger data fetching before reaching bottom of page.</a:t>
+            </a:r>
+          </a:p>
+        </p:txBody>
+      </p:sp>
       <p:sp>
         <p:nvSpPr>
           <p:cNvPr id="9" name="Rounded Rectangle 8"/>
@@ -10407,14 +9874,14 @@
               <a:spcAft>
                 <a:spcPts val="1000"/>
               </a:spcAft>
-              <a:defRPr sz="1300" b="1">
-                <a:solidFill>
-                  <a:srgbClr val="2BA640"/>
+              <a:defRPr sz="1350" b="1">
+                <a:solidFill>
+                  <a:srgbClr val="A855F7"/>
                 </a:solidFill>
               </a:defRPr>
             </a:pPr>
             <a:r>
-              <a:t>Settings Architecture &amp; Controls</a:t>
+              <a:t>YouTube Data API v3 Live Integration</a:t>
             </a:r>
           </a:p>
           <a:p>
@@ -10424,20 +9891,20 @@
               </a:spcAft>
             </a:pPr>
             <a:r>
-              <a:rPr sz="1100" b="1">
+              <a:rPr sz="1150" b="1">
                 <a:solidFill>
                   <a:srgbClr val="FFFFFF"/>
                 </a:solidFill>
               </a:rPr>
-              <a:t>• Authentic YouTube Settings UI: </a:t>
-            </a:r>
-            <a:r>
-              <a:rPr sz="1100">
+              <a:t>• Google Cloud YouTube API v3: </a:t>
+            </a:r>
+            <a:r>
+              <a:rPr sz="1150">
                 <a:solidFill>
                   <a:srgbClr val="CDD2DC"/>
                 </a:solidFill>
               </a:rPr>
-              <a:t>Replicates genuine YouTube preferences dialog with backdrop blur and smooth exit.</a:t>
+              <a:t>Direct RESTful integration querying live YouTube video metadata, thumbnails, and views.</a:t>
             </a:r>
           </a:p>
           <a:p>
@@ -10447,20 +9914,20 @@
               </a:spcAft>
             </a:pPr>
             <a:r>
-              <a:rPr sz="1100" b="1">
+              <a:rPr sz="1150" b="1">
                 <a:solidFill>
                   <a:srgbClr val="FFFFFF"/>
                 </a:solidFill>
               </a:rPr>
-              <a:t>• Display Theme Engine: </a:t>
-            </a:r>
-            <a:r>
-              <a:rPr sz="1100">
+              <a:t>• Live Key Manager: </a:t>
+            </a:r>
+            <a:r>
+              <a:rPr sz="1150">
                 <a:solidFill>
                   <a:srgbClr val="CDD2DC"/>
                 </a:solidFill>
               </a:rPr>
-              <a:t>Instant toggle between Dark Mode and Light Mode with CSS variables updating all UI elements.</a:t>
+              <a:t>In-app settings switch allows entering custom Google Cloud API key to toggle live YouTube data.</a:t>
             </a:r>
           </a:p>
           <a:p>
@@ -10470,66 +9937,20 @@
               </a:spcAft>
             </a:pPr>
             <a:r>
-              <a:rPr sz="1100" b="1">
+              <a:rPr sz="1150" b="1">
                 <a:solidFill>
                   <a:srgbClr val="FFFFFF"/>
                 </a:solidFill>
               </a:rPr>
-              <a:t>• Autoplay Next Video: </a:t>
-            </a:r>
-            <a:r>
-              <a:rPr sz="1100">
+              <a:t>• Resilient Offline Fallback: </a:t>
+            </a:r>
+            <a:r>
+              <a:rPr sz="1150">
                 <a:solidFill>
                   <a:srgbClr val="CDD2DC"/>
                 </a:solidFill>
               </a:rPr>
-              <a:t>Automated continuous playback queue seamlessly transitioning to next video upon finish.</a:t>
-            </a:r>
-          </a:p>
-          <a:p>
-            <a:pPr>
-              <a:spcAft>
-                <a:spcPts val="800"/>
-              </a:spcAft>
-            </a:pPr>
-            <a:r>
-              <a:rPr sz="1100" b="1">
-                <a:solidFill>
-                  <a:srgbClr val="FFFFFF"/>
-                </a:solidFill>
-              </a:rPr>
-              <a:t>• HD 1080p Stream Quality: </a:t>
-            </a:r>
-            <a:r>
-              <a:rPr sz="1100">
-                <a:solidFill>
-                  <a:srgbClr val="CDD2DC"/>
-                </a:solidFill>
-              </a:rPr>
-              <a:t>High-bitrate default stream resolution preference enforcement.</a:t>
-            </a:r>
-          </a:p>
-          <a:p>
-            <a:pPr>
-              <a:spcAft>
-                <a:spcPts val="800"/>
-              </a:spcAft>
-            </a:pPr>
-            <a:r>
-              <a:rPr sz="1100" b="1">
-                <a:solidFill>
-                  <a:srgbClr val="FFFFFF"/>
-                </a:solidFill>
-              </a:rPr>
-              <a:t>• Storage &amp; Cache Controls: </a:t>
-            </a:r>
-            <a:r>
-              <a:rPr sz="1100">
-                <a:solidFill>
-                  <a:srgbClr val="CDD2DC"/>
-                </a:solidFill>
-              </a:rPr>
-              <a:t>Dedicated 'Clear Watch History' and 'Reset All App Storage' buttons for evaluation testing.</a:t>
+              <a:t>Gracefully falls back to high-fidelity curated mock dataset (youtubeData.js) on quota exhaustion.</a:t>
             </a:r>
           </a:p>
         </p:txBody>

</xml_diff>

<commit_message>
Apply user screenshots: active playing video on slide 5 and glowing mic on slide 6, remove viva summary slide
</commit_message>
<xml_diff>
--- a/G15-PID-17.pptx
+++ b/G15-PID-17.pptx
@@ -16,7 +16,6 @@
     <p:sldId id="264" r:id="rId15"/>
     <p:sldId id="265" r:id="rId16"/>
     <p:sldId id="266" r:id="rId17"/>
-    <p:sldId id="267" r:id="rId18"/>
   </p:sldIdLst>
   <p:sldSz cx="12191695" cy="6858000" type="screen4x3"/>
   <p:notesSz cx="6858000" cy="9144000"/>
@@ -4044,522 +4043,6 @@
       </p:sp>
       <p:sp>
         <p:nvSpPr>
-          <p:cNvPr id="3" name="Rectangle 2"/>
-          <p:cNvSpPr/>
-          <p:nvPr/>
-        </p:nvSpPr>
-        <p:spPr>
-          <a:xfrm>
-            <a:off x="731520" y="365760"/>
-            <a:ext cx="365760" cy="54864"/>
-          </a:xfrm>
-          <a:prstGeom prst="rect">
-            <a:avLst/>
-          </a:prstGeom>
-          <a:solidFill>
-            <a:srgbClr val="FF0033"/>
-          </a:solidFill>
-          <a:ln>
-            <a:noFill/>
-          </a:ln>
-        </p:spPr>
-        <p:style>
-          <a:lnRef idx="1">
-            <a:schemeClr val="accent1"/>
-          </a:lnRef>
-          <a:fillRef idx="3">
-            <a:schemeClr val="accent1"/>
-          </a:fillRef>
-          <a:effectRef idx="2">
-            <a:schemeClr val="accent1"/>
-          </a:effectRef>
-          <a:fontRef idx="minor">
-            <a:schemeClr val="lt1"/>
-          </a:fontRef>
-        </p:style>
-        <p:txBody>
-          <a:bodyPr rtlCol="0" anchor="ctr"/>
-          <a:lstStyle/>
-          <a:p>
-            <a:pPr algn="ctr"/>
-          </a:p>
-        </p:txBody>
-      </p:sp>
-      <p:sp>
-        <p:nvSpPr>
-          <p:cNvPr id="4" name="TextBox 3"/>
-          <p:cNvSpPr txBox="1"/>
-          <p:nvPr/>
-        </p:nvSpPr>
-        <p:spPr>
-          <a:xfrm>
-            <a:off x="1188720" y="292608"/>
-            <a:ext cx="10241280" cy="274320"/>
-          </a:xfrm>
-          <a:prstGeom prst="rect">
-            <a:avLst/>
-          </a:prstGeom>
-          <a:noFill/>
-        </p:spPr>
-        <p:txBody>
-          <a:bodyPr wrap="none">
-            <a:spAutoFit/>
-          </a:bodyPr>
-          <a:lstStyle/>
-          <a:p>
-            <a:pPr>
-              <a:defRPr sz="1150" b="1">
-                <a:solidFill>
-                  <a:srgbClr val="3EA6FF"/>
-                </a:solidFill>
-              </a:defRPr>
-            </a:pPr>
-            <a:r>
-              <a:t>GROUP G15  •  PROJECT ID: G15-PID-17 (P-17)  •  EVALUATION-II (PHASE 2)</a:t>
-            </a:r>
-          </a:p>
-        </p:txBody>
-      </p:sp>
-      <p:sp>
-        <p:nvSpPr>
-          <p:cNvPr id="5" name="TextBox 4"/>
-          <p:cNvSpPr txBox="1"/>
-          <p:nvPr/>
-        </p:nvSpPr>
-        <p:spPr>
-          <a:xfrm>
-            <a:off x="731520" y="621792"/>
-            <a:ext cx="10728655" cy="594360"/>
-          </a:xfrm>
-          <a:prstGeom prst="rect">
-            <a:avLst/>
-          </a:prstGeom>
-          <a:noFill/>
-        </p:spPr>
-        <p:txBody>
-          <a:bodyPr wrap="square">
-            <a:spAutoFit/>
-          </a:bodyPr>
-          <a:lstStyle/>
-          <a:p>
-            <a:pPr>
-              <a:defRPr sz="2300" b="1">
-                <a:solidFill>
-                  <a:srgbClr val="FFFFFF"/>
-                </a:solidFill>
-              </a:defRPr>
-            </a:pPr>
-            <a:r>
-              <a:t>Summary, Live Demonstration &amp; Viva Voce Defense</a:t>
-            </a:r>
-          </a:p>
-        </p:txBody>
-      </p:sp>
-      <p:sp>
-        <p:nvSpPr>
-          <p:cNvPr id="6" name="TextBox 5"/>
-          <p:cNvSpPr txBox="1"/>
-          <p:nvPr/>
-        </p:nvSpPr>
-        <p:spPr>
-          <a:xfrm>
-            <a:off x="731520" y="6327648"/>
-            <a:ext cx="10728655" cy="274320"/>
-          </a:xfrm>
-          <a:prstGeom prst="rect">
-            <a:avLst/>
-          </a:prstGeom>
-          <a:noFill/>
-        </p:spPr>
-        <p:txBody>
-          <a:bodyPr wrap="none">
-            <a:spAutoFit/>
-          </a:bodyPr>
-          <a:lstStyle/>
-          <a:p>
-            <a:pPr>
-              <a:defRPr sz="1000">
-                <a:solidFill>
-                  <a:srgbClr val="8C94A5"/>
-                </a:solidFill>
-              </a:defRPr>
-            </a:pPr>
-            <a:r>
-              <a:t>PheW TuBe: Video Streaming Platform (G15-PID-17)  |  Chitkara University FEE-II  |  Page 11</a:t>
-            </a:r>
-          </a:p>
-        </p:txBody>
-      </p:sp>
-      <p:sp>
-        <p:nvSpPr>
-          <p:cNvPr id="7" name="Rounded Rectangle 6"/>
-          <p:cNvSpPr/>
-          <p:nvPr/>
-        </p:nvSpPr>
-        <p:spPr>
-          <a:xfrm>
-            <a:off x="731520" y="1325880"/>
-            <a:ext cx="5212080" cy="4663440"/>
-          </a:xfrm>
-          <a:prstGeom prst="roundRect">
-            <a:avLst/>
-          </a:prstGeom>
-          <a:solidFill>
-            <a:srgbClr val="161922"/>
-          </a:solidFill>
-          <a:ln w="16510">
-            <a:solidFill>
-              <a:srgbClr val="2E3445"/>
-            </a:solidFill>
-          </a:ln>
-        </p:spPr>
-        <p:style>
-          <a:lnRef idx="1">
-            <a:schemeClr val="accent1"/>
-          </a:lnRef>
-          <a:fillRef idx="3">
-            <a:schemeClr val="accent1"/>
-          </a:fillRef>
-          <a:effectRef idx="2">
-            <a:schemeClr val="accent1"/>
-          </a:effectRef>
-          <a:fontRef idx="minor">
-            <a:schemeClr val="lt1"/>
-          </a:fontRef>
-        </p:style>
-        <p:txBody>
-          <a:bodyPr rtlCol="0" anchor="ctr"/>
-          <a:lstStyle/>
-          <a:p>
-            <a:pPr algn="ctr"/>
-          </a:p>
-        </p:txBody>
-      </p:sp>
-      <p:sp>
-        <p:nvSpPr>
-          <p:cNvPr id="8" name="TextBox 7"/>
-          <p:cNvSpPr txBox="1"/>
-          <p:nvPr/>
-        </p:nvSpPr>
-        <p:spPr>
-          <a:xfrm>
-            <a:off x="932688" y="1490472"/>
-            <a:ext cx="4809744" cy="4334255"/>
-          </a:xfrm>
-          <a:prstGeom prst="rect">
-            <a:avLst/>
-          </a:prstGeom>
-          <a:noFill/>
-        </p:spPr>
-        <p:txBody>
-          <a:bodyPr wrap="square" tIns="0" bIns="0" lIns="0" rIns="0">
-            <a:spAutoFit/>
-          </a:bodyPr>
-          <a:lstStyle/>
-          <a:p>
-            <a:pPr>
-              <a:spcAft>
-                <a:spcPts val="1000"/>
-              </a:spcAft>
-              <a:defRPr sz="1350" b="1">
-                <a:solidFill>
-                  <a:srgbClr val="FF0033"/>
-                </a:solidFill>
-              </a:defRPr>
-            </a:pPr>
-            <a:r>
-              <a:t>Viva Defense &amp; 1-Minute Pitch</a:t>
-            </a:r>
-          </a:p>
-          <a:p>
-            <a:pPr>
-              <a:spcAft>
-                <a:spcPts val="800"/>
-              </a:spcAft>
-            </a:pPr>
-            <a:r>
-              <a:rPr sz="1150" b="1">
-                <a:solidFill>
-                  <a:srgbClr val="FFFFFF"/>
-                </a:solidFill>
-              </a:rPr>
-              <a:t>• Viva Title Justification: </a:t>
-            </a:r>
-            <a:r>
-              <a:rPr sz="1150">
-                <a:solidFill>
-                  <a:srgbClr val="CDD2DC"/>
-                </a:solidFill>
-              </a:rPr>
-              <a:t>PheW TuBe represents an ad-free, high-speed streaming platform with 100% in-app media rendering.</a:t>
-            </a:r>
-          </a:p>
-          <a:p>
-            <a:pPr>
-              <a:spcAft>
-                <a:spcPts val="800"/>
-              </a:spcAft>
-            </a:pPr>
-            <a:r>
-              <a:rPr sz="1150" b="1">
-                <a:solidFill>
-                  <a:srgbClr val="FFFFFF"/>
-                </a:solidFill>
-              </a:rPr>
-              <a:t>• Core Gap Solved: </a:t>
-            </a:r>
-            <a:r>
-              <a:rPr sz="1150">
-                <a:solidFill>
-                  <a:srgbClr val="CDD2DC"/>
-                </a:solidFill>
-              </a:rPr>
-              <a:t>Eliminates disruptive external site redirects, offers hands-free Web Speech API search, and provides full YouTube settings.</a:t>
-            </a:r>
-          </a:p>
-          <a:p>
-            <a:pPr>
-              <a:spcAft>
-                <a:spcPts val="800"/>
-              </a:spcAft>
-            </a:pPr>
-            <a:r>
-              <a:rPr sz="1150" b="1">
-                <a:solidFill>
-                  <a:srgbClr val="FFFFFF"/>
-                </a:solidFill>
-              </a:rPr>
-              <a:t>• Target Users: </a:t>
-            </a:r>
-            <a:r>
-              <a:rPr sz="1150">
-                <a:solidFill>
-                  <a:srgbClr val="CDD2DC"/>
-                </a:solidFill>
-              </a:rPr>
-              <a:t>Students, programmers, and tech enthusiasts requiring distraction-free educational video viewing.</a:t>
-            </a:r>
-          </a:p>
-        </p:txBody>
-      </p:sp>
-      <p:sp>
-        <p:nvSpPr>
-          <p:cNvPr id="9" name="Rounded Rectangle 8"/>
-          <p:cNvSpPr/>
-          <p:nvPr/>
-        </p:nvSpPr>
-        <p:spPr>
-          <a:xfrm>
-            <a:off x="6248095" y="1325880"/>
-            <a:ext cx="5212080" cy="4663440"/>
-          </a:xfrm>
-          <a:prstGeom prst="roundRect">
-            <a:avLst/>
-          </a:prstGeom>
-          <a:solidFill>
-            <a:srgbClr val="161922"/>
-          </a:solidFill>
-          <a:ln w="16510">
-            <a:solidFill>
-              <a:srgbClr val="2E3445"/>
-            </a:solidFill>
-          </a:ln>
-        </p:spPr>
-        <p:style>
-          <a:lnRef idx="1">
-            <a:schemeClr val="accent1"/>
-          </a:lnRef>
-          <a:fillRef idx="3">
-            <a:schemeClr val="accent1"/>
-          </a:fillRef>
-          <a:effectRef idx="2">
-            <a:schemeClr val="accent1"/>
-          </a:effectRef>
-          <a:fontRef idx="minor">
-            <a:schemeClr val="lt1"/>
-          </a:fontRef>
-        </p:style>
-        <p:txBody>
-          <a:bodyPr rtlCol="0" anchor="ctr"/>
-          <a:lstStyle/>
-          <a:p>
-            <a:pPr algn="ctr"/>
-          </a:p>
-        </p:txBody>
-      </p:sp>
-      <p:sp>
-        <p:nvSpPr>
-          <p:cNvPr id="10" name="TextBox 9"/>
-          <p:cNvSpPr txBox="1"/>
-          <p:nvPr/>
-        </p:nvSpPr>
-        <p:spPr>
-          <a:xfrm>
-            <a:off x="6449263" y="1490472"/>
-            <a:ext cx="4809744" cy="4334255"/>
-          </a:xfrm>
-          <a:prstGeom prst="rect">
-            <a:avLst/>
-          </a:prstGeom>
-          <a:noFill/>
-        </p:spPr>
-        <p:txBody>
-          <a:bodyPr wrap="square" tIns="0" bIns="0" lIns="0" rIns="0">
-            <a:spAutoFit/>
-          </a:bodyPr>
-          <a:lstStyle/>
-          <a:p>
-            <a:pPr>
-              <a:spcAft>
-                <a:spcPts val="1000"/>
-              </a:spcAft>
-              <a:defRPr sz="1350" b="1">
-                <a:solidFill>
-                  <a:srgbClr val="3EA6FF"/>
-                </a:solidFill>
-              </a:defRPr>
-            </a:pPr>
-            <a:r>
-              <a:t>Technical Merit &amp; Demonstration Roadmap</a:t>
-            </a:r>
-          </a:p>
-          <a:p>
-            <a:pPr>
-              <a:spcAft>
-                <a:spcPts val="800"/>
-              </a:spcAft>
-            </a:pPr>
-            <a:r>
-              <a:rPr sz="1150" b="1">
-                <a:solidFill>
-                  <a:srgbClr val="FFFFFF"/>
-                </a:solidFill>
-              </a:rPr>
-              <a:t>• Key Engineering Highlight: </a:t>
-            </a:r>
-            <a:r>
-              <a:rPr sz="1150">
-                <a:solidFill>
-                  <a:srgbClr val="CDD2DC"/>
-                </a:solidFill>
-              </a:rPr>
-              <a:t>React 18 component composition + Context API eliminating full-tree re-renders.</a:t>
-            </a:r>
-          </a:p>
-          <a:p>
-            <a:pPr>
-              <a:spcAft>
-                <a:spcPts val="800"/>
-              </a:spcAft>
-            </a:pPr>
-            <a:r>
-              <a:rPr sz="1150" b="1">
-                <a:solidFill>
-                  <a:srgbClr val="FFFFFF"/>
-                </a:solidFill>
-              </a:rPr>
-              <a:t>• Live Demonstration Flow: </a:t>
-            </a:r>
-            <a:r>
-              <a:rPr sz="1150">
-                <a:solidFill>
-                  <a:srgbClr val="CDD2DC"/>
-                </a:solidFill>
-              </a:rPr>
-              <a:t>1) Home feed &amp; Infinite Scroll -&gt; 2) Voice Search &amp; Filter -&gt; 3) In-Site Watch Player &amp; Likes -&gt; 4) Protected Route Lock -&gt; 5) Settings Modal.</a:t>
-            </a:r>
-          </a:p>
-          <a:p>
-            <a:pPr>
-              <a:spcAft>
-                <a:spcPts val="800"/>
-              </a:spcAft>
-            </a:pPr>
-            <a:r>
-              <a:rPr sz="1150" b="1">
-                <a:solidFill>
-                  <a:srgbClr val="FFFFFF"/>
-                </a:solidFill>
-              </a:rPr>
-              <a:t>• Evaluation Status: </a:t>
-            </a:r>
-            <a:r>
-              <a:rPr sz="1150">
-                <a:solidFill>
-                  <a:srgbClr val="CDD2DC"/>
-                </a:solidFill>
-              </a:rPr>
-              <a:t>100% feature-complete, zero console errors, passing Vite production build in 1.16s.</a:t>
-            </a:r>
-          </a:p>
-        </p:txBody>
-      </p:sp>
-    </p:spTree>
-  </p:cSld>
-  <p:clrMapOvr>
-    <a:masterClrMapping/>
-  </p:clrMapOvr>
-  <p:transition spd="fast">
-    <p:push dir="l"/>
-  </p:transition>
-</p:sld>
-</file>
-
-<file path=ppt/slides/slide12.xml><?xml version="1.0" encoding="utf-8"?>
-<p:sld xmlns:a="http://schemas.openxmlformats.org/drawingml/2006/main" xmlns:p="http://schemas.openxmlformats.org/presentationml/2006/main" xmlns:r="http://schemas.openxmlformats.org/officeDocument/2006/relationships">
-  <p:cSld>
-    <p:spTree>
-      <p:nvGrpSpPr>
-        <p:cNvPr id="1" name=""/>
-        <p:cNvGrpSpPr/>
-        <p:nvPr/>
-      </p:nvGrpSpPr>
-      <p:grpSpPr/>
-      <p:sp>
-        <p:nvSpPr>
-          <p:cNvPr id="2" name="Rectangle 1"/>
-          <p:cNvSpPr/>
-          <p:nvPr/>
-        </p:nvSpPr>
-        <p:spPr>
-          <a:xfrm>
-            <a:off x="0" y="0"/>
-            <a:ext cx="12191695" cy="6858000"/>
-          </a:xfrm>
-          <a:prstGeom prst="rect">
-            <a:avLst/>
-          </a:prstGeom>
-          <a:solidFill>
-            <a:srgbClr val="0B0C10"/>
-          </a:solidFill>
-          <a:ln>
-            <a:noFill/>
-          </a:ln>
-        </p:spPr>
-        <p:style>
-          <a:lnRef idx="1">
-            <a:schemeClr val="accent1"/>
-          </a:lnRef>
-          <a:fillRef idx="3">
-            <a:schemeClr val="accent1"/>
-          </a:fillRef>
-          <a:effectRef idx="2">
-            <a:schemeClr val="accent1"/>
-          </a:effectRef>
-          <a:fontRef idx="minor">
-            <a:schemeClr val="lt1"/>
-          </a:fontRef>
-        </p:style>
-        <p:txBody>
-          <a:bodyPr rtlCol="0" anchor="ctr"/>
-          <a:lstStyle/>
-          <a:p>
-            <a:pPr algn="ctr"/>
-          </a:p>
-        </p:txBody>
-      </p:sp>
-      <p:sp>
-        <p:nvSpPr>
           <p:cNvPr id="3" name="Rounded Rectangle 2"/>
           <p:cNvSpPr/>
           <p:nvPr/>
@@ -7782,7 +7265,7 @@
       </p:sp>
       <p:pic>
         <p:nvPicPr>
-          <p:cNvPr id="8" name="Picture 7" descr="feat_watch_player.png"/>
+          <p:cNvPr id="8" name="Picture 7" descr="video_playing_live.png"/>
           <p:cNvPicPr>
             <a:picLocks noChangeAspect="1"/>
           </p:cNvPicPr>
@@ -7796,8 +7279,8 @@
         </p:blipFill>
         <p:spPr>
           <a:xfrm>
-            <a:off x="868680" y="1508760"/>
-            <a:ext cx="5029200" cy="3143250"/>
+            <a:off x="868680" y="2514600"/>
+            <a:ext cx="5029200" cy="2146250"/>
           </a:xfrm>
           <a:prstGeom prst="rect">
             <a:avLst/>
@@ -8261,7 +7744,7 @@
       </p:sp>
       <p:pic>
         <p:nvPicPr>
-          <p:cNvPr id="8" name="Picture 7" descr="ui_search_clean.png"/>
+          <p:cNvPr id="8" name="Picture 7" descr="speech_search_glowing.png"/>
           <p:cNvPicPr>
             <a:picLocks noChangeAspect="1"/>
           </p:cNvPicPr>
@@ -8275,8 +7758,8 @@
         </p:blipFill>
         <p:spPr>
           <a:xfrm>
-            <a:off x="868680" y="1508760"/>
-            <a:ext cx="5029200" cy="4701209"/>
+            <a:off x="868680" y="2606040"/>
+            <a:ext cx="5029200" cy="1866305"/>
           </a:xfrm>
           <a:prstGeom prst="rect">
             <a:avLst/>

</xml_diff>

<commit_message>
Add dedicated responsiveness slide with iPad Pro DevTools screenshot, total 12 slides
</commit_message>
<xml_diff>
--- a/G15-PID-17.pptx
+++ b/G15-PID-17.pptx
@@ -16,6 +16,7 @@
     <p:sldId id="264" r:id="rId15"/>
     <p:sldId id="265" r:id="rId16"/>
     <p:sldId id="266" r:id="rId17"/>
+    <p:sldId id="267" r:id="rId18"/>
   </p:sldIdLst>
   <p:sldSz cx="12191695" cy="6858000" type="screen4x3"/>
   <p:notesSz cx="6858000" cy="9144000"/>
@@ -3633,7 +3634,7 @@
               </a:defRPr>
             </a:pPr>
             <a:r>
-              <a:t>Multi-Device Responsive Design &amp; Modern UI/UX Layer</a:t>
+              <a:t>Modern UI/UX Architecture &amp; Visual Design Systems</a:t>
             </a:r>
           </a:p>
         </p:txBody>
@@ -3751,7 +3752,7 @@
               </a:defRPr>
             </a:pPr>
             <a:r>
-              <a:t>Viewport Adaptations &amp; Layout Hierarchy</a:t>
+              <a:t>Design Systems &amp; Token Architecture</a:t>
             </a:r>
           </a:p>
           <a:p>
@@ -3766,7 +3767,7 @@
                   <a:srgbClr val="FFFFFF"/>
                 </a:solidFill>
               </a:rPr>
-              <a:t>• Desktop (1440px+): </a:t>
+              <a:t>• Obsidian Dark Theme: </a:t>
             </a:r>
             <a:r>
               <a:rPr sz="1150">
@@ -3774,7 +3775,7 @@
                   <a:srgbClr val="CDD2DC"/>
                 </a:solidFill>
               </a:rPr>
-              <a:t>Full widescreen layout with expanded 240px sidebar, 4-column video feed, and watch player with up-next rail.</a:t>
+              <a:t>Deep obsidian canvas (#0B0C10) paired with frosted slate cards (#161922) and high-contrast borders (#2E3445).</a:t>
             </a:r>
           </a:p>
           <a:p>
@@ -3789,7 +3790,7 @@
                   <a:srgbClr val="FFFFFF"/>
                 </a:solidFill>
               </a:rPr>
-              <a:t>• Tablet / iPad Mini (1024px &amp; 768px): </a:t>
+              <a:t>• Dynamic CSS Variables: </a:t>
             </a:r>
             <a:r>
               <a:rPr sz="1150">
@@ -3797,7 +3798,7 @@
                   <a:srgbClr val="CDD2DC"/>
                 </a:solidFill>
               </a:rPr>
-              <a:t>Compact collapsed mini-rail sidebar with 2-3 column responsive video card grid.</a:t>
+              <a:t>Centralized theme design tokens in index.css allow instantaneous toggle between Dark and Light mode themes.</a:t>
             </a:r>
           </a:p>
           <a:p>
@@ -3812,7 +3813,7 @@
                   <a:srgbClr val="FFFFFF"/>
                 </a:solidFill>
               </a:rPr>
-              <a:t>• Mobile (375px - 480px): </a:t>
+              <a:t>• YouTube Typography &amp; Scale: </a:t>
             </a:r>
             <a:r>
               <a:rPr sz="1150">
@@ -3820,7 +3821,30 @@
                   <a:srgbClr val="CDD2DC"/>
                 </a:solidFill>
               </a:rPr>
-              <a:t>Single-column video stream with bottom drawer navigation and touch-optimized action targets.</a:t>
+              <a:t>Strict typography scaling with bold headings, muted metadata, and official YouTube iconography.</a:t>
+            </a:r>
+          </a:p>
+          <a:p>
+            <a:pPr>
+              <a:spcAft>
+                <a:spcPts val="800"/>
+              </a:spcAft>
+            </a:pPr>
+            <a:r>
+              <a:rPr sz="1150" b="1">
+                <a:solidFill>
+                  <a:srgbClr val="FFFFFF"/>
+                </a:solidFill>
+              </a:rPr>
+              <a:t>• Category Pill Badges: </a:t>
+            </a:r>
+            <a:r>
+              <a:rPr sz="1150">
+                <a:solidFill>
+                  <a:srgbClr val="CDD2DC"/>
+                </a:solidFill>
+              </a:rPr>
+              <a:t>High-contrast pill filters with smooth horizontal scroll and active state indicators.</a:t>
             </a:r>
           </a:p>
         </p:txBody>
@@ -3903,7 +3927,7 @@
               </a:defRPr>
             </a:pPr>
             <a:r>
-              <a:t>Design Systems &amp; Visual Feedback</a:t>
+              <a:t>Micro-Interactions &amp; Modal Feedback</a:t>
             </a:r>
           </a:p>
           <a:p>
@@ -3918,7 +3942,7 @@
                   <a:srgbClr val="FFFFFF"/>
                 </a:solidFill>
               </a:rPr>
-              <a:t>• Tailwind Fluid Breakpoints: </a:t>
+              <a:t>• Glassmorphic Modals: </a:t>
             </a:r>
             <a:r>
               <a:rPr sz="1150">
@@ -3926,7 +3950,7 @@
                   <a:srgbClr val="CDD2DC"/>
                 </a:solidFill>
               </a:rPr>
-              <a:t>Standardized responsive classes (sm, md, lg, xl) ensuring zero horizontal scrollbars.</a:t>
+              <a:t>High-z-index overlays with backdrop-filter: blur(8px) for Auth and Settings modals.</a:t>
             </a:r>
           </a:p>
           <a:p>
@@ -3941,7 +3965,7 @@
                   <a:srgbClr val="FFFFFF"/>
                 </a:solidFill>
               </a:rPr>
-              <a:t>• Glassmorphic Modals: </a:t>
+              <a:t>• Active Scale Physics: </a:t>
             </a:r>
             <a:r>
               <a:rPr sz="1150">
@@ -3949,7 +3973,7 @@
                   <a:srgbClr val="CDD2DC"/>
                 </a:solidFill>
               </a:rPr>
-              <a:t>High-z-index overlays with backdrop-filter: blur(8px) for Auth and Settings modals.</a:t>
+              <a:t>Micro-interactions with active scale-down on click, hover elevations, and soundwave pulse feedback.</a:t>
             </a:r>
           </a:p>
           <a:p>
@@ -3964,7 +3988,7 @@
                   <a:srgbClr val="FFFFFF"/>
                 </a:solidFill>
               </a:rPr>
-              <a:t>• Micro-Interactions: </a:t>
+              <a:t>• Optimistic State Commits: </a:t>
             </a:r>
             <a:r>
               <a:rPr sz="1150">
@@ -3972,7 +3996,30 @@
                   <a:srgbClr val="CDD2DC"/>
                 </a:solidFill>
               </a:rPr>
-              <a:t>Active scale animations, soundwave mic pulse, and hover elevations across all interactive cards.</a:t>
+              <a:t>Instant UI reaction on Like and Watch Later toggles before asynchronous persistence.</a:t>
+            </a:r>
+          </a:p>
+          <a:p>
+            <a:pPr>
+              <a:spcAft>
+                <a:spcPts val="800"/>
+              </a:spcAft>
+            </a:pPr>
+            <a:r>
+              <a:rPr sz="1150" b="1">
+                <a:solidFill>
+                  <a:srgbClr val="FFFFFF"/>
+                </a:solidFill>
+              </a:rPr>
+              <a:t>• Accessible Form Controls: </a:t>
+            </a:r>
+            <a:r>
+              <a:rPr sz="1150">
+                <a:solidFill>
+                  <a:srgbClr val="CDD2DC"/>
+                </a:solidFill>
+              </a:rPr>
+              <a:t>High-visibility focus rings, inline password visibility toggles, and screen-reader compliant aria tags.</a:t>
             </a:r>
           </a:p>
         </p:txBody>
@@ -3989,6 +4036,508 @@
 </file>
 
 <file path=ppt/slides/slide11.xml><?xml version="1.0" encoding="utf-8"?>
+<p:sld xmlns:a="http://schemas.openxmlformats.org/drawingml/2006/main" xmlns:p="http://schemas.openxmlformats.org/presentationml/2006/main" xmlns:r="http://schemas.openxmlformats.org/officeDocument/2006/relationships">
+  <p:cSld>
+    <p:spTree>
+      <p:nvGrpSpPr>
+        <p:cNvPr id="1" name=""/>
+        <p:cNvGrpSpPr/>
+        <p:nvPr/>
+      </p:nvGrpSpPr>
+      <p:grpSpPr/>
+      <p:sp>
+        <p:nvSpPr>
+          <p:cNvPr id="2" name="Rectangle 1"/>
+          <p:cNvSpPr/>
+          <p:nvPr/>
+        </p:nvSpPr>
+        <p:spPr>
+          <a:xfrm>
+            <a:off x="0" y="0"/>
+            <a:ext cx="12191695" cy="6858000"/>
+          </a:xfrm>
+          <a:prstGeom prst="rect">
+            <a:avLst/>
+          </a:prstGeom>
+          <a:solidFill>
+            <a:srgbClr val="0B0C10"/>
+          </a:solidFill>
+          <a:ln>
+            <a:noFill/>
+          </a:ln>
+        </p:spPr>
+        <p:style>
+          <a:lnRef idx="1">
+            <a:schemeClr val="accent1"/>
+          </a:lnRef>
+          <a:fillRef idx="3">
+            <a:schemeClr val="accent1"/>
+          </a:fillRef>
+          <a:effectRef idx="2">
+            <a:schemeClr val="accent1"/>
+          </a:effectRef>
+          <a:fontRef idx="minor">
+            <a:schemeClr val="lt1"/>
+          </a:fontRef>
+        </p:style>
+        <p:txBody>
+          <a:bodyPr rtlCol="0" anchor="ctr"/>
+          <a:lstStyle/>
+          <a:p>
+            <a:pPr algn="ctr"/>
+          </a:p>
+        </p:txBody>
+      </p:sp>
+      <p:sp>
+        <p:nvSpPr>
+          <p:cNvPr id="3" name="Rectangle 2"/>
+          <p:cNvSpPr/>
+          <p:nvPr/>
+        </p:nvSpPr>
+        <p:spPr>
+          <a:xfrm>
+            <a:off x="731520" y="365760"/>
+            <a:ext cx="365760" cy="54864"/>
+          </a:xfrm>
+          <a:prstGeom prst="rect">
+            <a:avLst/>
+          </a:prstGeom>
+          <a:solidFill>
+            <a:srgbClr val="FF0033"/>
+          </a:solidFill>
+          <a:ln>
+            <a:noFill/>
+          </a:ln>
+        </p:spPr>
+        <p:style>
+          <a:lnRef idx="1">
+            <a:schemeClr val="accent1"/>
+          </a:lnRef>
+          <a:fillRef idx="3">
+            <a:schemeClr val="accent1"/>
+          </a:fillRef>
+          <a:effectRef idx="2">
+            <a:schemeClr val="accent1"/>
+          </a:effectRef>
+          <a:fontRef idx="minor">
+            <a:schemeClr val="lt1"/>
+          </a:fontRef>
+        </p:style>
+        <p:txBody>
+          <a:bodyPr rtlCol="0" anchor="ctr"/>
+          <a:lstStyle/>
+          <a:p>
+            <a:pPr algn="ctr"/>
+          </a:p>
+        </p:txBody>
+      </p:sp>
+      <p:sp>
+        <p:nvSpPr>
+          <p:cNvPr id="4" name="TextBox 3"/>
+          <p:cNvSpPr txBox="1"/>
+          <p:nvPr/>
+        </p:nvSpPr>
+        <p:spPr>
+          <a:xfrm>
+            <a:off x="1188720" y="292608"/>
+            <a:ext cx="10241280" cy="274320"/>
+          </a:xfrm>
+          <a:prstGeom prst="rect">
+            <a:avLst/>
+          </a:prstGeom>
+          <a:noFill/>
+        </p:spPr>
+        <p:txBody>
+          <a:bodyPr wrap="none">
+            <a:spAutoFit/>
+          </a:bodyPr>
+          <a:lstStyle/>
+          <a:p>
+            <a:pPr>
+              <a:defRPr sz="1150" b="1">
+                <a:solidFill>
+                  <a:srgbClr val="3EA6FF"/>
+                </a:solidFill>
+              </a:defRPr>
+            </a:pPr>
+            <a:r>
+              <a:t>GROUP G15  •  PROJECT ID: G15-PID-17 (P-17)  •  EVALUATION-II (PHASE 2)</a:t>
+            </a:r>
+          </a:p>
+        </p:txBody>
+      </p:sp>
+      <p:sp>
+        <p:nvSpPr>
+          <p:cNvPr id="5" name="TextBox 4"/>
+          <p:cNvSpPr txBox="1"/>
+          <p:nvPr/>
+        </p:nvSpPr>
+        <p:spPr>
+          <a:xfrm>
+            <a:off x="731520" y="621792"/>
+            <a:ext cx="10728655" cy="594360"/>
+          </a:xfrm>
+          <a:prstGeom prst="rect">
+            <a:avLst/>
+          </a:prstGeom>
+          <a:noFill/>
+        </p:spPr>
+        <p:txBody>
+          <a:bodyPr wrap="square">
+            <a:spAutoFit/>
+          </a:bodyPr>
+          <a:lstStyle/>
+          <a:p>
+            <a:pPr>
+              <a:defRPr sz="2300" b="1">
+                <a:solidFill>
+                  <a:srgbClr val="FFFFFF"/>
+                </a:solidFill>
+              </a:defRPr>
+            </a:pPr>
+            <a:r>
+              <a:t>Multi-Device Responsive Design &amp; Viewport Audit</a:t>
+            </a:r>
+          </a:p>
+        </p:txBody>
+      </p:sp>
+      <p:sp>
+        <p:nvSpPr>
+          <p:cNvPr id="6" name="TextBox 5"/>
+          <p:cNvSpPr txBox="1"/>
+          <p:nvPr/>
+        </p:nvSpPr>
+        <p:spPr>
+          <a:xfrm>
+            <a:off x="731520" y="6327648"/>
+            <a:ext cx="10728655" cy="274320"/>
+          </a:xfrm>
+          <a:prstGeom prst="rect">
+            <a:avLst/>
+          </a:prstGeom>
+          <a:noFill/>
+        </p:spPr>
+        <p:txBody>
+          <a:bodyPr wrap="none">
+            <a:spAutoFit/>
+          </a:bodyPr>
+          <a:lstStyle/>
+          <a:p>
+            <a:pPr>
+              <a:defRPr sz="1000">
+                <a:solidFill>
+                  <a:srgbClr val="8C94A5"/>
+                </a:solidFill>
+              </a:defRPr>
+            </a:pPr>
+            <a:r>
+              <a:t>PheW TuBe: Video Streaming Platform (G15-PID-17)  |  Chitkara University FEE-II  |  Page 11</a:t>
+            </a:r>
+          </a:p>
+        </p:txBody>
+      </p:sp>
+      <p:sp>
+        <p:nvSpPr>
+          <p:cNvPr id="7" name="Rounded Rectangle 6"/>
+          <p:cNvSpPr/>
+          <p:nvPr/>
+        </p:nvSpPr>
+        <p:spPr>
+          <a:xfrm>
+            <a:off x="731520" y="1325880"/>
+            <a:ext cx="5303520" cy="4663440"/>
+          </a:xfrm>
+          <a:prstGeom prst="roundRect">
+            <a:avLst/>
+          </a:prstGeom>
+          <a:solidFill>
+            <a:srgbClr val="161922"/>
+          </a:solidFill>
+          <a:ln w="16510">
+            <a:solidFill>
+              <a:srgbClr val="2E3445"/>
+            </a:solidFill>
+          </a:ln>
+        </p:spPr>
+        <p:style>
+          <a:lnRef idx="1">
+            <a:schemeClr val="accent1"/>
+          </a:lnRef>
+          <a:fillRef idx="3">
+            <a:schemeClr val="accent1"/>
+          </a:fillRef>
+          <a:effectRef idx="2">
+            <a:schemeClr val="accent1"/>
+          </a:effectRef>
+          <a:fontRef idx="minor">
+            <a:schemeClr val="lt1"/>
+          </a:fontRef>
+        </p:style>
+        <p:txBody>
+          <a:bodyPr rtlCol="0" anchor="ctr"/>
+          <a:lstStyle/>
+          <a:p>
+            <a:pPr algn="ctr"/>
+          </a:p>
+        </p:txBody>
+      </p:sp>
+      <p:pic>
+        <p:nvPicPr>
+          <p:cNvPr id="8" name="Picture 7" descr="responsive_ipad.png"/>
+          <p:cNvPicPr>
+            <a:picLocks noChangeAspect="1"/>
+          </p:cNvPicPr>
+          <p:nvPr/>
+        </p:nvPicPr>
+        <p:blipFill>
+          <a:blip r:embed="rId2"/>
+          <a:stretch>
+            <a:fillRect/>
+          </a:stretch>
+        </p:blipFill>
+        <p:spPr>
+          <a:xfrm>
+            <a:off x="932688" y="1508760"/>
+            <a:ext cx="4895115" cy="4297680"/>
+          </a:xfrm>
+          <a:prstGeom prst="rect">
+            <a:avLst/>
+          </a:prstGeom>
+        </p:spPr>
+      </p:pic>
+      <p:sp>
+        <p:nvSpPr>
+          <p:cNvPr id="9" name="Rounded Rectangle 8"/>
+          <p:cNvSpPr/>
+          <p:nvPr/>
+        </p:nvSpPr>
+        <p:spPr>
+          <a:xfrm>
+            <a:off x="6248095" y="1325880"/>
+            <a:ext cx="5212080" cy="4663440"/>
+          </a:xfrm>
+          <a:prstGeom prst="roundRect">
+            <a:avLst/>
+          </a:prstGeom>
+          <a:solidFill>
+            <a:srgbClr val="161922"/>
+          </a:solidFill>
+          <a:ln w="16510">
+            <a:solidFill>
+              <a:srgbClr val="2E3445"/>
+            </a:solidFill>
+          </a:ln>
+        </p:spPr>
+        <p:style>
+          <a:lnRef idx="1">
+            <a:schemeClr val="accent1"/>
+          </a:lnRef>
+          <a:fillRef idx="3">
+            <a:schemeClr val="accent1"/>
+          </a:fillRef>
+          <a:effectRef idx="2">
+            <a:schemeClr val="accent1"/>
+          </a:effectRef>
+          <a:fontRef idx="minor">
+            <a:schemeClr val="lt1"/>
+          </a:fontRef>
+        </p:style>
+        <p:txBody>
+          <a:bodyPr rtlCol="0" anchor="ctr"/>
+          <a:lstStyle/>
+          <a:p>
+            <a:pPr algn="ctr"/>
+          </a:p>
+        </p:txBody>
+      </p:sp>
+      <p:sp>
+        <p:nvSpPr>
+          <p:cNvPr id="10" name="TextBox 9"/>
+          <p:cNvSpPr txBox="1"/>
+          <p:nvPr/>
+        </p:nvSpPr>
+        <p:spPr>
+          <a:xfrm>
+            <a:off x="6449263" y="1490472"/>
+            <a:ext cx="4809744" cy="4334255"/>
+          </a:xfrm>
+          <a:prstGeom prst="rect">
+            <a:avLst/>
+          </a:prstGeom>
+          <a:noFill/>
+        </p:spPr>
+        <p:txBody>
+          <a:bodyPr wrap="square" tIns="0" bIns="0" lIns="0" rIns="0">
+            <a:spAutoFit/>
+          </a:bodyPr>
+          <a:lstStyle/>
+          <a:p>
+            <a:pPr>
+              <a:spcAft>
+                <a:spcPts val="1000"/>
+              </a:spcAft>
+              <a:defRPr sz="1250" b="1">
+                <a:solidFill>
+                  <a:srgbClr val="3EA6FF"/>
+                </a:solidFill>
+              </a:defRPr>
+            </a:pPr>
+            <a:r>
+              <a:t>Responsive Viewport Adaptations</a:t>
+            </a:r>
+          </a:p>
+          <a:p>
+            <a:pPr>
+              <a:spcAft>
+                <a:spcPts val="800"/>
+              </a:spcAft>
+            </a:pPr>
+            <a:r>
+              <a:rPr sz="1050" b="1">
+                <a:solidFill>
+                  <a:srgbClr val="FFFFFF"/>
+                </a:solidFill>
+              </a:rPr>
+              <a:t>• Tablet / iPad Pro (1032 x 1376px): </a:t>
+            </a:r>
+            <a:r>
+              <a:rPr sz="1050">
+                <a:solidFill>
+                  <a:srgbClr val="CDD2DC"/>
+                </a:solidFill>
+              </a:rPr>
+              <a:t>Fluid 2-column video card grid dynamically adapting from desktop 4-column feed with zero clipping.</a:t>
+            </a:r>
+          </a:p>
+          <a:p>
+            <a:pPr>
+              <a:spcAft>
+                <a:spcPts val="800"/>
+              </a:spcAft>
+            </a:pPr>
+            <a:r>
+              <a:rPr sz="1050" b="1">
+                <a:solidFill>
+                  <a:srgbClr val="FFFFFF"/>
+                </a:solidFill>
+              </a:rPr>
+              <a:t>• Collapsed Mini-Rail Sidebar: </a:t>
+            </a:r>
+            <a:r>
+              <a:rPr sz="1050">
+                <a:solidFill>
+                  <a:srgbClr val="CDD2DC"/>
+                </a:solidFill>
+              </a:rPr>
+              <a:t>Maximizes content viewport area on tablet devices by shrinking 240px sidebar into compact icon rail.</a:t>
+            </a:r>
+          </a:p>
+          <a:p>
+            <a:pPr>
+              <a:spcAft>
+                <a:spcPts val="800"/>
+              </a:spcAft>
+            </a:pPr>
+            <a:r>
+              <a:rPr sz="1050" b="1">
+                <a:solidFill>
+                  <a:srgbClr val="FFFFFF"/>
+                </a:solidFill>
+              </a:rPr>
+              <a:t>• Desktop Viewport (1440px+): </a:t>
+            </a:r>
+            <a:r>
+              <a:rPr sz="1050">
+                <a:solidFill>
+                  <a:srgbClr val="CDD2DC"/>
+                </a:solidFill>
+              </a:rPr>
+              <a:t>Expansive widescreen layout with full drawer sidebar, 4-column grid, and dedicated Up-Next rail.</a:t>
+            </a:r>
+          </a:p>
+          <a:p>
+            <a:pPr>
+              <a:spcAft>
+                <a:spcPts val="800"/>
+              </a:spcAft>
+            </a:pPr>
+            <a:r>
+              <a:rPr sz="1050" b="1">
+                <a:solidFill>
+                  <a:srgbClr val="FFFFFF"/>
+                </a:solidFill>
+              </a:rPr>
+              <a:t>• Mobile Viewport (375px - 480px): </a:t>
+            </a:r>
+            <a:r>
+              <a:rPr sz="1050">
+                <a:solidFill>
+                  <a:srgbClr val="CDD2DC"/>
+                </a:solidFill>
+              </a:rPr>
+              <a:t>Single-column video stream with bottom drawer navigation and touch-optimized controls.</a:t>
+            </a:r>
+          </a:p>
+          <a:p>
+            <a:pPr>
+              <a:spcAft>
+                <a:spcPts val="800"/>
+              </a:spcAft>
+            </a:pPr>
+            <a:r>
+              <a:rPr sz="1050" b="1">
+                <a:solidFill>
+                  <a:srgbClr val="FFFFFF"/>
+                </a:solidFill>
+              </a:rPr>
+              <a:t>• Tailwind Breakpoint Matrix: </a:t>
+            </a:r>
+            <a:r>
+              <a:rPr sz="1050">
+                <a:solidFill>
+                  <a:srgbClr val="CDD2DC"/>
+                </a:solidFill>
+              </a:rPr>
+              <a:t>Uses strict responsive utility classes (sm, md, lg, xl, 2xl) eliminating horizontal scrollbars.</a:t>
+            </a:r>
+          </a:p>
+          <a:p>
+            <a:pPr>
+              <a:spcAft>
+                <a:spcPts val="800"/>
+              </a:spcAft>
+            </a:pPr>
+            <a:r>
+              <a:rPr sz="1050" b="1">
+                <a:solidFill>
+                  <a:srgbClr val="FFFFFF"/>
+                </a:solidFill>
+              </a:rPr>
+              <a:t>• DevTools Emulation Audit: </a:t>
+            </a:r>
+            <a:r>
+              <a:rPr sz="1050">
+                <a:solidFill>
+                  <a:srgbClr val="CDD2DC"/>
+                </a:solidFill>
+              </a:rPr>
+              <a:t>Verified and tested across iPad Pro, iPad Mini, and iPhone viewports via Chrome DevTools.</a:t>
+            </a:r>
+          </a:p>
+        </p:txBody>
+      </p:sp>
+    </p:spTree>
+  </p:cSld>
+  <p:clrMapOvr>
+    <a:masterClrMapping/>
+  </p:clrMapOvr>
+  <p:transition spd="fast">
+    <p:push dir="l"/>
+  </p:transition>
+</p:sld>
+</file>
+
+<file path=ppt/slides/slide12.xml><?xml version="1.0" encoding="utf-8"?>
 <p:sld xmlns:a="http://schemas.openxmlformats.org/drawingml/2006/main" xmlns:p="http://schemas.openxmlformats.org/presentationml/2006/main" xmlns:r="http://schemas.openxmlformats.org/officeDocument/2006/relationships">
   <p:cSld>
     <p:spTree>

</xml_diff>

<commit_message>
Remove Modern UI/UX Architecture slide, renumber deck to 11 slides and update TOC
</commit_message>
<xml_diff>
--- a/G15-PID-17.pptx
+++ b/G15-PID-17.pptx
@@ -16,7 +16,6 @@
     <p:sldId id="264" r:id="rId15"/>
     <p:sldId id="265" r:id="rId16"/>
     <p:sldId id="266" r:id="rId17"/>
-    <p:sldId id="267" r:id="rId18"/>
   </p:sldIdLst>
   <p:sldSz cx="12191695" cy="6858000" type="screen4x3"/>
   <p:notesSz cx="6858000" cy="9144000"/>
@@ -3634,7 +3633,7 @@
               </a:defRPr>
             </a:pPr>
             <a:r>
-              <a:t>Modern UI/UX Architecture &amp; Visual Design Systems</a:t>
+              <a:t>Multi-Device Responsive Design &amp; Viewport Audit</a:t>
             </a:r>
           </a:p>
         </p:txBody>
@@ -3683,7 +3682,7 @@
         <p:spPr>
           <a:xfrm>
             <a:off x="731520" y="1325880"/>
-            <a:ext cx="5212080" cy="4663440"/>
+            <a:ext cx="5303520" cy="4663440"/>
           </a:xfrm>
           <a:prstGeom prst="roundRect">
             <a:avLst/>
@@ -3719,136 +3718,30 @@
           </a:p>
         </p:txBody>
       </p:sp>
-      <p:sp>
-        <p:nvSpPr>
-          <p:cNvPr id="8" name="TextBox 7"/>
-          <p:cNvSpPr txBox="1"/>
-          <p:nvPr/>
-        </p:nvSpPr>
-        <p:spPr>
-          <a:xfrm>
-            <a:off x="932688" y="1490472"/>
-            <a:ext cx="4809744" cy="4334255"/>
+      <p:pic>
+        <p:nvPicPr>
+          <p:cNvPr id="8" name="Picture 7" descr="responsive_ipad.png"/>
+          <p:cNvPicPr>
+            <a:picLocks noChangeAspect="1"/>
+          </p:cNvPicPr>
+          <p:nvPr/>
+        </p:nvPicPr>
+        <p:blipFill>
+          <a:blip r:embed="rId2"/>
+          <a:stretch>
+            <a:fillRect/>
+          </a:stretch>
+        </p:blipFill>
+        <p:spPr>
+          <a:xfrm>
+            <a:off x="932688" y="1508760"/>
+            <a:ext cx="4895115" cy="4297680"/>
           </a:xfrm>
           <a:prstGeom prst="rect">
             <a:avLst/>
           </a:prstGeom>
-          <a:noFill/>
-        </p:spPr>
-        <p:txBody>
-          <a:bodyPr wrap="square" tIns="0" bIns="0" lIns="0" rIns="0">
-            <a:spAutoFit/>
-          </a:bodyPr>
-          <a:lstStyle/>
-          <a:p>
-            <a:pPr>
-              <a:spcAft>
-                <a:spcPts val="1000"/>
-              </a:spcAft>
-              <a:defRPr sz="1350" b="1">
-                <a:solidFill>
-                  <a:srgbClr val="3EA6FF"/>
-                </a:solidFill>
-              </a:defRPr>
-            </a:pPr>
-            <a:r>
-              <a:t>Design Systems &amp; Token Architecture</a:t>
-            </a:r>
-          </a:p>
-          <a:p>
-            <a:pPr>
-              <a:spcAft>
-                <a:spcPts val="800"/>
-              </a:spcAft>
-            </a:pPr>
-            <a:r>
-              <a:rPr sz="1150" b="1">
-                <a:solidFill>
-                  <a:srgbClr val="FFFFFF"/>
-                </a:solidFill>
-              </a:rPr>
-              <a:t>• Obsidian Dark Theme: </a:t>
-            </a:r>
-            <a:r>
-              <a:rPr sz="1150">
-                <a:solidFill>
-                  <a:srgbClr val="CDD2DC"/>
-                </a:solidFill>
-              </a:rPr>
-              <a:t>Deep obsidian canvas (#0B0C10) paired with frosted slate cards (#161922) and high-contrast borders (#2E3445).</a:t>
-            </a:r>
-          </a:p>
-          <a:p>
-            <a:pPr>
-              <a:spcAft>
-                <a:spcPts val="800"/>
-              </a:spcAft>
-            </a:pPr>
-            <a:r>
-              <a:rPr sz="1150" b="1">
-                <a:solidFill>
-                  <a:srgbClr val="FFFFFF"/>
-                </a:solidFill>
-              </a:rPr>
-              <a:t>• Dynamic CSS Variables: </a:t>
-            </a:r>
-            <a:r>
-              <a:rPr sz="1150">
-                <a:solidFill>
-                  <a:srgbClr val="CDD2DC"/>
-                </a:solidFill>
-              </a:rPr>
-              <a:t>Centralized theme design tokens in index.css allow instantaneous toggle between Dark and Light mode themes.</a:t>
-            </a:r>
-          </a:p>
-          <a:p>
-            <a:pPr>
-              <a:spcAft>
-                <a:spcPts val="800"/>
-              </a:spcAft>
-            </a:pPr>
-            <a:r>
-              <a:rPr sz="1150" b="1">
-                <a:solidFill>
-                  <a:srgbClr val="FFFFFF"/>
-                </a:solidFill>
-              </a:rPr>
-              <a:t>• YouTube Typography &amp; Scale: </a:t>
-            </a:r>
-            <a:r>
-              <a:rPr sz="1150">
-                <a:solidFill>
-                  <a:srgbClr val="CDD2DC"/>
-                </a:solidFill>
-              </a:rPr>
-              <a:t>Strict typography scaling with bold headings, muted metadata, and official YouTube iconography.</a:t>
-            </a:r>
-          </a:p>
-          <a:p>
-            <a:pPr>
-              <a:spcAft>
-                <a:spcPts val="800"/>
-              </a:spcAft>
-            </a:pPr>
-            <a:r>
-              <a:rPr sz="1150" b="1">
-                <a:solidFill>
-                  <a:srgbClr val="FFFFFF"/>
-                </a:solidFill>
-              </a:rPr>
-              <a:t>• Category Pill Badges: </a:t>
-            </a:r>
-            <a:r>
-              <a:rPr sz="1150">
-                <a:solidFill>
-                  <a:srgbClr val="CDD2DC"/>
-                </a:solidFill>
-              </a:rPr>
-              <a:t>High-contrast pill filters with smooth horizontal scroll and active state indicators.</a:t>
-            </a:r>
-          </a:p>
-        </p:txBody>
-      </p:sp>
+        </p:spPr>
+      </p:pic>
       <p:sp>
         <p:nvSpPr>
           <p:cNvPr id="9" name="Rounded Rectangle 8"/>
@@ -3920,14 +3813,14 @@
               <a:spcAft>
                 <a:spcPts val="1000"/>
               </a:spcAft>
-              <a:defRPr sz="1350" b="1">
-                <a:solidFill>
-                  <a:srgbClr val="2BA640"/>
+              <a:defRPr sz="1250" b="1">
+                <a:solidFill>
+                  <a:srgbClr val="3EA6FF"/>
                 </a:solidFill>
               </a:defRPr>
             </a:pPr>
             <a:r>
-              <a:t>Micro-Interactions &amp; Modal Feedback</a:t>
+              <a:t>Responsive Viewport Adaptations</a:t>
             </a:r>
           </a:p>
           <a:p>
@@ -3937,20 +3830,20 @@
               </a:spcAft>
             </a:pPr>
             <a:r>
-              <a:rPr sz="1150" b="1">
+              <a:rPr sz="1050" b="1">
                 <a:solidFill>
                   <a:srgbClr val="FFFFFF"/>
                 </a:solidFill>
               </a:rPr>
-              <a:t>• Glassmorphic Modals: </a:t>
-            </a:r>
-            <a:r>
-              <a:rPr sz="1150">
+              <a:t>• Tablet / iPad Pro (1032 x 1376px): </a:t>
+            </a:r>
+            <a:r>
+              <a:rPr sz="1050">
                 <a:solidFill>
                   <a:srgbClr val="CDD2DC"/>
                 </a:solidFill>
               </a:rPr>
-              <a:t>High-z-index overlays with backdrop-filter: blur(8px) for Auth and Settings modals.</a:t>
+              <a:t>Fluid 2-column video card grid dynamically adapting from desktop 4-column feed with zero clipping.</a:t>
             </a:r>
           </a:p>
           <a:p>
@@ -3960,20 +3853,20 @@
               </a:spcAft>
             </a:pPr>
             <a:r>
-              <a:rPr sz="1150" b="1">
+              <a:rPr sz="1050" b="1">
                 <a:solidFill>
                   <a:srgbClr val="FFFFFF"/>
                 </a:solidFill>
               </a:rPr>
-              <a:t>• Active Scale Physics: </a:t>
-            </a:r>
-            <a:r>
-              <a:rPr sz="1150">
+              <a:t>• Collapsed Mini-Rail Sidebar: </a:t>
+            </a:r>
+            <a:r>
+              <a:rPr sz="1050">
                 <a:solidFill>
                   <a:srgbClr val="CDD2DC"/>
                 </a:solidFill>
               </a:rPr>
-              <a:t>Micro-interactions with active scale-down on click, hover elevations, and soundwave pulse feedback.</a:t>
+              <a:t>Maximizes content viewport area on tablet devices by shrinking 240px sidebar into compact icon rail.</a:t>
             </a:r>
           </a:p>
           <a:p>
@@ -3983,20 +3876,20 @@
               </a:spcAft>
             </a:pPr>
             <a:r>
-              <a:rPr sz="1150" b="1">
+              <a:rPr sz="1050" b="1">
                 <a:solidFill>
                   <a:srgbClr val="FFFFFF"/>
                 </a:solidFill>
               </a:rPr>
-              <a:t>• Optimistic State Commits: </a:t>
-            </a:r>
-            <a:r>
-              <a:rPr sz="1150">
+              <a:t>• Desktop Viewport (1440px+): </a:t>
+            </a:r>
+            <a:r>
+              <a:rPr sz="1050">
                 <a:solidFill>
                   <a:srgbClr val="CDD2DC"/>
                 </a:solidFill>
               </a:rPr>
-              <a:t>Instant UI reaction on Like and Watch Later toggles before asynchronous persistence.</a:t>
+              <a:t>Expansive widescreen layout with full drawer sidebar, 4-column grid, and dedicated Up-Next rail.</a:t>
             </a:r>
           </a:p>
           <a:p>
@@ -4006,20 +3899,66 @@
               </a:spcAft>
             </a:pPr>
             <a:r>
-              <a:rPr sz="1150" b="1">
+              <a:rPr sz="1050" b="1">
                 <a:solidFill>
                   <a:srgbClr val="FFFFFF"/>
                 </a:solidFill>
               </a:rPr>
-              <a:t>• Accessible Form Controls: </a:t>
-            </a:r>
-            <a:r>
-              <a:rPr sz="1150">
+              <a:t>• Mobile Viewport (375px - 480px): </a:t>
+            </a:r>
+            <a:r>
+              <a:rPr sz="1050">
                 <a:solidFill>
                   <a:srgbClr val="CDD2DC"/>
                 </a:solidFill>
               </a:rPr>
-              <a:t>High-visibility focus rings, inline password visibility toggles, and screen-reader compliant aria tags.</a:t>
+              <a:t>Single-column video stream with bottom drawer navigation and touch-optimized controls.</a:t>
+            </a:r>
+          </a:p>
+          <a:p>
+            <a:pPr>
+              <a:spcAft>
+                <a:spcPts val="800"/>
+              </a:spcAft>
+            </a:pPr>
+            <a:r>
+              <a:rPr sz="1050" b="1">
+                <a:solidFill>
+                  <a:srgbClr val="FFFFFF"/>
+                </a:solidFill>
+              </a:rPr>
+              <a:t>• Tailwind Breakpoint Matrix: </a:t>
+            </a:r>
+            <a:r>
+              <a:rPr sz="1050">
+                <a:solidFill>
+                  <a:srgbClr val="CDD2DC"/>
+                </a:solidFill>
+              </a:rPr>
+              <a:t>Uses strict responsive utility classes (sm, md, lg, xl, 2xl) eliminating horizontal scrollbars.</a:t>
+            </a:r>
+          </a:p>
+          <a:p>
+            <a:pPr>
+              <a:spcAft>
+                <a:spcPts val="800"/>
+              </a:spcAft>
+            </a:pPr>
+            <a:r>
+              <a:rPr sz="1050" b="1">
+                <a:solidFill>
+                  <a:srgbClr val="FFFFFF"/>
+                </a:solidFill>
+              </a:rPr>
+              <a:t>• DevTools Emulation Audit: </a:t>
+            </a:r>
+            <a:r>
+              <a:rPr sz="1050">
+                <a:solidFill>
+                  <a:srgbClr val="CDD2DC"/>
+                </a:solidFill>
+              </a:rPr>
+              <a:t>Verified and tested across iPad Pro, iPad Mini, and iPhone viewports via Chrome DevTools.</a:t>
             </a:r>
           </a:p>
         </p:txBody>
@@ -4036,508 +3975,6 @@
 </file>
 
 <file path=ppt/slides/slide11.xml><?xml version="1.0" encoding="utf-8"?>
-<p:sld xmlns:a="http://schemas.openxmlformats.org/drawingml/2006/main" xmlns:p="http://schemas.openxmlformats.org/presentationml/2006/main" xmlns:r="http://schemas.openxmlformats.org/officeDocument/2006/relationships">
-  <p:cSld>
-    <p:spTree>
-      <p:nvGrpSpPr>
-        <p:cNvPr id="1" name=""/>
-        <p:cNvGrpSpPr/>
-        <p:nvPr/>
-      </p:nvGrpSpPr>
-      <p:grpSpPr/>
-      <p:sp>
-        <p:nvSpPr>
-          <p:cNvPr id="2" name="Rectangle 1"/>
-          <p:cNvSpPr/>
-          <p:nvPr/>
-        </p:nvSpPr>
-        <p:spPr>
-          <a:xfrm>
-            <a:off x="0" y="0"/>
-            <a:ext cx="12191695" cy="6858000"/>
-          </a:xfrm>
-          <a:prstGeom prst="rect">
-            <a:avLst/>
-          </a:prstGeom>
-          <a:solidFill>
-            <a:srgbClr val="0B0C10"/>
-          </a:solidFill>
-          <a:ln>
-            <a:noFill/>
-          </a:ln>
-        </p:spPr>
-        <p:style>
-          <a:lnRef idx="1">
-            <a:schemeClr val="accent1"/>
-          </a:lnRef>
-          <a:fillRef idx="3">
-            <a:schemeClr val="accent1"/>
-          </a:fillRef>
-          <a:effectRef idx="2">
-            <a:schemeClr val="accent1"/>
-          </a:effectRef>
-          <a:fontRef idx="minor">
-            <a:schemeClr val="lt1"/>
-          </a:fontRef>
-        </p:style>
-        <p:txBody>
-          <a:bodyPr rtlCol="0" anchor="ctr"/>
-          <a:lstStyle/>
-          <a:p>
-            <a:pPr algn="ctr"/>
-          </a:p>
-        </p:txBody>
-      </p:sp>
-      <p:sp>
-        <p:nvSpPr>
-          <p:cNvPr id="3" name="Rectangle 2"/>
-          <p:cNvSpPr/>
-          <p:nvPr/>
-        </p:nvSpPr>
-        <p:spPr>
-          <a:xfrm>
-            <a:off x="731520" y="365760"/>
-            <a:ext cx="365760" cy="54864"/>
-          </a:xfrm>
-          <a:prstGeom prst="rect">
-            <a:avLst/>
-          </a:prstGeom>
-          <a:solidFill>
-            <a:srgbClr val="FF0033"/>
-          </a:solidFill>
-          <a:ln>
-            <a:noFill/>
-          </a:ln>
-        </p:spPr>
-        <p:style>
-          <a:lnRef idx="1">
-            <a:schemeClr val="accent1"/>
-          </a:lnRef>
-          <a:fillRef idx="3">
-            <a:schemeClr val="accent1"/>
-          </a:fillRef>
-          <a:effectRef idx="2">
-            <a:schemeClr val="accent1"/>
-          </a:effectRef>
-          <a:fontRef idx="minor">
-            <a:schemeClr val="lt1"/>
-          </a:fontRef>
-        </p:style>
-        <p:txBody>
-          <a:bodyPr rtlCol="0" anchor="ctr"/>
-          <a:lstStyle/>
-          <a:p>
-            <a:pPr algn="ctr"/>
-          </a:p>
-        </p:txBody>
-      </p:sp>
-      <p:sp>
-        <p:nvSpPr>
-          <p:cNvPr id="4" name="TextBox 3"/>
-          <p:cNvSpPr txBox="1"/>
-          <p:nvPr/>
-        </p:nvSpPr>
-        <p:spPr>
-          <a:xfrm>
-            <a:off x="1188720" y="292608"/>
-            <a:ext cx="10241280" cy="274320"/>
-          </a:xfrm>
-          <a:prstGeom prst="rect">
-            <a:avLst/>
-          </a:prstGeom>
-          <a:noFill/>
-        </p:spPr>
-        <p:txBody>
-          <a:bodyPr wrap="none">
-            <a:spAutoFit/>
-          </a:bodyPr>
-          <a:lstStyle/>
-          <a:p>
-            <a:pPr>
-              <a:defRPr sz="1150" b="1">
-                <a:solidFill>
-                  <a:srgbClr val="3EA6FF"/>
-                </a:solidFill>
-              </a:defRPr>
-            </a:pPr>
-            <a:r>
-              <a:t>GROUP G15  •  PROJECT ID: G15-PID-17 (P-17)  •  EVALUATION-II (PHASE 2)</a:t>
-            </a:r>
-          </a:p>
-        </p:txBody>
-      </p:sp>
-      <p:sp>
-        <p:nvSpPr>
-          <p:cNvPr id="5" name="TextBox 4"/>
-          <p:cNvSpPr txBox="1"/>
-          <p:nvPr/>
-        </p:nvSpPr>
-        <p:spPr>
-          <a:xfrm>
-            <a:off x="731520" y="621792"/>
-            <a:ext cx="10728655" cy="594360"/>
-          </a:xfrm>
-          <a:prstGeom prst="rect">
-            <a:avLst/>
-          </a:prstGeom>
-          <a:noFill/>
-        </p:spPr>
-        <p:txBody>
-          <a:bodyPr wrap="square">
-            <a:spAutoFit/>
-          </a:bodyPr>
-          <a:lstStyle/>
-          <a:p>
-            <a:pPr>
-              <a:defRPr sz="2300" b="1">
-                <a:solidFill>
-                  <a:srgbClr val="FFFFFF"/>
-                </a:solidFill>
-              </a:defRPr>
-            </a:pPr>
-            <a:r>
-              <a:t>Multi-Device Responsive Design &amp; Viewport Audit</a:t>
-            </a:r>
-          </a:p>
-        </p:txBody>
-      </p:sp>
-      <p:sp>
-        <p:nvSpPr>
-          <p:cNvPr id="6" name="TextBox 5"/>
-          <p:cNvSpPr txBox="1"/>
-          <p:nvPr/>
-        </p:nvSpPr>
-        <p:spPr>
-          <a:xfrm>
-            <a:off x="731520" y="6327648"/>
-            <a:ext cx="10728655" cy="274320"/>
-          </a:xfrm>
-          <a:prstGeom prst="rect">
-            <a:avLst/>
-          </a:prstGeom>
-          <a:noFill/>
-        </p:spPr>
-        <p:txBody>
-          <a:bodyPr wrap="none">
-            <a:spAutoFit/>
-          </a:bodyPr>
-          <a:lstStyle/>
-          <a:p>
-            <a:pPr>
-              <a:defRPr sz="1000">
-                <a:solidFill>
-                  <a:srgbClr val="8C94A5"/>
-                </a:solidFill>
-              </a:defRPr>
-            </a:pPr>
-            <a:r>
-              <a:t>PheW TuBe: Video Streaming Platform (G15-PID-17)  |  Chitkara University FEE-II  |  Page 11</a:t>
-            </a:r>
-          </a:p>
-        </p:txBody>
-      </p:sp>
-      <p:sp>
-        <p:nvSpPr>
-          <p:cNvPr id="7" name="Rounded Rectangle 6"/>
-          <p:cNvSpPr/>
-          <p:nvPr/>
-        </p:nvSpPr>
-        <p:spPr>
-          <a:xfrm>
-            <a:off x="731520" y="1325880"/>
-            <a:ext cx="5303520" cy="4663440"/>
-          </a:xfrm>
-          <a:prstGeom prst="roundRect">
-            <a:avLst/>
-          </a:prstGeom>
-          <a:solidFill>
-            <a:srgbClr val="161922"/>
-          </a:solidFill>
-          <a:ln w="16510">
-            <a:solidFill>
-              <a:srgbClr val="2E3445"/>
-            </a:solidFill>
-          </a:ln>
-        </p:spPr>
-        <p:style>
-          <a:lnRef idx="1">
-            <a:schemeClr val="accent1"/>
-          </a:lnRef>
-          <a:fillRef idx="3">
-            <a:schemeClr val="accent1"/>
-          </a:fillRef>
-          <a:effectRef idx="2">
-            <a:schemeClr val="accent1"/>
-          </a:effectRef>
-          <a:fontRef idx="minor">
-            <a:schemeClr val="lt1"/>
-          </a:fontRef>
-        </p:style>
-        <p:txBody>
-          <a:bodyPr rtlCol="0" anchor="ctr"/>
-          <a:lstStyle/>
-          <a:p>
-            <a:pPr algn="ctr"/>
-          </a:p>
-        </p:txBody>
-      </p:sp>
-      <p:pic>
-        <p:nvPicPr>
-          <p:cNvPr id="8" name="Picture 7" descr="responsive_ipad.png"/>
-          <p:cNvPicPr>
-            <a:picLocks noChangeAspect="1"/>
-          </p:cNvPicPr>
-          <p:nvPr/>
-        </p:nvPicPr>
-        <p:blipFill>
-          <a:blip r:embed="rId2"/>
-          <a:stretch>
-            <a:fillRect/>
-          </a:stretch>
-        </p:blipFill>
-        <p:spPr>
-          <a:xfrm>
-            <a:off x="932688" y="1508760"/>
-            <a:ext cx="4895115" cy="4297680"/>
-          </a:xfrm>
-          <a:prstGeom prst="rect">
-            <a:avLst/>
-          </a:prstGeom>
-        </p:spPr>
-      </p:pic>
-      <p:sp>
-        <p:nvSpPr>
-          <p:cNvPr id="9" name="Rounded Rectangle 8"/>
-          <p:cNvSpPr/>
-          <p:nvPr/>
-        </p:nvSpPr>
-        <p:spPr>
-          <a:xfrm>
-            <a:off x="6248095" y="1325880"/>
-            <a:ext cx="5212080" cy="4663440"/>
-          </a:xfrm>
-          <a:prstGeom prst="roundRect">
-            <a:avLst/>
-          </a:prstGeom>
-          <a:solidFill>
-            <a:srgbClr val="161922"/>
-          </a:solidFill>
-          <a:ln w="16510">
-            <a:solidFill>
-              <a:srgbClr val="2E3445"/>
-            </a:solidFill>
-          </a:ln>
-        </p:spPr>
-        <p:style>
-          <a:lnRef idx="1">
-            <a:schemeClr val="accent1"/>
-          </a:lnRef>
-          <a:fillRef idx="3">
-            <a:schemeClr val="accent1"/>
-          </a:fillRef>
-          <a:effectRef idx="2">
-            <a:schemeClr val="accent1"/>
-          </a:effectRef>
-          <a:fontRef idx="minor">
-            <a:schemeClr val="lt1"/>
-          </a:fontRef>
-        </p:style>
-        <p:txBody>
-          <a:bodyPr rtlCol="0" anchor="ctr"/>
-          <a:lstStyle/>
-          <a:p>
-            <a:pPr algn="ctr"/>
-          </a:p>
-        </p:txBody>
-      </p:sp>
-      <p:sp>
-        <p:nvSpPr>
-          <p:cNvPr id="10" name="TextBox 9"/>
-          <p:cNvSpPr txBox="1"/>
-          <p:nvPr/>
-        </p:nvSpPr>
-        <p:spPr>
-          <a:xfrm>
-            <a:off x="6449263" y="1490472"/>
-            <a:ext cx="4809744" cy="4334255"/>
-          </a:xfrm>
-          <a:prstGeom prst="rect">
-            <a:avLst/>
-          </a:prstGeom>
-          <a:noFill/>
-        </p:spPr>
-        <p:txBody>
-          <a:bodyPr wrap="square" tIns="0" bIns="0" lIns="0" rIns="0">
-            <a:spAutoFit/>
-          </a:bodyPr>
-          <a:lstStyle/>
-          <a:p>
-            <a:pPr>
-              <a:spcAft>
-                <a:spcPts val="1000"/>
-              </a:spcAft>
-              <a:defRPr sz="1250" b="1">
-                <a:solidFill>
-                  <a:srgbClr val="3EA6FF"/>
-                </a:solidFill>
-              </a:defRPr>
-            </a:pPr>
-            <a:r>
-              <a:t>Responsive Viewport Adaptations</a:t>
-            </a:r>
-          </a:p>
-          <a:p>
-            <a:pPr>
-              <a:spcAft>
-                <a:spcPts val="800"/>
-              </a:spcAft>
-            </a:pPr>
-            <a:r>
-              <a:rPr sz="1050" b="1">
-                <a:solidFill>
-                  <a:srgbClr val="FFFFFF"/>
-                </a:solidFill>
-              </a:rPr>
-              <a:t>• Tablet / iPad Pro (1032 x 1376px): </a:t>
-            </a:r>
-            <a:r>
-              <a:rPr sz="1050">
-                <a:solidFill>
-                  <a:srgbClr val="CDD2DC"/>
-                </a:solidFill>
-              </a:rPr>
-              <a:t>Fluid 2-column video card grid dynamically adapting from desktop 4-column feed with zero clipping.</a:t>
-            </a:r>
-          </a:p>
-          <a:p>
-            <a:pPr>
-              <a:spcAft>
-                <a:spcPts val="800"/>
-              </a:spcAft>
-            </a:pPr>
-            <a:r>
-              <a:rPr sz="1050" b="1">
-                <a:solidFill>
-                  <a:srgbClr val="FFFFFF"/>
-                </a:solidFill>
-              </a:rPr>
-              <a:t>• Collapsed Mini-Rail Sidebar: </a:t>
-            </a:r>
-            <a:r>
-              <a:rPr sz="1050">
-                <a:solidFill>
-                  <a:srgbClr val="CDD2DC"/>
-                </a:solidFill>
-              </a:rPr>
-              <a:t>Maximizes content viewport area on tablet devices by shrinking 240px sidebar into compact icon rail.</a:t>
-            </a:r>
-          </a:p>
-          <a:p>
-            <a:pPr>
-              <a:spcAft>
-                <a:spcPts val="800"/>
-              </a:spcAft>
-            </a:pPr>
-            <a:r>
-              <a:rPr sz="1050" b="1">
-                <a:solidFill>
-                  <a:srgbClr val="FFFFFF"/>
-                </a:solidFill>
-              </a:rPr>
-              <a:t>• Desktop Viewport (1440px+): </a:t>
-            </a:r>
-            <a:r>
-              <a:rPr sz="1050">
-                <a:solidFill>
-                  <a:srgbClr val="CDD2DC"/>
-                </a:solidFill>
-              </a:rPr>
-              <a:t>Expansive widescreen layout with full drawer sidebar, 4-column grid, and dedicated Up-Next rail.</a:t>
-            </a:r>
-          </a:p>
-          <a:p>
-            <a:pPr>
-              <a:spcAft>
-                <a:spcPts val="800"/>
-              </a:spcAft>
-            </a:pPr>
-            <a:r>
-              <a:rPr sz="1050" b="1">
-                <a:solidFill>
-                  <a:srgbClr val="FFFFFF"/>
-                </a:solidFill>
-              </a:rPr>
-              <a:t>• Mobile Viewport (375px - 480px): </a:t>
-            </a:r>
-            <a:r>
-              <a:rPr sz="1050">
-                <a:solidFill>
-                  <a:srgbClr val="CDD2DC"/>
-                </a:solidFill>
-              </a:rPr>
-              <a:t>Single-column video stream with bottom drawer navigation and touch-optimized controls.</a:t>
-            </a:r>
-          </a:p>
-          <a:p>
-            <a:pPr>
-              <a:spcAft>
-                <a:spcPts val="800"/>
-              </a:spcAft>
-            </a:pPr>
-            <a:r>
-              <a:rPr sz="1050" b="1">
-                <a:solidFill>
-                  <a:srgbClr val="FFFFFF"/>
-                </a:solidFill>
-              </a:rPr>
-              <a:t>• Tailwind Breakpoint Matrix: </a:t>
-            </a:r>
-            <a:r>
-              <a:rPr sz="1050">
-                <a:solidFill>
-                  <a:srgbClr val="CDD2DC"/>
-                </a:solidFill>
-              </a:rPr>
-              <a:t>Uses strict responsive utility classes (sm, md, lg, xl, 2xl) eliminating horizontal scrollbars.</a:t>
-            </a:r>
-          </a:p>
-          <a:p>
-            <a:pPr>
-              <a:spcAft>
-                <a:spcPts val="800"/>
-              </a:spcAft>
-            </a:pPr>
-            <a:r>
-              <a:rPr sz="1050" b="1">
-                <a:solidFill>
-                  <a:srgbClr val="FFFFFF"/>
-                </a:solidFill>
-              </a:rPr>
-              <a:t>• DevTools Emulation Audit: </a:t>
-            </a:r>
-            <a:r>
-              <a:rPr sz="1050">
-                <a:solidFill>
-                  <a:srgbClr val="CDD2DC"/>
-                </a:solidFill>
-              </a:rPr>
-              <a:t>Verified and tested across iPad Pro, iPad Mini, and iPhone viewports via Chrome DevTools.</a:t>
-            </a:r>
-          </a:p>
-        </p:txBody>
-      </p:sp>
-    </p:spTree>
-  </p:cSld>
-  <p:clrMapOvr>
-    <a:masterClrMapping/>
-  </p:clrMapOvr>
-  <p:transition spd="fast">
-    <p:push dir="l"/>
-  </p:transition>
-</p:sld>
-</file>
-
-<file path=ppt/slides/slide12.xml><?xml version="1.0" encoding="utf-8"?>
 <p:sld xmlns:a="http://schemas.openxmlformats.org/drawingml/2006/main" xmlns:p="http://schemas.openxmlformats.org/presentationml/2006/main" xmlns:r="http://schemas.openxmlformats.org/officeDocument/2006/relationships">
   <p:cSld>
     <p:spTree>

</xml_diff>

<commit_message>
Sync user font edits in PPT and update compiled Master PDF
</commit_message>
<xml_diff>
--- a/G15-PID-17.pptx
+++ b/G15-PID-17.pptx
@@ -5,19 +5,19 @@
     <p:sldMasterId id="2147483648" r:id="rId1"/>
   </p:sldMasterIdLst>
   <p:sldIdLst>
-    <p:sldId id="256" r:id="rId7"/>
-    <p:sldId id="257" r:id="rId8"/>
-    <p:sldId id="258" r:id="rId9"/>
-    <p:sldId id="259" r:id="rId10"/>
-    <p:sldId id="260" r:id="rId11"/>
-    <p:sldId id="261" r:id="rId12"/>
-    <p:sldId id="262" r:id="rId13"/>
-    <p:sldId id="263" r:id="rId14"/>
-    <p:sldId id="264" r:id="rId15"/>
-    <p:sldId id="265" r:id="rId16"/>
-    <p:sldId id="266" r:id="rId17"/>
+    <p:sldId id="256" r:id="rId2"/>
+    <p:sldId id="257" r:id="rId3"/>
+    <p:sldId id="258" r:id="rId4"/>
+    <p:sldId id="259" r:id="rId5"/>
+    <p:sldId id="260" r:id="rId6"/>
+    <p:sldId id="261" r:id="rId7"/>
+    <p:sldId id="262" r:id="rId8"/>
+    <p:sldId id="263" r:id="rId9"/>
+    <p:sldId id="264" r:id="rId10"/>
+    <p:sldId id="265" r:id="rId11"/>
+    <p:sldId id="266" r:id="rId12"/>
   </p:sldIdLst>
-  <p:sldSz cx="12191695" cy="6858000" type="screen4x3"/>
+  <p:sldSz cx="12192000" cy="6858000"/>
   <p:notesSz cx="6858000" cy="9144000"/>
   <p:defaultTextStyle>
     <a:defPPr>
@@ -114,6 +114,22 @@
       </a:defRPr>
     </a:lvl9pPr>
   </p:defaultTextStyle>
+  <p:extLst>
+    <p:ext uri="{EFAFB233-063F-42B5-8137-9DF3F51BA10A}">
+      <p15:sldGuideLst xmlns:p15="http://schemas.microsoft.com/office/powerpoint/2012/main">
+        <p15:guide id="1" orient="horz" pos="2160">
+          <p15:clr>
+            <a:srgbClr val="A4A3A4"/>
+          </p15:clr>
+        </p15:guide>
+        <p15:guide id="2" pos="2880">
+          <p15:clr>
+            <a:srgbClr val="A4A3A4"/>
+          </p15:clr>
+        </p15:guide>
+      </p15:sldGuideLst>
+    </p:ext>
+  </p:extLst>
 </p:presentation>
 </file>
 
@@ -155,10 +171,9 @@
           <a:lstStyle/>
           <a:p>
             <a:r>
-              <a:rPr lang="en-US" smtClean="0"/>
+              <a:rPr lang="en-US"/>
               <a:t>Click to edit Master title style</a:t>
             </a:r>
-            <a:endParaRPr lang="en-US"/>
           </a:p>
         </p:txBody>
       </p:sp>
@@ -274,10 +289,9 @@
           </a:lstStyle>
           <a:p>
             <a:r>
-              <a:rPr lang="en-US" smtClean="0"/>
+              <a:rPr lang="en-US"/>
               <a:t>Click to edit Master subtitle style</a:t>
             </a:r>
-            <a:endParaRPr lang="en-US"/>
           </a:p>
         </p:txBody>
       </p:sp>
@@ -298,7 +312,7 @@
           <a:p>
             <a:fld id="{5BCAD085-E8A6-8845-BD4E-CB4CCA059FC4}" type="datetimeFigureOut">
               <a:rPr lang="en-US" smtClean="0"/>
-              <a:t>1/27/13</a:t>
+              <a:t>10/25/2026</a:t>
             </a:fld>
             <a:endParaRPr lang="en-US"/>
           </a:p>
@@ -392,10 +406,9 @@
           <a:lstStyle/>
           <a:p>
             <a:r>
-              <a:rPr lang="en-US" smtClean="0"/>
+              <a:rPr lang="en-US"/>
               <a:t>Click to edit Master title style</a:t>
             </a:r>
-            <a:endParaRPr lang="en-US"/>
           </a:p>
         </p:txBody>
       </p:sp>
@@ -416,38 +429,37 @@
           <a:p>
             <a:pPr lvl="0"/>
             <a:r>
-              <a:rPr lang="en-US" smtClean="0"/>
+              <a:rPr lang="en-US"/>
               <a:t>Click to edit Master text styles</a:t>
             </a:r>
           </a:p>
           <a:p>
             <a:pPr lvl="1"/>
             <a:r>
-              <a:rPr lang="en-US" smtClean="0"/>
+              <a:rPr lang="en-US"/>
               <a:t>Second level</a:t>
             </a:r>
           </a:p>
           <a:p>
             <a:pPr lvl="2"/>
             <a:r>
-              <a:rPr lang="en-US" smtClean="0"/>
+              <a:rPr lang="en-US"/>
               <a:t>Third level</a:t>
             </a:r>
           </a:p>
           <a:p>
             <a:pPr lvl="3"/>
             <a:r>
-              <a:rPr lang="en-US" smtClean="0"/>
+              <a:rPr lang="en-US"/>
               <a:t>Fourth level</a:t>
             </a:r>
           </a:p>
           <a:p>
             <a:pPr lvl="4"/>
             <a:r>
-              <a:rPr lang="en-US" smtClean="0"/>
+              <a:rPr lang="en-US"/>
               <a:t>Fifth level</a:t>
             </a:r>
-            <a:endParaRPr lang="en-US"/>
           </a:p>
         </p:txBody>
       </p:sp>
@@ -468,7 +480,7 @@
           <a:p>
             <a:fld id="{5BCAD085-E8A6-8845-BD4E-CB4CCA059FC4}" type="datetimeFigureOut">
               <a:rPr lang="en-US" smtClean="0"/>
-              <a:t>1/27/13</a:t>
+              <a:t>10/25/2026</a:t>
             </a:fld>
             <a:endParaRPr lang="en-US"/>
           </a:p>
@@ -567,10 +579,9 @@
           <a:lstStyle/>
           <a:p>
             <a:r>
-              <a:rPr lang="en-US" smtClean="0"/>
+              <a:rPr lang="en-US"/>
               <a:t>Click to edit Master title style</a:t>
             </a:r>
-            <a:endParaRPr lang="en-US"/>
           </a:p>
         </p:txBody>
       </p:sp>
@@ -596,38 +607,37 @@
           <a:p>
             <a:pPr lvl="0"/>
             <a:r>
-              <a:rPr lang="en-US" smtClean="0"/>
+              <a:rPr lang="en-US"/>
               <a:t>Click to edit Master text styles</a:t>
             </a:r>
           </a:p>
           <a:p>
             <a:pPr lvl="1"/>
             <a:r>
-              <a:rPr lang="en-US" smtClean="0"/>
+              <a:rPr lang="en-US"/>
               <a:t>Second level</a:t>
             </a:r>
           </a:p>
           <a:p>
             <a:pPr lvl="2"/>
             <a:r>
-              <a:rPr lang="en-US" smtClean="0"/>
+              <a:rPr lang="en-US"/>
               <a:t>Third level</a:t>
             </a:r>
           </a:p>
           <a:p>
             <a:pPr lvl="3"/>
             <a:r>
-              <a:rPr lang="en-US" smtClean="0"/>
+              <a:rPr lang="en-US"/>
               <a:t>Fourth level</a:t>
             </a:r>
           </a:p>
           <a:p>
             <a:pPr lvl="4"/>
             <a:r>
-              <a:rPr lang="en-US" smtClean="0"/>
+              <a:rPr lang="en-US"/>
               <a:t>Fifth level</a:t>
             </a:r>
-            <a:endParaRPr lang="en-US"/>
           </a:p>
         </p:txBody>
       </p:sp>
@@ -648,7 +658,7 @@
           <a:p>
             <a:fld id="{5BCAD085-E8A6-8845-BD4E-CB4CCA059FC4}" type="datetimeFigureOut">
               <a:rPr lang="en-US" smtClean="0"/>
-              <a:t>1/27/13</a:t>
+              <a:t>10/25/2026</a:t>
             </a:fld>
             <a:endParaRPr lang="en-US"/>
           </a:p>
@@ -742,10 +752,9 @@
           <a:lstStyle/>
           <a:p>
             <a:r>
-              <a:rPr lang="en-US" smtClean="0"/>
+              <a:rPr lang="en-US"/>
               <a:t>Click to edit Master title style</a:t>
             </a:r>
-            <a:endParaRPr lang="en-US"/>
           </a:p>
         </p:txBody>
       </p:sp>
@@ -766,38 +775,37 @@
           <a:p>
             <a:pPr lvl="0"/>
             <a:r>
-              <a:rPr lang="en-US" smtClean="0"/>
+              <a:rPr lang="en-US"/>
               <a:t>Click to edit Master text styles</a:t>
             </a:r>
           </a:p>
           <a:p>
             <a:pPr lvl="1"/>
             <a:r>
-              <a:rPr lang="en-US" smtClean="0"/>
+              <a:rPr lang="en-US"/>
               <a:t>Second level</a:t>
             </a:r>
           </a:p>
           <a:p>
             <a:pPr lvl="2"/>
             <a:r>
-              <a:rPr lang="en-US" smtClean="0"/>
+              <a:rPr lang="en-US"/>
               <a:t>Third level</a:t>
             </a:r>
           </a:p>
           <a:p>
             <a:pPr lvl="3"/>
             <a:r>
-              <a:rPr lang="en-US" smtClean="0"/>
+              <a:rPr lang="en-US"/>
               <a:t>Fourth level</a:t>
             </a:r>
           </a:p>
           <a:p>
             <a:pPr lvl="4"/>
             <a:r>
-              <a:rPr lang="en-US" smtClean="0"/>
+              <a:rPr lang="en-US"/>
               <a:t>Fifth level</a:t>
             </a:r>
-            <a:endParaRPr lang="en-US"/>
           </a:p>
         </p:txBody>
       </p:sp>
@@ -818,7 +826,7 @@
           <a:p>
             <a:fld id="{5BCAD085-E8A6-8845-BD4E-CB4CCA059FC4}" type="datetimeFigureOut">
               <a:rPr lang="en-US" smtClean="0"/>
-              <a:t>1/27/13</a:t>
+              <a:t>10/25/2026</a:t>
             </a:fld>
             <a:endParaRPr lang="en-US"/>
           </a:p>
@@ -921,10 +929,9 @@
           </a:lstStyle>
           <a:p>
             <a:r>
-              <a:rPr lang="en-US" smtClean="0"/>
+              <a:rPr lang="en-US"/>
               <a:t>Click to edit Master title style</a:t>
             </a:r>
-            <a:endParaRPr lang="en-US"/>
           </a:p>
         </p:txBody>
       </p:sp>
@@ -1041,7 +1048,7 @@
           <a:p>
             <a:pPr lvl="0"/>
             <a:r>
-              <a:rPr lang="en-US" smtClean="0"/>
+              <a:rPr lang="en-US"/>
               <a:t>Click to edit Master text styles</a:t>
             </a:r>
           </a:p>
@@ -1064,7 +1071,7 @@
           <a:p>
             <a:fld id="{5BCAD085-E8A6-8845-BD4E-CB4CCA059FC4}" type="datetimeFigureOut">
               <a:rPr lang="en-US" smtClean="0"/>
-              <a:t>1/27/13</a:t>
+              <a:t>10/25/2026</a:t>
             </a:fld>
             <a:endParaRPr lang="en-US"/>
           </a:p>
@@ -1158,10 +1165,9 @@
           <a:lstStyle/>
           <a:p>
             <a:r>
-              <a:rPr lang="en-US" smtClean="0"/>
+              <a:rPr lang="en-US"/>
               <a:t>Click to edit Master title style</a:t>
             </a:r>
-            <a:endParaRPr lang="en-US"/>
           </a:p>
         </p:txBody>
       </p:sp>
@@ -1215,38 +1221,37 @@
           <a:p>
             <a:pPr lvl="0"/>
             <a:r>
-              <a:rPr lang="en-US" smtClean="0"/>
+              <a:rPr lang="en-US"/>
               <a:t>Click to edit Master text styles</a:t>
             </a:r>
           </a:p>
           <a:p>
             <a:pPr lvl="1"/>
             <a:r>
-              <a:rPr lang="en-US" smtClean="0"/>
+              <a:rPr lang="en-US"/>
               <a:t>Second level</a:t>
             </a:r>
           </a:p>
           <a:p>
             <a:pPr lvl="2"/>
             <a:r>
-              <a:rPr lang="en-US" smtClean="0"/>
+              <a:rPr lang="en-US"/>
               <a:t>Third level</a:t>
             </a:r>
           </a:p>
           <a:p>
             <a:pPr lvl="3"/>
             <a:r>
-              <a:rPr lang="en-US" smtClean="0"/>
+              <a:rPr lang="en-US"/>
               <a:t>Fourth level</a:t>
             </a:r>
           </a:p>
           <a:p>
             <a:pPr lvl="4"/>
             <a:r>
-              <a:rPr lang="en-US" smtClean="0"/>
+              <a:rPr lang="en-US"/>
               <a:t>Fifth level</a:t>
             </a:r>
-            <a:endParaRPr lang="en-US"/>
           </a:p>
         </p:txBody>
       </p:sp>
@@ -1300,38 +1305,37 @@
           <a:p>
             <a:pPr lvl="0"/>
             <a:r>
-              <a:rPr lang="en-US" smtClean="0"/>
+              <a:rPr lang="en-US"/>
               <a:t>Click to edit Master text styles</a:t>
             </a:r>
           </a:p>
           <a:p>
             <a:pPr lvl="1"/>
             <a:r>
-              <a:rPr lang="en-US" smtClean="0"/>
+              <a:rPr lang="en-US"/>
               <a:t>Second level</a:t>
             </a:r>
           </a:p>
           <a:p>
             <a:pPr lvl="2"/>
             <a:r>
-              <a:rPr lang="en-US" smtClean="0"/>
+              <a:rPr lang="en-US"/>
               <a:t>Third level</a:t>
             </a:r>
           </a:p>
           <a:p>
             <a:pPr lvl="3"/>
             <a:r>
-              <a:rPr lang="en-US" smtClean="0"/>
+              <a:rPr lang="en-US"/>
               <a:t>Fourth level</a:t>
             </a:r>
           </a:p>
           <a:p>
             <a:pPr lvl="4"/>
             <a:r>
-              <a:rPr lang="en-US" smtClean="0"/>
+              <a:rPr lang="en-US"/>
               <a:t>Fifth level</a:t>
             </a:r>
-            <a:endParaRPr lang="en-US"/>
           </a:p>
         </p:txBody>
       </p:sp>
@@ -1352,7 +1356,7 @@
           <a:p>
             <a:fld id="{5BCAD085-E8A6-8845-BD4E-CB4CCA059FC4}" type="datetimeFigureOut">
               <a:rPr lang="en-US" smtClean="0"/>
-              <a:t>1/27/13</a:t>
+              <a:t>10/25/2026</a:t>
             </a:fld>
             <a:endParaRPr lang="en-US"/>
           </a:p>
@@ -1450,10 +1454,9 @@
           </a:lstStyle>
           <a:p>
             <a:r>
-              <a:rPr lang="en-US" smtClean="0"/>
+              <a:rPr lang="en-US"/>
               <a:t>Click to edit Master title style</a:t>
             </a:r>
-            <a:endParaRPr lang="en-US"/>
           </a:p>
         </p:txBody>
       </p:sp>
@@ -1516,7 +1519,7 @@
           <a:p>
             <a:pPr lvl="0"/>
             <a:r>
-              <a:rPr lang="en-US" smtClean="0"/>
+              <a:rPr lang="en-US"/>
               <a:t>Click to edit Master text styles</a:t>
             </a:r>
           </a:p>
@@ -1572,38 +1575,37 @@
           <a:p>
             <a:pPr lvl="0"/>
             <a:r>
-              <a:rPr lang="en-US" smtClean="0"/>
+              <a:rPr lang="en-US"/>
               <a:t>Click to edit Master text styles</a:t>
             </a:r>
           </a:p>
           <a:p>
             <a:pPr lvl="1"/>
             <a:r>
-              <a:rPr lang="en-US" smtClean="0"/>
+              <a:rPr lang="en-US"/>
               <a:t>Second level</a:t>
             </a:r>
           </a:p>
           <a:p>
             <a:pPr lvl="2"/>
             <a:r>
-              <a:rPr lang="en-US" smtClean="0"/>
+              <a:rPr lang="en-US"/>
               <a:t>Third level</a:t>
             </a:r>
           </a:p>
           <a:p>
             <a:pPr lvl="3"/>
             <a:r>
-              <a:rPr lang="en-US" smtClean="0"/>
+              <a:rPr lang="en-US"/>
               <a:t>Fourth level</a:t>
             </a:r>
           </a:p>
           <a:p>
             <a:pPr lvl="4"/>
             <a:r>
-              <a:rPr lang="en-US" smtClean="0"/>
+              <a:rPr lang="en-US"/>
               <a:t>Fifth level</a:t>
             </a:r>
-            <a:endParaRPr lang="en-US"/>
           </a:p>
         </p:txBody>
       </p:sp>
@@ -1666,7 +1668,7 @@
           <a:p>
             <a:pPr lvl="0"/>
             <a:r>
-              <a:rPr lang="en-US" smtClean="0"/>
+              <a:rPr lang="en-US"/>
               <a:t>Click to edit Master text styles</a:t>
             </a:r>
           </a:p>
@@ -1722,38 +1724,37 @@
           <a:p>
             <a:pPr lvl="0"/>
             <a:r>
-              <a:rPr lang="en-US" smtClean="0"/>
+              <a:rPr lang="en-US"/>
               <a:t>Click to edit Master text styles</a:t>
             </a:r>
           </a:p>
           <a:p>
             <a:pPr lvl="1"/>
             <a:r>
-              <a:rPr lang="en-US" smtClean="0"/>
+              <a:rPr lang="en-US"/>
               <a:t>Second level</a:t>
             </a:r>
           </a:p>
           <a:p>
             <a:pPr lvl="2"/>
             <a:r>
-              <a:rPr lang="en-US" smtClean="0"/>
+              <a:rPr lang="en-US"/>
               <a:t>Third level</a:t>
             </a:r>
           </a:p>
           <a:p>
             <a:pPr lvl="3"/>
             <a:r>
-              <a:rPr lang="en-US" smtClean="0"/>
+              <a:rPr lang="en-US"/>
               <a:t>Fourth level</a:t>
             </a:r>
           </a:p>
           <a:p>
             <a:pPr lvl="4"/>
             <a:r>
-              <a:rPr lang="en-US" smtClean="0"/>
+              <a:rPr lang="en-US"/>
               <a:t>Fifth level</a:t>
             </a:r>
-            <a:endParaRPr lang="en-US"/>
           </a:p>
         </p:txBody>
       </p:sp>
@@ -1774,7 +1775,7 @@
           <a:p>
             <a:fld id="{5BCAD085-E8A6-8845-BD4E-CB4CCA059FC4}" type="datetimeFigureOut">
               <a:rPr lang="en-US" smtClean="0"/>
-              <a:t>1/27/13</a:t>
+              <a:t>10/25/2026</a:t>
             </a:fld>
             <a:endParaRPr lang="en-US"/>
           </a:p>
@@ -1868,10 +1869,9 @@
           <a:lstStyle/>
           <a:p>
             <a:r>
-              <a:rPr lang="en-US" smtClean="0"/>
+              <a:rPr lang="en-US"/>
               <a:t>Click to edit Master title style</a:t>
             </a:r>
-            <a:endParaRPr lang="en-US"/>
           </a:p>
         </p:txBody>
       </p:sp>
@@ -1892,7 +1892,7 @@
           <a:p>
             <a:fld id="{5BCAD085-E8A6-8845-BD4E-CB4CCA059FC4}" type="datetimeFigureOut">
               <a:rPr lang="en-US" smtClean="0"/>
-              <a:t>1/27/13</a:t>
+              <a:t>10/25/2026</a:t>
             </a:fld>
             <a:endParaRPr lang="en-US"/>
           </a:p>
@@ -1987,7 +1987,7 @@
           <a:p>
             <a:fld id="{5BCAD085-E8A6-8845-BD4E-CB4CCA059FC4}" type="datetimeFigureOut">
               <a:rPr lang="en-US" smtClean="0"/>
-              <a:t>1/27/13</a:t>
+              <a:t>10/25/2026</a:t>
             </a:fld>
             <a:endParaRPr lang="en-US"/>
           </a:p>
@@ -2090,10 +2090,9 @@
           </a:lstStyle>
           <a:p>
             <a:r>
-              <a:rPr lang="en-US" smtClean="0"/>
+              <a:rPr lang="en-US"/>
               <a:t>Click to edit Master title style</a:t>
             </a:r>
-            <a:endParaRPr lang="en-US"/>
           </a:p>
         </p:txBody>
       </p:sp>
@@ -2147,38 +2146,37 @@
           <a:p>
             <a:pPr lvl="0"/>
             <a:r>
-              <a:rPr lang="en-US" smtClean="0"/>
+              <a:rPr lang="en-US"/>
               <a:t>Click to edit Master text styles</a:t>
             </a:r>
           </a:p>
           <a:p>
             <a:pPr lvl="1"/>
             <a:r>
-              <a:rPr lang="en-US" smtClean="0"/>
+              <a:rPr lang="en-US"/>
               <a:t>Second level</a:t>
             </a:r>
           </a:p>
           <a:p>
             <a:pPr lvl="2"/>
             <a:r>
-              <a:rPr lang="en-US" smtClean="0"/>
+              <a:rPr lang="en-US"/>
               <a:t>Third level</a:t>
             </a:r>
           </a:p>
           <a:p>
             <a:pPr lvl="3"/>
             <a:r>
-              <a:rPr lang="en-US" smtClean="0"/>
+              <a:rPr lang="en-US"/>
               <a:t>Fourth level</a:t>
             </a:r>
           </a:p>
           <a:p>
             <a:pPr lvl="4"/>
             <a:r>
-              <a:rPr lang="en-US" smtClean="0"/>
+              <a:rPr lang="en-US"/>
               <a:t>Fifth level</a:t>
             </a:r>
-            <a:endParaRPr lang="en-US"/>
           </a:p>
         </p:txBody>
       </p:sp>
@@ -2241,7 +2239,7 @@
           <a:p>
             <a:pPr lvl="0"/>
             <a:r>
-              <a:rPr lang="en-US" smtClean="0"/>
+              <a:rPr lang="en-US"/>
               <a:t>Click to edit Master text styles</a:t>
             </a:r>
           </a:p>
@@ -2264,7 +2262,7 @@
           <a:p>
             <a:fld id="{5BCAD085-E8A6-8845-BD4E-CB4CCA059FC4}" type="datetimeFigureOut">
               <a:rPr lang="en-US" smtClean="0"/>
-              <a:t>1/27/13</a:t>
+              <a:t>10/25/2026</a:t>
             </a:fld>
             <a:endParaRPr lang="en-US"/>
           </a:p>
@@ -2367,10 +2365,9 @@
           </a:lstStyle>
           <a:p>
             <a:r>
-              <a:rPr lang="en-US" smtClean="0"/>
+              <a:rPr lang="en-US"/>
               <a:t>Click to edit Master title style</a:t>
             </a:r>
-            <a:endParaRPr lang="en-US"/>
           </a:p>
         </p:txBody>
       </p:sp>
@@ -2494,7 +2491,7 @@
           <a:p>
             <a:pPr lvl="0"/>
             <a:r>
-              <a:rPr lang="en-US" smtClean="0"/>
+              <a:rPr lang="en-US"/>
               <a:t>Click to edit Master text styles</a:t>
             </a:r>
           </a:p>
@@ -2517,7 +2514,7 @@
           <a:p>
             <a:fld id="{5BCAD085-E8A6-8845-BD4E-CB4CCA059FC4}" type="datetimeFigureOut">
               <a:rPr lang="en-US" smtClean="0"/>
-              <a:t>1/27/13</a:t>
+              <a:t>10/25/2026</a:t>
             </a:fld>
             <a:endParaRPr lang="en-US"/>
           </a:p>
@@ -2626,10 +2623,9 @@
           <a:lstStyle/>
           <a:p>
             <a:r>
-              <a:rPr lang="en-US" smtClean="0"/>
+              <a:rPr lang="en-US"/>
               <a:t>Click to edit Master title style</a:t>
             </a:r>
-            <a:endParaRPr lang="en-US"/>
           </a:p>
         </p:txBody>
       </p:sp>
@@ -2660,38 +2656,37 @@
           <a:p>
             <a:pPr lvl="0"/>
             <a:r>
-              <a:rPr lang="en-US" smtClean="0"/>
+              <a:rPr lang="en-US"/>
               <a:t>Click to edit Master text styles</a:t>
             </a:r>
           </a:p>
           <a:p>
             <a:pPr lvl="1"/>
             <a:r>
-              <a:rPr lang="en-US" smtClean="0"/>
+              <a:rPr lang="en-US"/>
               <a:t>Second level</a:t>
             </a:r>
           </a:p>
           <a:p>
             <a:pPr lvl="2"/>
             <a:r>
-              <a:rPr lang="en-US" smtClean="0"/>
+              <a:rPr lang="en-US"/>
               <a:t>Third level</a:t>
             </a:r>
           </a:p>
           <a:p>
             <a:pPr lvl="3"/>
             <a:r>
-              <a:rPr lang="en-US" smtClean="0"/>
+              <a:rPr lang="en-US"/>
               <a:t>Fourth level</a:t>
             </a:r>
           </a:p>
           <a:p>
             <a:pPr lvl="4"/>
             <a:r>
-              <a:rPr lang="en-US" smtClean="0"/>
+              <a:rPr lang="en-US"/>
               <a:t>Fifth level</a:t>
             </a:r>
-            <a:endParaRPr lang="en-US"/>
           </a:p>
         </p:txBody>
       </p:sp>
@@ -2730,7 +2725,7 @@
           <a:p>
             <a:fld id="{5BCAD085-E8A6-8845-BD4E-CB4CCA059FC4}" type="datetimeFigureOut">
               <a:rPr lang="en-US" smtClean="0"/>
-              <a:t>1/27/13</a:t>
+              <a:t>10/25/2026</a:t>
             </a:fld>
             <a:endParaRPr lang="en-US"/>
           </a:p>
@@ -3089,7 +3084,7 @@
 </file>
 
 <file path=ppt/slides/slide1.xml><?xml version="1.0" encoding="utf-8"?>
-<p:sld xmlns:a="http://schemas.openxmlformats.org/drawingml/2006/main" xmlns:p="http://schemas.openxmlformats.org/presentationml/2006/main" xmlns:r="http://schemas.openxmlformats.org/officeDocument/2006/relationships">
+<p:sld xmlns:a="http://schemas.openxmlformats.org/drawingml/2006/main" xmlns:r="http://schemas.openxmlformats.org/officeDocument/2006/relationships" xmlns:p="http://schemas.openxmlformats.org/presentationml/2006/main">
   <p:cSld>
     <p:spTree>
       <p:nvGrpSpPr>
@@ -3097,7 +3092,14 @@
         <p:cNvGrpSpPr/>
         <p:nvPr/>
       </p:nvGrpSpPr>
-      <p:grpSpPr/>
+      <p:grpSpPr>
+        <a:xfrm>
+          <a:off x="0" y="0"/>
+          <a:ext cx="0" cy="0"/>
+          <a:chOff x="0" y="0"/>
+          <a:chExt cx="0" cy="0"/>
+        </a:xfrm>
+      </p:grpSpPr>
       <p:sp>
         <p:nvSpPr>
           <p:cNvPr id="2" name="Rectangle 1"/>
@@ -3138,6 +3140,7 @@
           <a:lstStyle/>
           <a:p>
             <a:pPr algn="ctr"/>
+            <a:endParaRPr/>
           </a:p>
         </p:txBody>
       </p:sp>
@@ -3181,6 +3184,7 @@
           <a:lstStyle/>
           <a:p>
             <a:pPr algn="ctr"/>
+            <a:endParaRPr/>
           </a:p>
         </p:txBody>
       </p:sp>
@@ -3193,7 +3197,7 @@
         <p:spPr>
           <a:xfrm>
             <a:off x="731520" y="1097280"/>
-            <a:ext cx="10728655" cy="1645920"/>
+            <a:ext cx="10728655" cy="1287532"/>
           </a:xfrm>
           <a:prstGeom prst="rect">
             <a:avLst/>
@@ -3214,7 +3218,20 @@
               </a:defRPr>
             </a:pPr>
             <a:r>
-              <a:t>PheW TuBe: Video Streaming Platform</a:t>
+              <a:rPr i="1" u="sng" dirty="0" err="1"/>
+              <a:t>PheW</a:t>
+            </a:r>
+            <a:r>
+              <a:rPr i="1" u="sng" dirty="0"/>
+              <a:t> </a:t>
+            </a:r>
+            <a:r>
+              <a:rPr i="1" u="sng" dirty="0" err="1"/>
+              <a:t>TuBe</a:t>
+            </a:r>
+            <a:r>
+              <a:rPr i="1" u="sng" dirty="0"/>
+              <a:t>: Video Streaming Platform</a:t>
             </a:r>
           </a:p>
           <a:p>
@@ -3229,6 +3246,7 @@
               </a:defRPr>
             </a:pPr>
             <a:r>
+              <a:rPr sz="1600" dirty="0"/>
               <a:t>Front End Engineering - II (25CSE0203) — Project Based Evaluation-2 (Batch-2025)</a:t>
             </a:r>
           </a:p>
@@ -3244,6 +3262,7 @@
               </a:defRPr>
             </a:pPr>
             <a:r>
+              <a:rPr sz="1400" dirty="0"/>
               <a:t>Department of Computer Science &amp; Engineering • Chitkara University, Punjab</a:t>
             </a:r>
           </a:p>
@@ -3291,6 +3310,7 @@
           <a:lstStyle/>
           <a:p>
             <a:pPr algn="ctr"/>
+            <a:endParaRPr/>
           </a:p>
         </p:txBody>
       </p:sp>
@@ -3303,7 +3323,7 @@
         <p:spPr>
           <a:xfrm>
             <a:off x="1188720" y="3566160"/>
-            <a:ext cx="4114800" cy="2286000"/>
+            <a:ext cx="4341894" cy="1169551"/>
           </a:xfrm>
           <a:prstGeom prst="rect">
             <a:avLst/>
@@ -3327,6 +3347,7 @@
               </a:defRPr>
             </a:pPr>
             <a:r>
+              <a:rPr u="sng" dirty="0"/>
               <a:t>Supervised By:</a:t>
             </a:r>
           </a:p>
@@ -3342,6 +3363,7 @@
               </a:defRPr>
             </a:pPr>
             <a:r>
+              <a:rPr sz="1600" dirty="0"/>
               <a:t>Mr. Shubham Kumar</a:t>
             </a:r>
           </a:p>
@@ -3354,10 +3376,14 @@
               </a:defRPr>
             </a:pPr>
             <a:r>
+              <a:rPr sz="1400" dirty="0"/>
               <a:t>Technical Trainer, Department of CSE</a:t>
             </a:r>
-            <a:br/>
-            <a:r>
+            <a:br>
+              <a:rPr sz="1400" dirty="0"/>
+            </a:br>
+            <a:r>
+              <a:rPr sz="1400" dirty="0"/>
               <a:t>Chitkara University Institute of Engineering &amp; Technology</a:t>
             </a:r>
           </a:p>
@@ -3372,7 +3398,7 @@
         <p:spPr>
           <a:xfrm>
             <a:off x="6217920" y="3566160"/>
-            <a:ext cx="4846320" cy="2286000"/>
+            <a:ext cx="3648819" cy="1456809"/>
           </a:xfrm>
           <a:prstGeom prst="rect">
             <a:avLst/>
@@ -3396,6 +3422,7 @@
               </a:defRPr>
             </a:pPr>
             <a:r>
+              <a:rPr u="sng" dirty="0"/>
               <a:t>Submitted By (Group G-15):</a:t>
             </a:r>
           </a:p>
@@ -3411,6 +3438,7 @@
               </a:defRPr>
             </a:pPr>
             <a:r>
+              <a:rPr sz="1400" dirty="0"/>
               <a:t>Kanav Chadha — Roll No: 2510990649 (G-15)</a:t>
             </a:r>
           </a:p>
@@ -3426,6 +3454,7 @@
               </a:defRPr>
             </a:pPr>
             <a:r>
+              <a:rPr sz="1400" dirty="0"/>
               <a:t>Kishan — Roll No: 2510991457 (G-15)</a:t>
             </a:r>
           </a:p>
@@ -3441,6 +3470,7 @@
               </a:defRPr>
             </a:pPr>
             <a:r>
+              <a:rPr sz="1400" dirty="0"/>
               <a:t>Arsh Behl — Roll No: 2510991354 (G-15)</a:t>
             </a:r>
           </a:p>
@@ -3456,7 +3486,20 @@
               </a:defRPr>
             </a:pPr>
             <a:r>
-              <a:t>Soumajit Majee — Roll No: 2510990383 (G-15)</a:t>
+              <a:rPr sz="1400" dirty="0" err="1"/>
+              <a:t>Soumajit</a:t>
+            </a:r>
+            <a:r>
+              <a:rPr sz="1400" dirty="0"/>
+              <a:t> </a:t>
+            </a:r>
+            <a:r>
+              <a:rPr sz="1400" dirty="0" err="1"/>
+              <a:t>Majee</a:t>
+            </a:r>
+            <a:r>
+              <a:rPr sz="1400" dirty="0"/>
+              <a:t> — Roll No: 2510990383 (G-15)</a:t>
             </a:r>
           </a:p>
         </p:txBody>
@@ -3466,14 +3509,14 @@
   <p:clrMapOvr>
     <a:masterClrMapping/>
   </p:clrMapOvr>
-  <p:transition spd="fast">
-    <p:push dir="l"/>
+  <p:transition>
+    <p:push/>
   </p:transition>
 </p:sld>
 </file>
 
 <file path=ppt/slides/slide10.xml><?xml version="1.0" encoding="utf-8"?>
-<p:sld xmlns:a="http://schemas.openxmlformats.org/drawingml/2006/main" xmlns:p="http://schemas.openxmlformats.org/presentationml/2006/main" xmlns:r="http://schemas.openxmlformats.org/officeDocument/2006/relationships">
+<p:sld xmlns:a="http://schemas.openxmlformats.org/drawingml/2006/main" xmlns:r="http://schemas.openxmlformats.org/officeDocument/2006/relationships" xmlns:p="http://schemas.openxmlformats.org/presentationml/2006/main">
   <p:cSld>
     <p:spTree>
       <p:nvGrpSpPr>
@@ -3481,7 +3524,14 @@
         <p:cNvGrpSpPr/>
         <p:nvPr/>
       </p:nvGrpSpPr>
-      <p:grpSpPr/>
+      <p:grpSpPr>
+        <a:xfrm>
+          <a:off x="0" y="0"/>
+          <a:ext cx="0" cy="0"/>
+          <a:chOff x="0" y="0"/>
+          <a:chExt cx="0" cy="0"/>
+        </a:xfrm>
+      </p:grpSpPr>
       <p:sp>
         <p:nvSpPr>
           <p:cNvPr id="2" name="Rectangle 1"/>
@@ -3522,6 +3572,7 @@
           <a:lstStyle/>
           <a:p>
             <a:pPr algn="ctr"/>
+            <a:endParaRPr/>
           </a:p>
         </p:txBody>
       </p:sp>
@@ -3565,6 +3616,7 @@
           <a:lstStyle/>
           <a:p>
             <a:pPr algn="ctr"/>
+            <a:endParaRPr/>
           </a:p>
         </p:txBody>
       </p:sp>
@@ -3612,7 +3664,7 @@
         <p:spPr>
           <a:xfrm>
             <a:off x="731520" y="621792"/>
-            <a:ext cx="10728655" cy="594360"/>
+            <a:ext cx="10728655" cy="523220"/>
           </a:xfrm>
           <a:prstGeom prst="rect">
             <a:avLst/>
@@ -3633,6 +3685,7 @@
               </a:defRPr>
             </a:pPr>
             <a:r>
+              <a:rPr sz="2800" i="1" u="sng" dirty="0"/>
               <a:t>Multi-Device Responsive Design &amp; Viewport Audit</a:t>
             </a:r>
           </a:p>
@@ -3715,6 +3768,7 @@
           <a:lstStyle/>
           <a:p>
             <a:pPr algn="ctr"/>
+            <a:endParaRPr/>
           </a:p>
         </p:txBody>
       </p:sp>
@@ -3784,6 +3838,7 @@
           <a:lstStyle/>
           <a:p>
             <a:pPr algn="ctr"/>
+            <a:endParaRPr/>
           </a:p>
         </p:txBody>
       </p:sp>
@@ -3796,7 +3851,7 @@
         <p:spPr>
           <a:xfrm>
             <a:off x="6449263" y="1490472"/>
-            <a:ext cx="4809744" cy="4334255"/>
+            <a:ext cx="4809744" cy="3903633"/>
           </a:xfrm>
           <a:prstGeom prst="rect">
             <a:avLst/>
@@ -3804,12 +3859,12 @@
           <a:noFill/>
         </p:spPr>
         <p:txBody>
-          <a:bodyPr wrap="square" tIns="0" bIns="0" lIns="0" rIns="0">
+          <a:bodyPr wrap="square" lIns="0" tIns="0" rIns="0" bIns="0">
             <a:spAutoFit/>
           </a:bodyPr>
           <a:lstStyle/>
           <a:p>
-            <a:pPr>
+            <a:pPr algn="ctr">
               <a:spcAft>
                 <a:spcPts val="1000"/>
               </a:spcAft>
@@ -3820,6 +3875,7 @@
               </a:defRPr>
             </a:pPr>
             <a:r>
+              <a:rPr sz="1600" i="1" u="sng" dirty="0"/>
               <a:t>Responsive Viewport Adaptations</a:t>
             </a:r>
           </a:p>
@@ -3830,7 +3886,7 @@
               </a:spcAft>
             </a:pPr>
             <a:r>
-              <a:rPr sz="1050" b="1">
+              <a:rPr sz="1400" b="1" dirty="0">
                 <a:solidFill>
                   <a:srgbClr val="FFFFFF"/>
                 </a:solidFill>
@@ -3838,7 +3894,7 @@
               <a:t>• Tablet / iPad Pro (1032 x 1376px): </a:t>
             </a:r>
             <a:r>
-              <a:rPr sz="1050">
+              <a:rPr sz="1400" dirty="0">
                 <a:solidFill>
                   <a:srgbClr val="CDD2DC"/>
                 </a:solidFill>
@@ -3853,7 +3909,7 @@
               </a:spcAft>
             </a:pPr>
             <a:r>
-              <a:rPr sz="1050" b="1">
+              <a:rPr sz="1400" b="1" dirty="0">
                 <a:solidFill>
                   <a:srgbClr val="FFFFFF"/>
                 </a:solidFill>
@@ -3861,7 +3917,7 @@
               <a:t>• Collapsed Mini-Rail Sidebar: </a:t>
             </a:r>
             <a:r>
-              <a:rPr sz="1050">
+              <a:rPr sz="1400" dirty="0">
                 <a:solidFill>
                   <a:srgbClr val="CDD2DC"/>
                 </a:solidFill>
@@ -3876,7 +3932,7 @@
               </a:spcAft>
             </a:pPr>
             <a:r>
-              <a:rPr sz="1050" b="1">
+              <a:rPr sz="1400" b="1" dirty="0">
                 <a:solidFill>
                   <a:srgbClr val="FFFFFF"/>
                 </a:solidFill>
@@ -3884,7 +3940,7 @@
               <a:t>• Desktop Viewport (1440px+): </a:t>
             </a:r>
             <a:r>
-              <a:rPr sz="1050">
+              <a:rPr sz="1400" dirty="0">
                 <a:solidFill>
                   <a:srgbClr val="CDD2DC"/>
                 </a:solidFill>
@@ -3899,7 +3955,7 @@
               </a:spcAft>
             </a:pPr>
             <a:r>
-              <a:rPr sz="1050" b="1">
+              <a:rPr sz="1400" b="1" dirty="0">
                 <a:solidFill>
                   <a:srgbClr val="FFFFFF"/>
                 </a:solidFill>
@@ -3907,7 +3963,7 @@
               <a:t>• Mobile Viewport (375px - 480px): </a:t>
             </a:r>
             <a:r>
-              <a:rPr sz="1050">
+              <a:rPr sz="1400" dirty="0">
                 <a:solidFill>
                   <a:srgbClr val="CDD2DC"/>
                 </a:solidFill>
@@ -3922,7 +3978,7 @@
               </a:spcAft>
             </a:pPr>
             <a:r>
-              <a:rPr sz="1050" b="1">
+              <a:rPr sz="1400" b="1" dirty="0">
                 <a:solidFill>
                   <a:srgbClr val="FFFFFF"/>
                 </a:solidFill>
@@ -3930,12 +3986,28 @@
               <a:t>• Tailwind Breakpoint Matrix: </a:t>
             </a:r>
             <a:r>
-              <a:rPr sz="1050">
-                <a:solidFill>
-                  <a:srgbClr val="CDD2DC"/>
-                </a:solidFill>
-              </a:rPr>
-              <a:t>Uses strict responsive utility classes (sm, md, lg, xl, 2xl) eliminating horizontal scrollbars.</a:t>
+              <a:rPr sz="1400" dirty="0">
+                <a:solidFill>
+                  <a:srgbClr val="CDD2DC"/>
+                </a:solidFill>
+              </a:rPr>
+              <a:t>Uses strict responsive utility classes (</a:t>
+            </a:r>
+            <a:r>
+              <a:rPr sz="1400" dirty="0" err="1">
+                <a:solidFill>
+                  <a:srgbClr val="CDD2DC"/>
+                </a:solidFill>
+              </a:rPr>
+              <a:t>sm</a:t>
+            </a:r>
+            <a:r>
+              <a:rPr sz="1400" dirty="0">
+                <a:solidFill>
+                  <a:srgbClr val="CDD2DC"/>
+                </a:solidFill>
+              </a:rPr>
+              <a:t>, md, lg, xl, 2xl) eliminating horizontal scrollbars.</a:t>
             </a:r>
           </a:p>
           <a:p>
@@ -3945,20 +4017,52 @@
               </a:spcAft>
             </a:pPr>
             <a:r>
-              <a:rPr sz="1050" b="1">
+              <a:rPr sz="1400" b="1" dirty="0">
                 <a:solidFill>
                   <a:srgbClr val="FFFFFF"/>
                 </a:solidFill>
               </a:rPr>
-              <a:t>• DevTools Emulation Audit: </a:t>
-            </a:r>
-            <a:r>
-              <a:rPr sz="1050">
-                <a:solidFill>
-                  <a:srgbClr val="CDD2DC"/>
-                </a:solidFill>
-              </a:rPr>
-              <a:t>Verified and tested across iPad Pro, iPad Mini, and iPhone viewports via Chrome DevTools.</a:t>
+              <a:t>• </a:t>
+            </a:r>
+            <a:r>
+              <a:rPr sz="1400" b="1" dirty="0" err="1">
+                <a:solidFill>
+                  <a:srgbClr val="FFFFFF"/>
+                </a:solidFill>
+              </a:rPr>
+              <a:t>DevTools</a:t>
+            </a:r>
+            <a:r>
+              <a:rPr sz="1400" b="1" dirty="0">
+                <a:solidFill>
+                  <a:srgbClr val="FFFFFF"/>
+                </a:solidFill>
+              </a:rPr>
+              <a:t> Emulation Audit: </a:t>
+            </a:r>
+            <a:r>
+              <a:rPr sz="1400" dirty="0">
+                <a:solidFill>
+                  <a:srgbClr val="CDD2DC"/>
+                </a:solidFill>
+              </a:rPr>
+              <a:t>Verified and tested across iPad Pro, iPad Mini, and iPhone viewports via Chrome </a:t>
+            </a:r>
+            <a:r>
+              <a:rPr sz="1400" dirty="0" err="1">
+                <a:solidFill>
+                  <a:srgbClr val="CDD2DC"/>
+                </a:solidFill>
+              </a:rPr>
+              <a:t>DevTools</a:t>
+            </a:r>
+            <a:r>
+              <a:rPr sz="1400" dirty="0">
+                <a:solidFill>
+                  <a:srgbClr val="CDD2DC"/>
+                </a:solidFill>
+              </a:rPr>
+              <a:t>.</a:t>
             </a:r>
           </a:p>
         </p:txBody>
@@ -3968,14 +4072,14 @@
   <p:clrMapOvr>
     <a:masterClrMapping/>
   </p:clrMapOvr>
-  <p:transition spd="fast">
-    <p:push dir="l"/>
+  <p:transition>
+    <p:push/>
   </p:transition>
 </p:sld>
 </file>
 
 <file path=ppt/slides/slide11.xml><?xml version="1.0" encoding="utf-8"?>
-<p:sld xmlns:a="http://schemas.openxmlformats.org/drawingml/2006/main" xmlns:p="http://schemas.openxmlformats.org/presentationml/2006/main" xmlns:r="http://schemas.openxmlformats.org/officeDocument/2006/relationships">
+<p:sld xmlns:a="http://schemas.openxmlformats.org/drawingml/2006/main" xmlns:r="http://schemas.openxmlformats.org/officeDocument/2006/relationships" xmlns:p="http://schemas.openxmlformats.org/presentationml/2006/main">
   <p:cSld>
     <p:spTree>
       <p:nvGrpSpPr>
@@ -3983,7 +4087,14 @@
         <p:cNvGrpSpPr/>
         <p:nvPr/>
       </p:nvGrpSpPr>
-      <p:grpSpPr/>
+      <p:grpSpPr>
+        <a:xfrm>
+          <a:off x="0" y="0"/>
+          <a:ext cx="0" cy="0"/>
+          <a:chOff x="0" y="0"/>
+          <a:chExt cx="0" cy="0"/>
+        </a:xfrm>
+      </p:grpSpPr>
       <p:sp>
         <p:nvSpPr>
           <p:cNvPr id="2" name="Rectangle 1"/>
@@ -4024,6 +4135,7 @@
           <a:lstStyle/>
           <a:p>
             <a:pPr algn="ctr"/>
+            <a:endParaRPr/>
           </a:p>
         </p:txBody>
       </p:sp>
@@ -4069,6 +4181,7 @@
           <a:lstStyle/>
           <a:p>
             <a:pPr algn="ctr"/>
+            <a:endParaRPr/>
           </a:p>
         </p:txBody>
       </p:sp>
@@ -4081,7 +4194,7 @@
         <p:spPr>
           <a:xfrm>
             <a:off x="1097280" y="1463040"/>
-            <a:ext cx="9997135" cy="3931920"/>
+            <a:ext cx="9997135" cy="2021066"/>
           </a:xfrm>
           <a:prstGeom prst="rect">
             <a:avLst/>
@@ -4094,7 +4207,7 @@
           </a:bodyPr>
           <a:lstStyle/>
           <a:p>
-            <a:pPr algn="l">
+            <a:pPr algn="ctr">
               <a:defRPr sz="4400" b="1">
                 <a:solidFill>
                   <a:srgbClr val="FFFFFF"/>
@@ -4102,11 +4215,12 @@
               </a:defRPr>
             </a:pPr>
             <a:r>
+              <a:rPr sz="4800" i="1" u="sng" dirty="0"/>
               <a:t>THANK YOU</a:t>
             </a:r>
           </a:p>
           <a:p>
-            <a:pPr algn="l">
+            <a:pPr algn="ctr">
               <a:spcBef>
                 <a:spcPts val="1200"/>
               </a:spcBef>
@@ -4117,11 +4231,24 @@
               </a:defRPr>
             </a:pPr>
             <a:r>
-              <a:t>PheW TuBe: High-Performance Video Streaming Platform</a:t>
-            </a:r>
-          </a:p>
-          <a:p>
-            <a:pPr algn="l">
+              <a:rPr dirty="0" err="1"/>
+              <a:t>PheW</a:t>
+            </a:r>
+            <a:r>
+              <a:rPr dirty="0"/>
+              <a:t> </a:t>
+            </a:r>
+            <a:r>
+              <a:rPr dirty="0" err="1"/>
+              <a:t>TuBe</a:t>
+            </a:r>
+            <a:r>
+              <a:rPr dirty="0"/>
+              <a:t>: High-Performance Video Streaming Platform</a:t>
+            </a:r>
+          </a:p>
+          <a:p>
+            <a:pPr algn="ctr">
               <a:spcBef>
                 <a:spcPts val="800"/>
               </a:spcBef>
@@ -4132,11 +4259,12 @@
               </a:defRPr>
             </a:pPr>
             <a:r>
+              <a:rPr sz="1600" dirty="0"/>
               <a:t>Department of Computer Science &amp; Engineering • Chitkara University, Punjab</a:t>
             </a:r>
           </a:p>
           <a:p>
-            <a:pPr algn="l">
+            <a:pPr algn="ctr">
               <a:spcBef>
                 <a:spcPts val="1400"/>
               </a:spcBef>
@@ -4147,6 +4275,7 @@
               </a:defRPr>
             </a:pPr>
             <a:r>
+              <a:rPr sz="1600" dirty="0"/>
               <a:t>GROUP G15 • PROJECT ID: G15-PID-17 • EVALUATION-II (PHASE 2)</a:t>
             </a:r>
           </a:p>
@@ -4157,14 +4286,14 @@
   <p:clrMapOvr>
     <a:masterClrMapping/>
   </p:clrMapOvr>
-  <p:transition spd="fast">
-    <p:push dir="l"/>
+  <p:transition>
+    <p:push/>
   </p:transition>
 </p:sld>
 </file>
 
 <file path=ppt/slides/slide2.xml><?xml version="1.0" encoding="utf-8"?>
-<p:sld xmlns:a="http://schemas.openxmlformats.org/drawingml/2006/main" xmlns:p="http://schemas.openxmlformats.org/presentationml/2006/main" xmlns:r="http://schemas.openxmlformats.org/officeDocument/2006/relationships">
+<p:sld xmlns:a="http://schemas.openxmlformats.org/drawingml/2006/main" xmlns:r="http://schemas.openxmlformats.org/officeDocument/2006/relationships" xmlns:p="http://schemas.openxmlformats.org/presentationml/2006/main">
   <p:cSld>
     <p:spTree>
       <p:nvGrpSpPr>
@@ -4172,7 +4301,14 @@
         <p:cNvGrpSpPr/>
         <p:nvPr/>
       </p:nvGrpSpPr>
-      <p:grpSpPr/>
+      <p:grpSpPr>
+        <a:xfrm>
+          <a:off x="0" y="0"/>
+          <a:ext cx="0" cy="0"/>
+          <a:chOff x="0" y="0"/>
+          <a:chExt cx="0" cy="0"/>
+        </a:xfrm>
+      </p:grpSpPr>
       <p:sp>
         <p:nvSpPr>
           <p:cNvPr id="2" name="Rectangle 1"/>
@@ -4213,6 +4349,7 @@
           <a:lstStyle/>
           <a:p>
             <a:pPr algn="ctr"/>
+            <a:endParaRPr/>
           </a:p>
         </p:txBody>
       </p:sp>
@@ -4256,6 +4393,7 @@
           <a:lstStyle/>
           <a:p>
             <a:pPr algn="ctr"/>
+            <a:endParaRPr/>
           </a:p>
         </p:txBody>
       </p:sp>
@@ -4303,7 +4441,7 @@
         <p:spPr>
           <a:xfrm>
             <a:off x="731520" y="621792"/>
-            <a:ext cx="10728655" cy="594360"/>
+            <a:ext cx="10728655" cy="523220"/>
           </a:xfrm>
           <a:prstGeom prst="rect">
             <a:avLst/>
@@ -4316,7 +4454,7 @@
           </a:bodyPr>
           <a:lstStyle/>
           <a:p>
-            <a:pPr>
+            <a:pPr algn="ctr">
               <a:defRPr sz="2300" b="1">
                 <a:solidFill>
                   <a:srgbClr val="FFFFFF"/>
@@ -4324,6 +4462,7 @@
               </a:defRPr>
             </a:pPr>
             <a:r>
+              <a:rPr sz="2800" i="1" u="sng" dirty="0"/>
               <a:t>Evaluation-II Vision &amp; Milestone Objectives</a:t>
             </a:r>
           </a:p>
@@ -4406,6 +4545,7 @@
           <a:lstStyle/>
           <a:p>
             <a:pPr algn="ctr"/>
+            <a:endParaRPr/>
           </a:p>
         </p:txBody>
       </p:sp>
@@ -4418,7 +4558,7 @@
         <p:spPr>
           <a:xfrm>
             <a:off x="932688" y="1490472"/>
-            <a:ext cx="2980944" cy="4334255"/>
+            <a:ext cx="2980944" cy="3985706"/>
           </a:xfrm>
           <a:prstGeom prst="rect">
             <a:avLst/>
@@ -4426,12 +4566,12 @@
           <a:noFill/>
         </p:spPr>
         <p:txBody>
-          <a:bodyPr wrap="square" tIns="0" bIns="0" lIns="0" rIns="0">
+          <a:bodyPr wrap="square" lIns="0" tIns="0" rIns="0" bIns="0">
             <a:spAutoFit/>
           </a:bodyPr>
           <a:lstStyle/>
           <a:p>
-            <a:pPr>
+            <a:pPr algn="ctr">
               <a:spcAft>
                 <a:spcPts val="1000"/>
               </a:spcAft>
@@ -4442,6 +4582,7 @@
               </a:defRPr>
             </a:pPr>
             <a:r>
+              <a:rPr sz="1600" i="1" u="sng" dirty="0"/>
               <a:t>Phase 1 vs Phase 2 Focus</a:t>
             </a:r>
           </a:p>
@@ -4452,7 +4593,7 @@
               </a:spcAft>
             </a:pPr>
             <a:r>
-              <a:rPr sz="1150" b="1">
+              <a:rPr sz="1600" b="1" dirty="0">
                 <a:solidFill>
                   <a:srgbClr val="FFFFFF"/>
                 </a:solidFill>
@@ -4460,13 +4601,18 @@
               <a:t>• Phase 1 Foundation: </a:t>
             </a:r>
             <a:r>
-              <a:rPr sz="1150">
+              <a:rPr sz="1600" dirty="0">
                 <a:solidFill>
                   <a:srgbClr val="CDD2DC"/>
                 </a:solidFill>
               </a:rPr>
               <a:t>Established responsive video card grids, category chips, and external links.</a:t>
             </a:r>
+            <a:endParaRPr lang="en-IN" sz="1600" dirty="0">
+              <a:solidFill>
+                <a:srgbClr val="CDD2DC"/>
+              </a:solidFill>
+            </a:endParaRPr>
           </a:p>
           <a:p>
             <a:pPr>
@@ -4474,8 +4620,20 @@
                 <a:spcPts val="800"/>
               </a:spcAft>
             </a:pPr>
-            <a:r>
-              <a:rPr sz="1150" b="1">
+            <a:endParaRPr sz="1600" dirty="0">
+              <a:solidFill>
+                <a:srgbClr val="CDD2DC"/>
+              </a:solidFill>
+            </a:endParaRPr>
+          </a:p>
+          <a:p>
+            <a:pPr>
+              <a:spcAft>
+                <a:spcPts val="800"/>
+              </a:spcAft>
+            </a:pPr>
+            <a:r>
+              <a:rPr sz="1600" b="1" dirty="0">
                 <a:solidFill>
                   <a:srgbClr val="FFFFFF"/>
                 </a:solidFill>
@@ -4483,13 +4641,50 @@
               <a:t>• Phase 2 Transition: </a:t>
             </a:r>
             <a:r>
-              <a:rPr sz="1150">
-                <a:solidFill>
-                  <a:srgbClr val="CDD2DC"/>
-                </a:solidFill>
-              </a:rPr>
-              <a:t>Elevated PheW TuBe into an authentic, stateful Single Page Application (SPA).</a:t>
-            </a:r>
+              <a:rPr sz="1600" dirty="0">
+                <a:solidFill>
+                  <a:srgbClr val="CDD2DC"/>
+                </a:solidFill>
+              </a:rPr>
+              <a:t>Elevated </a:t>
+            </a:r>
+            <a:r>
+              <a:rPr sz="1600" dirty="0" err="1">
+                <a:solidFill>
+                  <a:srgbClr val="CDD2DC"/>
+                </a:solidFill>
+              </a:rPr>
+              <a:t>PheW</a:t>
+            </a:r>
+            <a:r>
+              <a:rPr sz="1600" dirty="0">
+                <a:solidFill>
+                  <a:srgbClr val="CDD2DC"/>
+                </a:solidFill>
+              </a:rPr>
+              <a:t> </a:t>
+            </a:r>
+            <a:r>
+              <a:rPr sz="1600" dirty="0" err="1">
+                <a:solidFill>
+                  <a:srgbClr val="CDD2DC"/>
+                </a:solidFill>
+              </a:rPr>
+              <a:t>TuBe</a:t>
+            </a:r>
+            <a:r>
+              <a:rPr sz="1600" dirty="0">
+                <a:solidFill>
+                  <a:srgbClr val="CDD2DC"/>
+                </a:solidFill>
+              </a:rPr>
+              <a:t> into an authentic, stateful Single Page Application (SPA).</a:t>
+            </a:r>
+            <a:endParaRPr lang="en-IN" sz="1600" dirty="0">
+              <a:solidFill>
+                <a:srgbClr val="CDD2DC"/>
+              </a:solidFill>
+            </a:endParaRPr>
           </a:p>
           <a:p>
             <a:pPr>
@@ -4497,8 +4692,20 @@
                 <a:spcPts val="800"/>
               </a:spcAft>
             </a:pPr>
-            <a:r>
-              <a:rPr sz="1150" b="1">
+            <a:endParaRPr sz="1600" dirty="0">
+              <a:solidFill>
+                <a:srgbClr val="CDD2DC"/>
+              </a:solidFill>
+            </a:endParaRPr>
+          </a:p>
+          <a:p>
+            <a:pPr>
+              <a:spcAft>
+                <a:spcPts val="800"/>
+              </a:spcAft>
+            </a:pPr>
+            <a:r>
+              <a:rPr sz="1600" b="1" dirty="0">
                 <a:solidFill>
                   <a:srgbClr val="FFFFFF"/>
                 </a:solidFill>
@@ -4506,7 +4713,7 @@
               <a:t>• Zero Page Reloads: </a:t>
             </a:r>
             <a:r>
-              <a:rPr sz="1150">
+              <a:rPr sz="1600" dirty="0">
                 <a:solidFill>
                   <a:srgbClr val="CDD2DC"/>
                 </a:solidFill>
@@ -4558,6 +4765,7 @@
           <a:lstStyle/>
           <a:p>
             <a:pPr algn="ctr"/>
+            <a:endParaRPr/>
           </a:p>
         </p:txBody>
       </p:sp>
@@ -4570,7 +4778,7 @@
         <p:spPr>
           <a:xfrm>
             <a:off x="4604918" y="1490472"/>
-            <a:ext cx="2980944" cy="4334255"/>
+            <a:ext cx="2980944" cy="3985706"/>
           </a:xfrm>
           <a:prstGeom prst="rect">
             <a:avLst/>
@@ -4578,12 +4786,12 @@
           <a:noFill/>
         </p:spPr>
         <p:txBody>
-          <a:bodyPr wrap="square" tIns="0" bIns="0" lIns="0" rIns="0">
+          <a:bodyPr wrap="square" lIns="0" tIns="0" rIns="0" bIns="0">
             <a:spAutoFit/>
           </a:bodyPr>
           <a:lstStyle/>
           <a:p>
-            <a:pPr>
+            <a:pPr algn="ctr">
               <a:spcAft>
                 <a:spcPts val="1000"/>
               </a:spcAft>
@@ -4594,6 +4802,7 @@
               </a:defRPr>
             </a:pPr>
             <a:r>
+              <a:rPr sz="1600" i="1" u="sng" dirty="0"/>
               <a:t>Core Technical Objectives</a:t>
             </a:r>
           </a:p>
@@ -4604,7 +4813,7 @@
               </a:spcAft>
             </a:pPr>
             <a:r>
-              <a:rPr sz="1150" b="1">
+              <a:rPr sz="1600" b="1" dirty="0">
                 <a:solidFill>
                   <a:srgbClr val="FFFFFF"/>
                 </a:solidFill>
@@ -4612,13 +4821,34 @@
               <a:t>• In-Site Streaming: </a:t>
             </a:r>
             <a:r>
-              <a:rPr sz="1150">
-                <a:solidFill>
-                  <a:srgbClr val="CDD2DC"/>
-                </a:solidFill>
-              </a:rPr>
-              <a:t>Deep link /watch/:id powered by useParams() with embedded 16:9 streaming.</a:t>
-            </a:r>
+              <a:rPr sz="1600" dirty="0">
+                <a:solidFill>
+                  <a:srgbClr val="CDD2DC"/>
+                </a:solidFill>
+              </a:rPr>
+              <a:t>Deep link /watch/:id powered by </a:t>
+            </a:r>
+            <a:r>
+              <a:rPr sz="1600" dirty="0" err="1">
+                <a:solidFill>
+                  <a:srgbClr val="CDD2DC"/>
+                </a:solidFill>
+              </a:rPr>
+              <a:t>useParams</a:t>
+            </a:r>
+            <a:r>
+              <a:rPr sz="1600" dirty="0">
+                <a:solidFill>
+                  <a:srgbClr val="CDD2DC"/>
+                </a:solidFill>
+              </a:rPr>
+              <a:t>() with embedded 16:9 streaming.</a:t>
+            </a:r>
+            <a:endParaRPr lang="en-IN" sz="1600" dirty="0">
+              <a:solidFill>
+                <a:srgbClr val="CDD2DC"/>
+              </a:solidFill>
+            </a:endParaRPr>
           </a:p>
           <a:p>
             <a:pPr>
@@ -4626,22 +4856,55 @@
                 <a:spcPts val="800"/>
               </a:spcAft>
             </a:pPr>
-            <a:r>
-              <a:rPr sz="1150" b="1">
+            <a:endParaRPr sz="1600" dirty="0">
+              <a:solidFill>
+                <a:srgbClr val="CDD2DC"/>
+              </a:solidFill>
+            </a:endParaRPr>
+          </a:p>
+          <a:p>
+            <a:pPr>
+              <a:spcAft>
+                <a:spcPts val="800"/>
+              </a:spcAft>
+            </a:pPr>
+            <a:r>
+              <a:rPr sz="1600" b="1" dirty="0">
                 <a:solidFill>
                   <a:srgbClr val="FFFFFF"/>
                 </a:solidFill>
               </a:rPr>
-              <a:t>• DOM Control via useRef: </a:t>
-            </a:r>
-            <a:r>
-              <a:rPr sz="1150">
+              <a:t>• DOM Control via </a:t>
+            </a:r>
+            <a:r>
+              <a:rPr sz="1600" b="1" dirty="0" err="1">
+                <a:solidFill>
+                  <a:srgbClr val="FFFFFF"/>
+                </a:solidFill>
+              </a:rPr>
+              <a:t>useRef</a:t>
+            </a:r>
+            <a:r>
+              <a:rPr sz="1600" b="1" dirty="0">
+                <a:solidFill>
+                  <a:srgbClr val="FFFFFF"/>
+                </a:solidFill>
+              </a:rPr>
+              <a:t>: </a:t>
+            </a:r>
+            <a:r>
+              <a:rPr sz="1600" dirty="0">
                 <a:solidFill>
                   <a:srgbClr val="CDD2DC"/>
                 </a:solidFill>
               </a:rPr>
               <a:t>Direct focus on comment inputs and auto-scroll control without synthetic re-renders.</a:t>
             </a:r>
+            <a:endParaRPr lang="en-IN" sz="1600" dirty="0">
+              <a:solidFill>
+                <a:srgbClr val="CDD2DC"/>
+              </a:solidFill>
+            </a:endParaRPr>
           </a:p>
           <a:p>
             <a:pPr>
@@ -4649,8 +4912,20 @@
                 <a:spcPts val="800"/>
               </a:spcAft>
             </a:pPr>
-            <a:r>
-              <a:rPr sz="1150" b="1">
+            <a:endParaRPr sz="1600" dirty="0">
+              <a:solidFill>
+                <a:srgbClr val="CDD2DC"/>
+              </a:solidFill>
+            </a:endParaRPr>
+          </a:p>
+          <a:p>
+            <a:pPr>
+              <a:spcAft>
+                <a:spcPts val="800"/>
+              </a:spcAft>
+            </a:pPr>
+            <a:r>
+              <a:rPr sz="1600" b="1" dirty="0">
                 <a:solidFill>
                   <a:srgbClr val="FFFFFF"/>
                 </a:solidFill>
@@ -4658,7 +4933,7 @@
               <a:t>• Global Context API: </a:t>
             </a:r>
             <a:r>
-              <a:rPr sz="1150">
+              <a:rPr sz="1600" dirty="0">
                 <a:solidFill>
                   <a:srgbClr val="CDD2DC"/>
                 </a:solidFill>
@@ -4710,6 +4985,7 @@
           <a:lstStyle/>
           <a:p>
             <a:pPr algn="ctr"/>
+            <a:endParaRPr/>
           </a:p>
         </p:txBody>
       </p:sp>
@@ -4722,7 +4998,7 @@
         <p:spPr>
           <a:xfrm>
             <a:off x="8278063" y="1490472"/>
-            <a:ext cx="2980944" cy="4334255"/>
+            <a:ext cx="2980944" cy="3493264"/>
           </a:xfrm>
           <a:prstGeom prst="rect">
             <a:avLst/>
@@ -4730,12 +5006,12 @@
           <a:noFill/>
         </p:spPr>
         <p:txBody>
-          <a:bodyPr wrap="square" tIns="0" bIns="0" lIns="0" rIns="0">
+          <a:bodyPr wrap="square" lIns="0" tIns="0" rIns="0" bIns="0">
             <a:spAutoFit/>
           </a:bodyPr>
           <a:lstStyle/>
           <a:p>
-            <a:pPr>
+            <a:pPr algn="ctr">
               <a:spcAft>
                 <a:spcPts val="1000"/>
               </a:spcAft>
@@ -4746,6 +5022,7 @@
               </a:defRPr>
             </a:pPr>
             <a:r>
+              <a:rPr sz="1600" i="1" u="sng" dirty="0"/>
               <a:t>User Experience &amp; Realism</a:t>
             </a:r>
           </a:p>
@@ -4756,7 +5033,7 @@
               </a:spcAft>
             </a:pPr>
             <a:r>
-              <a:rPr sz="1150" b="1">
+              <a:rPr sz="1600" b="1" dirty="0">
                 <a:solidFill>
                   <a:srgbClr val="FFFFFF"/>
                 </a:solidFill>
@@ -4764,13 +5041,34 @@
               <a:t>• Up-Next Queue: </a:t>
             </a:r>
             <a:r>
-              <a:rPr sz="1150">
-                <a:solidFill>
-                  <a:srgbClr val="CDD2DC"/>
-                </a:solidFill>
-              </a:rPr>
-              <a:t>Dynamic video swapping via useNavigate() with synchronized channel metadata.</a:t>
-            </a:r>
+              <a:rPr sz="1600" dirty="0">
+                <a:solidFill>
+                  <a:srgbClr val="CDD2DC"/>
+                </a:solidFill>
+              </a:rPr>
+              <a:t>Dynamic video swapping via </a:t>
+            </a:r>
+            <a:r>
+              <a:rPr sz="1600" dirty="0" err="1">
+                <a:solidFill>
+                  <a:srgbClr val="CDD2DC"/>
+                </a:solidFill>
+              </a:rPr>
+              <a:t>useNavigate</a:t>
+            </a:r>
+            <a:r>
+              <a:rPr sz="1600" dirty="0">
+                <a:solidFill>
+                  <a:srgbClr val="CDD2DC"/>
+                </a:solidFill>
+              </a:rPr>
+              <a:t>() with synchronized channel metadata.</a:t>
+            </a:r>
+            <a:endParaRPr lang="en-IN" sz="1600" dirty="0">
+              <a:solidFill>
+                <a:srgbClr val="CDD2DC"/>
+              </a:solidFill>
+            </a:endParaRPr>
           </a:p>
           <a:p>
             <a:pPr>
@@ -4778,8 +5076,20 @@
                 <a:spcPts val="800"/>
               </a:spcAft>
             </a:pPr>
-            <a:r>
-              <a:rPr sz="1150" b="1">
+            <a:endParaRPr sz="1600" dirty="0">
+              <a:solidFill>
+                <a:srgbClr val="CDD2DC"/>
+              </a:solidFill>
+            </a:endParaRPr>
+          </a:p>
+          <a:p>
+            <a:pPr>
+              <a:spcAft>
+                <a:spcPts val="800"/>
+              </a:spcAft>
+            </a:pPr>
+            <a:r>
+              <a:rPr sz="1600" b="1" dirty="0">
                 <a:solidFill>
                   <a:srgbClr val="FFFFFF"/>
                 </a:solidFill>
@@ -4787,13 +5097,18 @@
               <a:t>• Working Action Controls: </a:t>
             </a:r>
             <a:r>
-              <a:rPr sz="1150">
+              <a:rPr sz="1600" dirty="0">
                 <a:solidFill>
                   <a:srgbClr val="CDD2DC"/>
                 </a:solidFill>
               </a:rPr>
               <a:t>Real Like increments, Share link copier, and Watch Later bookmarking.</a:t>
             </a:r>
+            <a:endParaRPr lang="en-IN" sz="1600" dirty="0">
+              <a:solidFill>
+                <a:srgbClr val="CDD2DC"/>
+              </a:solidFill>
+            </a:endParaRPr>
           </a:p>
           <a:p>
             <a:pPr>
@@ -4801,8 +5116,20 @@
                 <a:spcPts val="800"/>
               </a:spcAft>
             </a:pPr>
-            <a:r>
-              <a:rPr sz="1150" b="1">
+            <a:endParaRPr sz="1600" dirty="0">
+              <a:solidFill>
+                <a:srgbClr val="CDD2DC"/>
+              </a:solidFill>
+            </a:endParaRPr>
+          </a:p>
+          <a:p>
+            <a:pPr>
+              <a:spcAft>
+                <a:spcPts val="800"/>
+              </a:spcAft>
+            </a:pPr>
+            <a:r>
+              <a:rPr sz="1600" b="1" dirty="0">
                 <a:solidFill>
                   <a:srgbClr val="FFFFFF"/>
                 </a:solidFill>
@@ -4810,7 +5137,7 @@
               <a:t>• Responsive Parity: </a:t>
             </a:r>
             <a:r>
-              <a:rPr sz="1150">
+              <a:rPr sz="1600" dirty="0">
                 <a:solidFill>
                   <a:srgbClr val="CDD2DC"/>
                 </a:solidFill>
@@ -4825,14 +5152,14 @@
   <p:clrMapOvr>
     <a:masterClrMapping/>
   </p:clrMapOvr>
-  <p:transition spd="fast">
-    <p:push dir="l"/>
+  <p:transition>
+    <p:push/>
   </p:transition>
 </p:sld>
 </file>
 
 <file path=ppt/slides/slide3.xml><?xml version="1.0" encoding="utf-8"?>
-<p:sld xmlns:a="http://schemas.openxmlformats.org/drawingml/2006/main" xmlns:p="http://schemas.openxmlformats.org/presentationml/2006/main" xmlns:r="http://schemas.openxmlformats.org/officeDocument/2006/relationships">
+<p:sld xmlns:a="http://schemas.openxmlformats.org/drawingml/2006/main" xmlns:r="http://schemas.openxmlformats.org/officeDocument/2006/relationships" xmlns:p="http://schemas.openxmlformats.org/presentationml/2006/main">
   <p:cSld>
     <p:spTree>
       <p:nvGrpSpPr>
@@ -4840,7 +5167,14 @@
         <p:cNvGrpSpPr/>
         <p:nvPr/>
       </p:nvGrpSpPr>
-      <p:grpSpPr/>
+      <p:grpSpPr>
+        <a:xfrm>
+          <a:off x="0" y="0"/>
+          <a:ext cx="0" cy="0"/>
+          <a:chOff x="0" y="0"/>
+          <a:chExt cx="0" cy="0"/>
+        </a:xfrm>
+      </p:grpSpPr>
       <p:sp>
         <p:nvSpPr>
           <p:cNvPr id="2" name="Rectangle 1"/>
@@ -4881,6 +5215,7 @@
           <a:lstStyle/>
           <a:p>
             <a:pPr algn="ctr"/>
+            <a:endParaRPr/>
           </a:p>
         </p:txBody>
       </p:sp>
@@ -4924,6 +5259,7 @@
           <a:lstStyle/>
           <a:p>
             <a:pPr algn="ctr"/>
+            <a:endParaRPr/>
           </a:p>
         </p:txBody>
       </p:sp>
@@ -4971,7 +5307,7 @@
         <p:spPr>
           <a:xfrm>
             <a:off x="731520" y="621792"/>
-            <a:ext cx="10728655" cy="594360"/>
+            <a:ext cx="10728655" cy="461665"/>
           </a:xfrm>
           <a:prstGeom prst="rect">
             <a:avLst/>
@@ -4992,6 +5328,7 @@
               </a:defRPr>
             </a:pPr>
             <a:r>
+              <a:rPr sz="2400" i="1" u="sng" dirty="0"/>
               <a:t>Syllabus-Aligned Technology Stack &amp; Architecture</a:t>
             </a:r>
           </a:p>
@@ -5074,6 +5411,7 @@
           <a:lstStyle/>
           <a:p>
             <a:pPr algn="ctr"/>
+            <a:endParaRPr/>
           </a:p>
         </p:txBody>
       </p:sp>
@@ -5086,7 +5424,7 @@
         <p:spPr>
           <a:xfrm>
             <a:off x="932688" y="1490472"/>
-            <a:ext cx="3026664" cy="1911096"/>
+            <a:ext cx="3026664" cy="1667123"/>
           </a:xfrm>
           <a:prstGeom prst="rect">
             <a:avLst/>
@@ -5094,12 +5432,12 @@
           <a:noFill/>
         </p:spPr>
         <p:txBody>
-          <a:bodyPr wrap="square" tIns="0" bIns="0" lIns="0" rIns="0">
+          <a:bodyPr wrap="square" lIns="0" tIns="0" rIns="0" bIns="0">
             <a:spAutoFit/>
           </a:bodyPr>
           <a:lstStyle/>
           <a:p>
-            <a:pPr>
+            <a:pPr algn="ctr">
               <a:spcAft>
                 <a:spcPts val="1000"/>
               </a:spcAft>
@@ -5110,6 +5448,7 @@
               </a:defRPr>
             </a:pPr>
             <a:r>
+              <a:rPr sz="1600" i="1" u="sng" dirty="0"/>
               <a:t>React 18 (Core SPA Engine)</a:t>
             </a:r>
           </a:p>
@@ -5120,7 +5459,7 @@
               </a:spcAft>
             </a:pPr>
             <a:r>
-              <a:rPr sz="1050">
+              <a:rPr sz="1600" dirty="0">
                 <a:solidFill>
                   <a:srgbClr val="CDD2DC"/>
                 </a:solidFill>
@@ -5135,7 +5474,7 @@
               </a:spcAft>
             </a:pPr>
             <a:r>
-              <a:rPr sz="1050">
+              <a:rPr sz="1600" dirty="0">
                 <a:solidFill>
                   <a:srgbClr val="CDD2DC"/>
                 </a:solidFill>
@@ -5150,7 +5489,7 @@
               </a:spcAft>
             </a:pPr>
             <a:r>
-              <a:rPr sz="1050">
+              <a:rPr sz="1600" dirty="0">
                 <a:solidFill>
                   <a:srgbClr val="CDD2DC"/>
                 </a:solidFill>
@@ -5165,7 +5504,7 @@
               </a:spcAft>
             </a:pPr>
             <a:r>
-              <a:rPr sz="1050" b="1">
+              <a:rPr sz="1600" b="1" dirty="0">
                 <a:solidFill>
                   <a:srgbClr val="FFFFFF"/>
                 </a:solidFill>
@@ -5173,12 +5512,52 @@
               <a:t>• Hooks: </a:t>
             </a:r>
             <a:r>
-              <a:rPr sz="1050">
-                <a:solidFill>
-                  <a:srgbClr val="CDD2DC"/>
-                </a:solidFill>
-              </a:rPr>
-              <a:t>useState, useEffect, useRef.</a:t>
+              <a:rPr sz="1600" dirty="0" err="1">
+                <a:solidFill>
+                  <a:srgbClr val="CDD2DC"/>
+                </a:solidFill>
+              </a:rPr>
+              <a:t>useState</a:t>
+            </a:r>
+            <a:r>
+              <a:rPr sz="1600" dirty="0">
+                <a:solidFill>
+                  <a:srgbClr val="CDD2DC"/>
+                </a:solidFill>
+              </a:rPr>
+              <a:t>, </a:t>
+            </a:r>
+            <a:r>
+              <a:rPr sz="1600" dirty="0" err="1">
+                <a:solidFill>
+                  <a:srgbClr val="CDD2DC"/>
+                </a:solidFill>
+              </a:rPr>
+              <a:t>useEffect</a:t>
+            </a:r>
+            <a:r>
+              <a:rPr sz="1600" dirty="0">
+                <a:solidFill>
+                  <a:srgbClr val="CDD2DC"/>
+                </a:solidFill>
+              </a:rPr>
+              <a:t>, </a:t>
+            </a:r>
+            <a:r>
+              <a:rPr sz="1600" dirty="0" err="1">
+                <a:solidFill>
+                  <a:srgbClr val="CDD2DC"/>
+                </a:solidFill>
+              </a:rPr>
+              <a:t>useRef</a:t>
+            </a:r>
+            <a:r>
+              <a:rPr sz="1600" dirty="0">
+                <a:solidFill>
+                  <a:srgbClr val="CDD2DC"/>
+                </a:solidFill>
+              </a:rPr>
+              <a:t>.</a:t>
             </a:r>
           </a:p>
         </p:txBody>
@@ -5225,6 +5604,7 @@
           <a:lstStyle/>
           <a:p>
             <a:pPr algn="ctr"/>
+            <a:endParaRPr/>
           </a:p>
         </p:txBody>
       </p:sp>
@@ -5237,7 +5617,7 @@
         <p:spPr>
           <a:xfrm>
             <a:off x="4572000" y="1490472"/>
-            <a:ext cx="3026664" cy="1911096"/>
+            <a:ext cx="3026664" cy="1759456"/>
           </a:xfrm>
           <a:prstGeom prst="rect">
             <a:avLst/>
@@ -5245,12 +5625,12 @@
           <a:noFill/>
         </p:spPr>
         <p:txBody>
-          <a:bodyPr wrap="square" tIns="0" bIns="0" lIns="0" rIns="0">
+          <a:bodyPr wrap="square" lIns="0" tIns="0" rIns="0" bIns="0">
             <a:spAutoFit/>
           </a:bodyPr>
           <a:lstStyle/>
           <a:p>
-            <a:pPr>
+            <a:pPr algn="ctr">
               <a:spcAft>
                 <a:spcPts val="1000"/>
               </a:spcAft>
@@ -5261,6 +5641,7 @@
               </a:defRPr>
             </a:pPr>
             <a:r>
+              <a:rPr sz="1600" i="1" u="sng" dirty="0"/>
               <a:t>React Router v6</a:t>
             </a:r>
           </a:p>
@@ -5271,7 +5652,7 @@
               </a:spcAft>
             </a:pPr>
             <a:r>
-              <a:rPr sz="1050">
+              <a:rPr sz="1400" dirty="0">
                 <a:solidFill>
                   <a:srgbClr val="CDD2DC"/>
                 </a:solidFill>
@@ -5286,7 +5667,7 @@
               </a:spcAft>
             </a:pPr>
             <a:r>
-              <a:rPr sz="1050">
+              <a:rPr sz="1400" dirty="0">
                 <a:solidFill>
                   <a:srgbClr val="CDD2DC"/>
                 </a:solidFill>
@@ -5301,12 +5682,28 @@
               </a:spcAft>
             </a:pPr>
             <a:r>
-              <a:rPr sz="1050">
-                <a:solidFill>
-                  <a:srgbClr val="CDD2DC"/>
-                </a:solidFill>
-              </a:rPr>
-              <a:t>• Declarative &lt;ProtectedRoute /&gt; security.</a:t>
+              <a:rPr sz="1400" dirty="0">
+                <a:solidFill>
+                  <a:srgbClr val="CDD2DC"/>
+                </a:solidFill>
+              </a:rPr>
+              <a:t>• Declarative &lt;</a:t>
+            </a:r>
+            <a:r>
+              <a:rPr sz="1400" dirty="0" err="1">
+                <a:solidFill>
+                  <a:srgbClr val="CDD2DC"/>
+                </a:solidFill>
+              </a:rPr>
+              <a:t>ProtectedRoute</a:t>
+            </a:r>
+            <a:r>
+              <a:rPr sz="1400" dirty="0">
+                <a:solidFill>
+                  <a:srgbClr val="CDD2DC"/>
+                </a:solidFill>
+              </a:rPr>
+              <a:t> /&gt; security.</a:t>
             </a:r>
           </a:p>
           <a:p>
@@ -5316,12 +5713,28 @@
               </a:spcAft>
             </a:pPr>
             <a:r>
-              <a:rPr sz="1050">
-                <a:solidFill>
-                  <a:srgbClr val="CDD2DC"/>
-                </a:solidFill>
-              </a:rPr>
-              <a:t>• Seamless useNavigate() transitions.</a:t>
+              <a:rPr sz="1400" dirty="0">
+                <a:solidFill>
+                  <a:srgbClr val="CDD2DC"/>
+                </a:solidFill>
+              </a:rPr>
+              <a:t>• Seamless </a:t>
+            </a:r>
+            <a:r>
+              <a:rPr sz="1400" dirty="0" err="1">
+                <a:solidFill>
+                  <a:srgbClr val="CDD2DC"/>
+                </a:solidFill>
+              </a:rPr>
+              <a:t>useNavigate</a:t>
+            </a:r>
+            <a:r>
+              <a:rPr sz="1400" dirty="0">
+                <a:solidFill>
+                  <a:srgbClr val="CDD2DC"/>
+                </a:solidFill>
+              </a:rPr>
+              <a:t>() transitions.</a:t>
             </a:r>
           </a:p>
         </p:txBody>
@@ -5368,6 +5781,7 @@
           <a:lstStyle/>
           <a:p>
             <a:pPr algn="ctr"/>
+            <a:endParaRPr/>
           </a:p>
         </p:txBody>
       </p:sp>
@@ -5379,8 +5793,8 @@
         </p:nvSpPr>
         <p:spPr>
           <a:xfrm>
-            <a:off x="8211312" y="1490472"/>
-            <a:ext cx="3026664" cy="1911096"/>
+            <a:off x="8211312" y="1554481"/>
+            <a:ext cx="3026664" cy="1544012"/>
           </a:xfrm>
           <a:prstGeom prst="rect">
             <a:avLst/>
@@ -5388,12 +5802,12 @@
           <a:noFill/>
         </p:spPr>
         <p:txBody>
-          <a:bodyPr wrap="square" tIns="0" bIns="0" lIns="0" rIns="0">
+          <a:bodyPr wrap="square" lIns="0" tIns="0" rIns="0" bIns="0">
             <a:spAutoFit/>
           </a:bodyPr>
           <a:lstStyle/>
           <a:p>
-            <a:pPr>
+            <a:pPr algn="ctr">
               <a:spcAft>
                 <a:spcPts val="1000"/>
               </a:spcAft>
@@ -5404,6 +5818,7 @@
               </a:defRPr>
             </a:pPr>
             <a:r>
+              <a:rPr sz="1600" i="1" u="sng" dirty="0"/>
               <a:t>Tailwind CSS 3</a:t>
             </a:r>
           </a:p>
@@ -5414,7 +5829,7 @@
               </a:spcAft>
             </a:pPr>
             <a:r>
-              <a:rPr sz="1050">
+              <a:rPr sz="1400" dirty="0">
                 <a:solidFill>
                   <a:srgbClr val="CDD2DC"/>
                 </a:solidFill>
@@ -5429,7 +5844,7 @@
               </a:spcAft>
             </a:pPr>
             <a:r>
-              <a:rPr sz="1050">
+              <a:rPr sz="1400" dirty="0">
                 <a:solidFill>
                   <a:srgbClr val="CDD2DC"/>
                 </a:solidFill>
@@ -5444,7 +5859,7 @@
               </a:spcAft>
             </a:pPr>
             <a:r>
-              <a:rPr sz="1050">
+              <a:rPr sz="1400" dirty="0">
                 <a:solidFill>
                   <a:srgbClr val="CDD2DC"/>
                 </a:solidFill>
@@ -5459,12 +5874,20 @@
               </a:spcAft>
             </a:pPr>
             <a:r>
-              <a:rPr sz="1050">
-                <a:solidFill>
-                  <a:srgbClr val="CDD2DC"/>
-                </a:solidFill>
-              </a:rPr>
-              <a:t>• Strict YouTube aesthetics alignment.</a:t>
+              <a:rPr sz="1400" dirty="0">
+                <a:solidFill>
+                  <a:srgbClr val="CDD2DC"/>
+                </a:solidFill>
+              </a:rPr>
+              <a:t>• Strict YouTube aesthetics alignment</a:t>
+            </a:r>
+            <a:r>
+              <a:rPr sz="1050" dirty="0">
+                <a:solidFill>
+                  <a:srgbClr val="CDD2DC"/>
+                </a:solidFill>
+              </a:rPr>
+              <a:t>.</a:t>
             </a:r>
           </a:p>
         </p:txBody>
@@ -5511,6 +5934,7 @@
           <a:lstStyle/>
           <a:p>
             <a:pPr algn="ctr"/>
+            <a:endParaRPr/>
           </a:p>
         </p:txBody>
       </p:sp>
@@ -5523,7 +5947,7 @@
         <p:spPr>
           <a:xfrm>
             <a:off x="932688" y="3913631"/>
-            <a:ext cx="3026664" cy="1911096"/>
+            <a:ext cx="3026664" cy="1913344"/>
           </a:xfrm>
           <a:prstGeom prst="rect">
             <a:avLst/>
@@ -5531,12 +5955,12 @@
           <a:noFill/>
         </p:spPr>
         <p:txBody>
-          <a:bodyPr wrap="square" tIns="0" bIns="0" lIns="0" rIns="0">
+          <a:bodyPr wrap="square" lIns="0" tIns="0" rIns="0" bIns="0">
             <a:spAutoFit/>
           </a:bodyPr>
           <a:lstStyle/>
           <a:p>
-            <a:pPr>
+            <a:pPr algn="ctr">
               <a:spcAft>
                 <a:spcPts val="1000"/>
               </a:spcAft>
@@ -5547,8 +5971,14 @@
               </a:defRPr>
             </a:pPr>
             <a:r>
-              <a:t>Context API &amp; LocalStorage</a:t>
-            </a:r>
+              <a:rPr sz="1600" i="1" u="sng" dirty="0"/>
+              <a:t>Context API &amp; </a:t>
+            </a:r>
+            <a:r>
+              <a:rPr sz="1600" i="1" u="sng" dirty="0" err="1"/>
+              <a:t>LocalStorage</a:t>
+            </a:r>
+            <a:endParaRPr sz="1600" i="1" u="sng" dirty="0"/>
           </a:p>
           <a:p>
             <a:pPr>
@@ -5557,12 +5987,28 @@
               </a:spcAft>
             </a:pPr>
             <a:r>
-              <a:rPr sz="1050">
-                <a:solidFill>
-                  <a:srgbClr val="CDD2DC"/>
-                </a:solidFill>
-              </a:rPr>
-              <a:t>• Centralized global AppContext bus.</a:t>
+              <a:rPr sz="1600" dirty="0">
+                <a:solidFill>
+                  <a:srgbClr val="CDD2DC"/>
+                </a:solidFill>
+              </a:rPr>
+              <a:t>• Centralized global </a:t>
+            </a:r>
+            <a:r>
+              <a:rPr sz="1600" dirty="0" err="1">
+                <a:solidFill>
+                  <a:srgbClr val="CDD2DC"/>
+                </a:solidFill>
+              </a:rPr>
+              <a:t>AppContext</a:t>
+            </a:r>
+            <a:r>
+              <a:rPr sz="1600" dirty="0">
+                <a:solidFill>
+                  <a:srgbClr val="CDD2DC"/>
+                </a:solidFill>
+              </a:rPr>
+              <a:t> bus.</a:t>
             </a:r>
           </a:p>
           <a:p>
@@ -5572,7 +6018,7 @@
               </a:spcAft>
             </a:pPr>
             <a:r>
-              <a:rPr sz="1050">
+              <a:rPr sz="1600" dirty="0">
                 <a:solidFill>
                   <a:srgbClr val="CDD2DC"/>
                 </a:solidFill>
@@ -5587,7 +6033,7 @@
               </a:spcAft>
             </a:pPr>
             <a:r>
-              <a:rPr sz="1050">
+              <a:rPr sz="1600" dirty="0">
                 <a:solidFill>
                   <a:srgbClr val="CDD2DC"/>
                 </a:solidFill>
@@ -5602,7 +6048,7 @@
               </a:spcAft>
             </a:pPr>
             <a:r>
-              <a:rPr sz="1050">
+              <a:rPr sz="1600" dirty="0">
                 <a:solidFill>
                   <a:srgbClr val="CDD2DC"/>
                 </a:solidFill>
@@ -5654,6 +6100,7 @@
           <a:lstStyle/>
           <a:p>
             <a:pPr algn="ctr"/>
+            <a:endParaRPr/>
           </a:p>
         </p:txBody>
       </p:sp>
@@ -5666,7 +6113,7 @@
         <p:spPr>
           <a:xfrm>
             <a:off x="4572000" y="3913631"/>
-            <a:ext cx="3026664" cy="1911096"/>
+            <a:ext cx="3026664" cy="1544012"/>
           </a:xfrm>
           <a:prstGeom prst="rect">
             <a:avLst/>
@@ -5674,12 +6121,12 @@
           <a:noFill/>
         </p:spPr>
         <p:txBody>
-          <a:bodyPr wrap="square" tIns="0" bIns="0" lIns="0" rIns="0">
+          <a:bodyPr wrap="square" lIns="0" tIns="0" rIns="0" bIns="0">
             <a:spAutoFit/>
           </a:bodyPr>
           <a:lstStyle/>
           <a:p>
-            <a:pPr>
+            <a:pPr algn="ctr">
               <a:spcAft>
                 <a:spcPts val="1000"/>
               </a:spcAft>
@@ -5690,6 +6137,7 @@
               </a:defRPr>
             </a:pPr>
             <a:r>
+              <a:rPr sz="1600" i="1" u="sng" dirty="0"/>
               <a:t>YouTube Data API v3</a:t>
             </a:r>
           </a:p>
@@ -5700,7 +6148,7 @@
               </a:spcAft>
             </a:pPr>
             <a:r>
-              <a:rPr sz="1050">
+              <a:rPr sz="1400" dirty="0">
                 <a:solidFill>
                   <a:srgbClr val="CDD2DC"/>
                 </a:solidFill>
@@ -5715,7 +6163,7 @@
               </a:spcAft>
             </a:pPr>
             <a:r>
-              <a:rPr sz="1050">
+              <a:rPr sz="1400" dirty="0">
                 <a:solidFill>
                   <a:srgbClr val="CDD2DC"/>
                 </a:solidFill>
@@ -5730,7 +6178,7 @@
               </a:spcAft>
             </a:pPr>
             <a:r>
-              <a:rPr sz="1050">
+              <a:rPr sz="1400" dirty="0">
                 <a:solidFill>
                   <a:srgbClr val="CDD2DC"/>
                 </a:solidFill>
@@ -5745,7 +6193,7 @@
               </a:spcAft>
             </a:pPr>
             <a:r>
-              <a:rPr sz="1050">
+              <a:rPr sz="1400" dirty="0">
                 <a:solidFill>
                   <a:srgbClr val="CDD2DC"/>
                 </a:solidFill>
@@ -5797,6 +6245,7 @@
           <a:lstStyle/>
           <a:p>
             <a:pPr algn="ctr"/>
+            <a:endParaRPr/>
           </a:p>
         </p:txBody>
       </p:sp>
@@ -5809,7 +6258,7 @@
         <p:spPr>
           <a:xfrm>
             <a:off x="8211312" y="3913631"/>
-            <a:ext cx="3026664" cy="1911096"/>
+            <a:ext cx="3026664" cy="1759456"/>
           </a:xfrm>
           <a:prstGeom prst="rect">
             <a:avLst/>
@@ -5817,12 +6266,12 @@
           <a:noFill/>
         </p:spPr>
         <p:txBody>
-          <a:bodyPr wrap="square" tIns="0" bIns="0" lIns="0" rIns="0">
+          <a:bodyPr wrap="square" lIns="0" tIns="0" rIns="0" bIns="0">
             <a:spAutoFit/>
           </a:bodyPr>
           <a:lstStyle/>
           <a:p>
-            <a:pPr>
+            <a:pPr algn="ctr">
               <a:spcAft>
                 <a:spcPts val="1000"/>
               </a:spcAft>
@@ -5833,6 +6282,7 @@
               </a:defRPr>
             </a:pPr>
             <a:r>
+              <a:rPr sz="1600" i="1" u="sng" dirty="0"/>
               <a:t>Vite 5 (Build Tool)</a:t>
             </a:r>
           </a:p>
@@ -5843,7 +6293,7 @@
               </a:spcAft>
             </a:pPr>
             <a:r>
-              <a:rPr sz="1050">
+              <a:rPr sz="1400" dirty="0">
                 <a:solidFill>
                   <a:srgbClr val="CDD2DC"/>
                 </a:solidFill>
@@ -5858,7 +6308,7 @@
               </a:spcAft>
             </a:pPr>
             <a:r>
-              <a:rPr sz="1050">
+              <a:rPr sz="1400" dirty="0">
                 <a:solidFill>
                   <a:srgbClr val="CDD2DC"/>
                 </a:solidFill>
@@ -5873,7 +6323,7 @@
               </a:spcAft>
             </a:pPr>
             <a:r>
-              <a:rPr sz="1050">
+              <a:rPr sz="1400" dirty="0">
                 <a:solidFill>
                   <a:srgbClr val="CDD2DC"/>
                 </a:solidFill>
@@ -5888,7 +6338,7 @@
               </a:spcAft>
             </a:pPr>
             <a:r>
-              <a:rPr sz="1050">
+              <a:rPr sz="1400" dirty="0">
                 <a:solidFill>
                   <a:srgbClr val="CDD2DC"/>
                 </a:solidFill>
@@ -5903,14 +6353,14 @@
   <p:clrMapOvr>
     <a:masterClrMapping/>
   </p:clrMapOvr>
-  <p:transition spd="fast">
-    <p:push dir="l"/>
+  <p:transition>
+    <p:push/>
   </p:transition>
 </p:sld>
 </file>
 
 <file path=ppt/slides/slide4.xml><?xml version="1.0" encoding="utf-8"?>
-<p:sld xmlns:a="http://schemas.openxmlformats.org/drawingml/2006/main" xmlns:p="http://schemas.openxmlformats.org/presentationml/2006/main" xmlns:r="http://schemas.openxmlformats.org/officeDocument/2006/relationships">
+<p:sld xmlns:a="http://schemas.openxmlformats.org/drawingml/2006/main" xmlns:r="http://schemas.openxmlformats.org/officeDocument/2006/relationships" xmlns:p="http://schemas.openxmlformats.org/presentationml/2006/main">
   <p:cSld>
     <p:spTree>
       <p:nvGrpSpPr>
@@ -5918,7 +6368,14 @@
         <p:cNvGrpSpPr/>
         <p:nvPr/>
       </p:nvGrpSpPr>
-      <p:grpSpPr/>
+      <p:grpSpPr>
+        <a:xfrm>
+          <a:off x="0" y="0"/>
+          <a:ext cx="0" cy="0"/>
+          <a:chOff x="0" y="0"/>
+          <a:chExt cx="0" cy="0"/>
+        </a:xfrm>
+      </p:grpSpPr>
       <p:sp>
         <p:nvSpPr>
           <p:cNvPr id="2" name="Rectangle 1"/>
@@ -5959,6 +6416,7 @@
           <a:lstStyle/>
           <a:p>
             <a:pPr algn="ctr"/>
+            <a:endParaRPr/>
           </a:p>
         </p:txBody>
       </p:sp>
@@ -6002,6 +6460,7 @@
           <a:lstStyle/>
           <a:p>
             <a:pPr algn="ctr"/>
+            <a:endParaRPr/>
           </a:p>
         </p:txBody>
       </p:sp>
@@ -6049,7 +6508,7 @@
         <p:spPr>
           <a:xfrm>
             <a:off x="731520" y="621792"/>
-            <a:ext cx="10728655" cy="594360"/>
+            <a:ext cx="10728655" cy="523220"/>
           </a:xfrm>
           <a:prstGeom prst="rect">
             <a:avLst/>
@@ -6070,6 +6529,7 @@
               </a:defRPr>
             </a:pPr>
             <a:r>
+              <a:rPr sz="2800" i="1" u="sng" dirty="0"/>
               <a:t>Core Component Architecture &amp; Modularity</a:t>
             </a:r>
           </a:p>
@@ -6152,6 +6612,7 @@
           <a:lstStyle/>
           <a:p>
             <a:pPr algn="ctr"/>
+            <a:endParaRPr/>
           </a:p>
         </p:txBody>
       </p:sp>
@@ -6164,7 +6625,7 @@
         <p:spPr>
           <a:xfrm>
             <a:off x="932688" y="1490472"/>
-            <a:ext cx="3026664" cy="1911096"/>
+            <a:ext cx="3026664" cy="1544012"/>
           </a:xfrm>
           <a:prstGeom prst="rect">
             <a:avLst/>
@@ -6172,12 +6633,12 @@
           <a:noFill/>
         </p:spPr>
         <p:txBody>
-          <a:bodyPr wrap="square" tIns="0" bIns="0" lIns="0" rIns="0">
+          <a:bodyPr wrap="square" lIns="0" tIns="0" rIns="0" bIns="0">
             <a:spAutoFit/>
           </a:bodyPr>
           <a:lstStyle/>
           <a:p>
-            <a:pPr>
+            <a:pPr algn="ctr">
               <a:spcAft>
                 <a:spcPts val="1000"/>
               </a:spcAft>
@@ -6188,8 +6649,10 @@
               </a:defRPr>
             </a:pPr>
             <a:r>
+              <a:rPr sz="1600" i="1" u="sng" dirty="0" err="1"/>
               <a:t>Navbar.jsx</a:t>
             </a:r>
+            <a:endParaRPr sz="1600" i="1" u="sng" dirty="0"/>
           </a:p>
           <a:p>
             <a:pPr>
@@ -6198,7 +6661,7 @@
               </a:spcAft>
             </a:pPr>
             <a:r>
-              <a:rPr sz="1050">
+              <a:rPr sz="1400" dirty="0">
                 <a:solidFill>
                   <a:srgbClr val="CDD2DC"/>
                 </a:solidFill>
@@ -6213,7 +6676,7 @@
               </a:spcAft>
             </a:pPr>
             <a:r>
-              <a:rPr sz="1050">
+              <a:rPr sz="1400" dirty="0">
                 <a:solidFill>
                   <a:srgbClr val="CDD2DC"/>
                 </a:solidFill>
@@ -6228,7 +6691,7 @@
               </a:spcAft>
             </a:pPr>
             <a:r>
-              <a:rPr sz="1050">
+              <a:rPr sz="1400" dirty="0">
                 <a:solidFill>
                   <a:srgbClr val="CDD2DC"/>
                 </a:solidFill>
@@ -6243,12 +6706,20 @@
               </a:spcAft>
             </a:pPr>
             <a:r>
-              <a:rPr sz="1050">
-                <a:solidFill>
-                  <a:srgbClr val="CDD2DC"/>
-                </a:solidFill>
-              </a:rPr>
-              <a:t>• Collapsible hamburger drawer toggle.</a:t>
+              <a:rPr sz="1400" dirty="0">
+                <a:solidFill>
+                  <a:srgbClr val="CDD2DC"/>
+                </a:solidFill>
+              </a:rPr>
+              <a:t>• Collapsible hamburger drawer toggle</a:t>
+            </a:r>
+            <a:r>
+              <a:rPr sz="1050" dirty="0">
+                <a:solidFill>
+                  <a:srgbClr val="CDD2DC"/>
+                </a:solidFill>
+              </a:rPr>
+              <a:t>.</a:t>
             </a:r>
           </a:p>
         </p:txBody>
@@ -6295,6 +6766,7 @@
           <a:lstStyle/>
           <a:p>
             <a:pPr algn="ctr"/>
+            <a:endParaRPr/>
           </a:p>
         </p:txBody>
       </p:sp>
@@ -6307,7 +6779,7 @@
         <p:spPr>
           <a:xfrm>
             <a:off x="4572000" y="1490472"/>
-            <a:ext cx="3026664" cy="1911096"/>
+            <a:ext cx="3026664" cy="1759456"/>
           </a:xfrm>
           <a:prstGeom prst="rect">
             <a:avLst/>
@@ -6315,12 +6787,12 @@
           <a:noFill/>
         </p:spPr>
         <p:txBody>
-          <a:bodyPr wrap="square" tIns="0" bIns="0" lIns="0" rIns="0">
+          <a:bodyPr wrap="square" lIns="0" tIns="0" rIns="0" bIns="0">
             <a:spAutoFit/>
           </a:bodyPr>
           <a:lstStyle/>
           <a:p>
-            <a:pPr>
+            <a:pPr algn="ctr">
               <a:spcAft>
                 <a:spcPts val="1000"/>
               </a:spcAft>
@@ -6331,8 +6803,10 @@
               </a:defRPr>
             </a:pPr>
             <a:r>
+              <a:rPr sz="1600" i="1" u="sng" dirty="0" err="1"/>
               <a:t>Sidebar.jsx</a:t>
             </a:r>
+            <a:endParaRPr sz="1600" i="1" u="sng" dirty="0"/>
           </a:p>
           <a:p>
             <a:pPr>
@@ -6341,7 +6815,7 @@
               </a:spcAft>
             </a:pPr>
             <a:r>
-              <a:rPr sz="1050" b="1">
+              <a:rPr sz="1400" b="1" dirty="0">
                 <a:solidFill>
                   <a:srgbClr val="FFFFFF"/>
                 </a:solidFill>
@@ -6349,7 +6823,7 @@
               <a:t>• Main routes: </a:t>
             </a:r>
             <a:r>
-              <a:rPr sz="1050">
+              <a:rPr sz="1400" dirty="0">
                 <a:solidFill>
                   <a:srgbClr val="CDD2DC"/>
                 </a:solidFill>
@@ -6364,7 +6838,7 @@
               </a:spcAft>
             </a:pPr>
             <a:r>
-              <a:rPr sz="1050" b="1">
+              <a:rPr sz="1400" b="1" dirty="0">
                 <a:solidFill>
                   <a:srgbClr val="FFFFFF"/>
                 </a:solidFill>
@@ -6372,7 +6846,7 @@
               <a:t>• Protected: </a:t>
             </a:r>
             <a:r>
-              <a:rPr sz="1050">
+              <a:rPr sz="1400" dirty="0">
                 <a:solidFill>
                   <a:srgbClr val="CDD2DC"/>
                 </a:solidFill>
@@ -6387,7 +6861,7 @@
               </a:spcAft>
             </a:pPr>
             <a:r>
-              <a:rPr sz="1050">
+              <a:rPr sz="1400" dirty="0">
                 <a:solidFill>
                   <a:srgbClr val="CDD2DC"/>
                 </a:solidFill>
@@ -6402,7 +6876,7 @@
               </a:spcAft>
             </a:pPr>
             <a:r>
-              <a:rPr sz="1050">
+              <a:rPr sz="1400" dirty="0">
                 <a:solidFill>
                   <a:srgbClr val="CDD2DC"/>
                 </a:solidFill>
@@ -6454,6 +6928,7 @@
           <a:lstStyle/>
           <a:p>
             <a:pPr algn="ctr"/>
+            <a:endParaRPr/>
           </a:p>
         </p:txBody>
       </p:sp>
@@ -6466,7 +6941,7 @@
         <p:spPr>
           <a:xfrm>
             <a:off x="8211312" y="1490472"/>
-            <a:ext cx="3026664" cy="1911096"/>
+            <a:ext cx="3026664" cy="1544012"/>
           </a:xfrm>
           <a:prstGeom prst="rect">
             <a:avLst/>
@@ -6474,12 +6949,12 @@
           <a:noFill/>
         </p:spPr>
         <p:txBody>
-          <a:bodyPr wrap="square" tIns="0" bIns="0" lIns="0" rIns="0">
+          <a:bodyPr wrap="square" lIns="0" tIns="0" rIns="0" bIns="0">
             <a:spAutoFit/>
           </a:bodyPr>
           <a:lstStyle/>
           <a:p>
-            <a:pPr>
+            <a:pPr algn="ctr">
               <a:spcAft>
                 <a:spcPts val="1000"/>
               </a:spcAft>
@@ -6490,8 +6965,10 @@
               </a:defRPr>
             </a:pPr>
             <a:r>
+              <a:rPr sz="1600" i="1" u="sng" dirty="0" err="1"/>
               <a:t>VideoCard.jsx</a:t>
             </a:r>
+            <a:endParaRPr sz="1600" i="1" u="sng" dirty="0"/>
           </a:p>
           <a:p>
             <a:pPr>
@@ -6500,7 +6977,7 @@
               </a:spcAft>
             </a:pPr>
             <a:r>
-              <a:rPr sz="1050">
+              <a:rPr sz="1400" dirty="0">
                 <a:solidFill>
                   <a:srgbClr val="CDD2DC"/>
                 </a:solidFill>
@@ -6515,7 +6992,7 @@
               </a:spcAft>
             </a:pPr>
             <a:r>
-              <a:rPr sz="1050">
+              <a:rPr sz="1400" dirty="0">
                 <a:solidFill>
                   <a:srgbClr val="CDD2DC"/>
                 </a:solidFill>
@@ -6530,7 +7007,7 @@
               </a:spcAft>
             </a:pPr>
             <a:r>
-              <a:rPr sz="1050">
+              <a:rPr sz="1400" dirty="0">
                 <a:solidFill>
                   <a:srgbClr val="CDD2DC"/>
                 </a:solidFill>
@@ -6545,7 +7022,7 @@
               </a:spcAft>
             </a:pPr>
             <a:r>
-              <a:rPr sz="1050">
+              <a:rPr sz="1400" dirty="0">
                 <a:solidFill>
                   <a:srgbClr val="CDD2DC"/>
                 </a:solidFill>
@@ -6597,6 +7074,7 @@
           <a:lstStyle/>
           <a:p>
             <a:pPr algn="ctr"/>
+            <a:endParaRPr/>
           </a:p>
         </p:txBody>
       </p:sp>
@@ -6609,7 +7087,7 @@
         <p:spPr>
           <a:xfrm>
             <a:off x="932688" y="3913631"/>
-            <a:ext cx="3026664" cy="1911096"/>
+            <a:ext cx="3026664" cy="1759456"/>
           </a:xfrm>
           <a:prstGeom prst="rect">
             <a:avLst/>
@@ -6617,12 +7095,12 @@
           <a:noFill/>
         </p:spPr>
         <p:txBody>
-          <a:bodyPr wrap="square" tIns="0" bIns="0" lIns="0" rIns="0">
+          <a:bodyPr wrap="square" lIns="0" tIns="0" rIns="0" bIns="0">
             <a:spAutoFit/>
           </a:bodyPr>
           <a:lstStyle/>
           <a:p>
-            <a:pPr>
+            <a:pPr algn="ctr">
               <a:spcAft>
                 <a:spcPts val="1000"/>
               </a:spcAft>
@@ -6633,8 +7111,10 @@
               </a:defRPr>
             </a:pPr>
             <a:r>
+              <a:rPr sz="1600" i="1" u="sng" dirty="0" err="1"/>
               <a:t>WatchPage.jsx</a:t>
             </a:r>
+            <a:endParaRPr sz="1600" i="1" u="sng" dirty="0"/>
           </a:p>
           <a:p>
             <a:pPr>
@@ -6643,7 +7123,7 @@
               </a:spcAft>
             </a:pPr>
             <a:r>
-              <a:rPr sz="1050">
+              <a:rPr sz="1400" dirty="0">
                 <a:solidFill>
                   <a:srgbClr val="CDD2DC"/>
                 </a:solidFill>
@@ -6658,7 +7138,7 @@
               </a:spcAft>
             </a:pPr>
             <a:r>
-              <a:rPr sz="1050" b="1">
+              <a:rPr sz="1400" b="1" dirty="0">
                 <a:solidFill>
                   <a:srgbClr val="FFFFFF"/>
                 </a:solidFill>
@@ -6666,7 +7146,7 @@
               <a:t>• Action controls: </a:t>
             </a:r>
             <a:r>
-              <a:rPr sz="1050">
+              <a:rPr sz="1400" dirty="0">
                 <a:solidFill>
                   <a:srgbClr val="CDD2DC"/>
                 </a:solidFill>
@@ -6681,7 +7161,7 @@
               </a:spcAft>
             </a:pPr>
             <a:r>
-              <a:rPr sz="1050">
+              <a:rPr sz="1400" dirty="0">
                 <a:solidFill>
                   <a:srgbClr val="CDD2DC"/>
                 </a:solidFill>
@@ -6696,12 +7176,28 @@
               </a:spcAft>
             </a:pPr>
             <a:r>
-              <a:rPr sz="1050">
-                <a:solidFill>
-                  <a:srgbClr val="CDD2DC"/>
-                </a:solidFill>
-              </a:rPr>
-              <a:t>• Real-time useRef comment thread.</a:t>
+              <a:rPr sz="1400" dirty="0">
+                <a:solidFill>
+                  <a:srgbClr val="CDD2DC"/>
+                </a:solidFill>
+              </a:rPr>
+              <a:t>• Real-time </a:t>
+            </a:r>
+            <a:r>
+              <a:rPr sz="1400" dirty="0" err="1">
+                <a:solidFill>
+                  <a:srgbClr val="CDD2DC"/>
+                </a:solidFill>
+              </a:rPr>
+              <a:t>useRef</a:t>
+            </a:r>
+            <a:r>
+              <a:rPr sz="1400" dirty="0">
+                <a:solidFill>
+                  <a:srgbClr val="CDD2DC"/>
+                </a:solidFill>
+              </a:rPr>
+              <a:t> comment thread.</a:t>
             </a:r>
           </a:p>
         </p:txBody>
@@ -6748,6 +7244,7 @@
           <a:lstStyle/>
           <a:p>
             <a:pPr algn="ctr"/>
+            <a:endParaRPr/>
           </a:p>
         </p:txBody>
       </p:sp>
@@ -6760,7 +7257,7 @@
         <p:spPr>
           <a:xfrm>
             <a:off x="4572000" y="3913631"/>
-            <a:ext cx="3026664" cy="1911096"/>
+            <a:ext cx="3026664" cy="1544012"/>
           </a:xfrm>
           <a:prstGeom prst="rect">
             <a:avLst/>
@@ -6768,12 +7265,12 @@
           <a:noFill/>
         </p:spPr>
         <p:txBody>
-          <a:bodyPr wrap="square" tIns="0" bIns="0" lIns="0" rIns="0">
+          <a:bodyPr wrap="square" lIns="0" tIns="0" rIns="0" bIns="0">
             <a:spAutoFit/>
           </a:bodyPr>
           <a:lstStyle/>
           <a:p>
-            <a:pPr>
+            <a:pPr algn="ctr">
               <a:spcAft>
                 <a:spcPts val="1000"/>
               </a:spcAft>
@@ -6784,8 +7281,10 @@
               </a:defRPr>
             </a:pPr>
             <a:r>
+              <a:rPr sz="1600" i="1" u="sng" dirty="0" err="1"/>
               <a:t>AuthModal.jsx</a:t>
             </a:r>
+            <a:endParaRPr sz="1600" i="1" u="sng" dirty="0"/>
           </a:p>
           <a:p>
             <a:pPr>
@@ -6794,7 +7293,7 @@
               </a:spcAft>
             </a:pPr>
             <a:r>
-              <a:rPr sz="1050">
+              <a:rPr sz="1400" dirty="0">
                 <a:solidFill>
                   <a:srgbClr val="CDD2DC"/>
                 </a:solidFill>
@@ -6809,7 +7308,7 @@
               </a:spcAft>
             </a:pPr>
             <a:r>
-              <a:rPr sz="1050">
+              <a:rPr sz="1400" dirty="0">
                 <a:solidFill>
                   <a:srgbClr val="CDD2DC"/>
                 </a:solidFill>
@@ -6824,7 +7323,7 @@
               </a:spcAft>
             </a:pPr>
             <a:r>
-              <a:rPr sz="1050">
+              <a:rPr sz="1400" dirty="0">
                 <a:solidFill>
                   <a:srgbClr val="CDD2DC"/>
                 </a:solidFill>
@@ -6839,12 +7338,28 @@
               </a:spcAft>
             </a:pPr>
             <a:r>
-              <a:rPr sz="1050">
-                <a:solidFill>
-                  <a:srgbClr val="CDD2DC"/>
-                </a:solidFill>
-              </a:rPr>
-              <a:t>• Session persistence via LocalStorage.</a:t>
+              <a:rPr sz="1400" dirty="0">
+                <a:solidFill>
+                  <a:srgbClr val="CDD2DC"/>
+                </a:solidFill>
+              </a:rPr>
+              <a:t>• Session persistence via </a:t>
+            </a:r>
+            <a:r>
+              <a:rPr sz="1400" dirty="0" err="1">
+                <a:solidFill>
+                  <a:srgbClr val="CDD2DC"/>
+                </a:solidFill>
+              </a:rPr>
+              <a:t>LocalStorage</a:t>
+            </a:r>
+            <a:r>
+              <a:rPr sz="1400" dirty="0">
+                <a:solidFill>
+                  <a:srgbClr val="CDD2DC"/>
+                </a:solidFill>
+              </a:rPr>
+              <a:t>.</a:t>
             </a:r>
           </a:p>
         </p:txBody>
@@ -6891,6 +7406,7 @@
           <a:lstStyle/>
           <a:p>
             <a:pPr algn="ctr"/>
+            <a:endParaRPr/>
           </a:p>
         </p:txBody>
       </p:sp>
@@ -6903,7 +7419,7 @@
         <p:spPr>
           <a:xfrm>
             <a:off x="8211312" y="3913631"/>
-            <a:ext cx="3026664" cy="1911096"/>
+            <a:ext cx="3026664" cy="1544012"/>
           </a:xfrm>
           <a:prstGeom prst="rect">
             <a:avLst/>
@@ -6911,12 +7427,12 @@
           <a:noFill/>
         </p:spPr>
         <p:txBody>
-          <a:bodyPr wrap="square" tIns="0" bIns="0" lIns="0" rIns="0">
+          <a:bodyPr wrap="square" lIns="0" tIns="0" rIns="0" bIns="0">
             <a:spAutoFit/>
           </a:bodyPr>
           <a:lstStyle/>
           <a:p>
-            <a:pPr>
+            <a:pPr algn="ctr">
               <a:spcAft>
                 <a:spcPts val="1000"/>
               </a:spcAft>
@@ -6927,8 +7443,10 @@
               </a:defRPr>
             </a:pPr>
             <a:r>
+              <a:rPr sz="1600" i="1" u="sng" dirty="0" err="1"/>
               <a:t>SettingsModal.jsx</a:t>
             </a:r>
+            <a:endParaRPr sz="1600" i="1" u="sng" dirty="0"/>
           </a:p>
           <a:p>
             <a:pPr>
@@ -6937,7 +7455,7 @@
               </a:spcAft>
             </a:pPr>
             <a:r>
-              <a:rPr sz="1050">
+              <a:rPr sz="1400" dirty="0">
                 <a:solidFill>
                   <a:srgbClr val="CDD2DC"/>
                 </a:solidFill>
@@ -6952,7 +7470,7 @@
               </a:spcAft>
             </a:pPr>
             <a:r>
-              <a:rPr sz="1050">
+              <a:rPr sz="1400" dirty="0">
                 <a:solidFill>
                   <a:srgbClr val="CDD2DC"/>
                 </a:solidFill>
@@ -6967,7 +7485,7 @@
               </a:spcAft>
             </a:pPr>
             <a:r>
-              <a:rPr sz="1050">
+              <a:rPr sz="1400" dirty="0">
                 <a:solidFill>
                   <a:srgbClr val="CDD2DC"/>
                 </a:solidFill>
@@ -6982,7 +7500,7 @@
               </a:spcAft>
             </a:pPr>
             <a:r>
-              <a:rPr sz="1050">
+              <a:rPr sz="1400" dirty="0">
                 <a:solidFill>
                   <a:srgbClr val="CDD2DC"/>
                 </a:solidFill>
@@ -6997,14 +7515,14 @@
   <p:clrMapOvr>
     <a:masterClrMapping/>
   </p:clrMapOvr>
-  <p:transition spd="fast">
-    <p:push dir="l"/>
+  <p:transition>
+    <p:push/>
   </p:transition>
 </p:sld>
 </file>
 
 <file path=ppt/slides/slide5.xml><?xml version="1.0" encoding="utf-8"?>
-<p:sld xmlns:a="http://schemas.openxmlformats.org/drawingml/2006/main" xmlns:p="http://schemas.openxmlformats.org/presentationml/2006/main" xmlns:r="http://schemas.openxmlformats.org/officeDocument/2006/relationships">
+<p:sld xmlns:a="http://schemas.openxmlformats.org/drawingml/2006/main" xmlns:r="http://schemas.openxmlformats.org/officeDocument/2006/relationships" xmlns:p="http://schemas.openxmlformats.org/presentationml/2006/main">
   <p:cSld>
     <p:spTree>
       <p:nvGrpSpPr>
@@ -7012,7 +7530,14 @@
         <p:cNvGrpSpPr/>
         <p:nvPr/>
       </p:nvGrpSpPr>
-      <p:grpSpPr/>
+      <p:grpSpPr>
+        <a:xfrm>
+          <a:off x="0" y="0"/>
+          <a:ext cx="0" cy="0"/>
+          <a:chOff x="0" y="0"/>
+          <a:chExt cx="0" cy="0"/>
+        </a:xfrm>
+      </p:grpSpPr>
       <p:sp>
         <p:nvSpPr>
           <p:cNvPr id="2" name="Rectangle 1"/>
@@ -7053,6 +7578,7 @@
           <a:lstStyle/>
           <a:p>
             <a:pPr algn="ctr"/>
+            <a:endParaRPr/>
           </a:p>
         </p:txBody>
       </p:sp>
@@ -7096,6 +7622,7 @@
           <a:lstStyle/>
           <a:p>
             <a:pPr algn="ctr"/>
+            <a:endParaRPr/>
           </a:p>
         </p:txBody>
       </p:sp>
@@ -7143,7 +7670,7 @@
         <p:spPr>
           <a:xfrm>
             <a:off x="731520" y="621792"/>
-            <a:ext cx="10728655" cy="594360"/>
+            <a:ext cx="10728655" cy="523220"/>
           </a:xfrm>
           <a:prstGeom prst="rect">
             <a:avLst/>
@@ -7164,6 +7691,7 @@
               </a:defRPr>
             </a:pPr>
             <a:r>
+              <a:rPr sz="2800" i="1" u="sng" dirty="0"/>
               <a:t>In-Site Video Streaming Engine (/watch/:id) — No Redirecting</a:t>
             </a:r>
           </a:p>
@@ -7246,6 +7774,7 @@
           <a:lstStyle/>
           <a:p>
             <a:pPr algn="ctr"/>
+            <a:endParaRPr/>
           </a:p>
         </p:txBody>
       </p:sp>
@@ -7315,6 +7844,7 @@
           <a:lstStyle/>
           <a:p>
             <a:pPr algn="ctr"/>
+            <a:endParaRPr/>
           </a:p>
         </p:txBody>
       </p:sp>
@@ -7326,8 +7856,8 @@
         </p:nvSpPr>
         <p:spPr>
           <a:xfrm>
-            <a:off x="6449263" y="1490472"/>
-            <a:ext cx="4809744" cy="4334255"/>
+            <a:off x="6562683" y="1418525"/>
+            <a:ext cx="4582904" cy="4478149"/>
           </a:xfrm>
           <a:prstGeom prst="rect">
             <a:avLst/>
@@ -7335,12 +7865,12 @@
           <a:noFill/>
         </p:spPr>
         <p:txBody>
-          <a:bodyPr wrap="square" tIns="0" bIns="0" lIns="0" rIns="0">
+          <a:bodyPr wrap="square" lIns="0" tIns="0" rIns="0" bIns="0">
             <a:spAutoFit/>
           </a:bodyPr>
           <a:lstStyle/>
           <a:p>
-            <a:pPr>
+            <a:pPr algn="ctr">
               <a:spcAft>
                 <a:spcPts val="1000"/>
               </a:spcAft>
@@ -7351,6 +7881,7 @@
               </a:defRPr>
             </a:pPr>
             <a:r>
+              <a:rPr sz="1600" i="1" u="sng" dirty="0"/>
               <a:t>In-Site Streaming &amp; Action Controls</a:t>
             </a:r>
           </a:p>
@@ -7361,7 +7892,7 @@
               </a:spcAft>
             </a:pPr>
             <a:r>
-              <a:rPr sz="1100" b="1">
+              <a:rPr sz="1600" b="1" dirty="0">
                 <a:solidFill>
                   <a:srgbClr val="FFFFFF"/>
                 </a:solidFill>
@@ -7369,12 +7900,44 @@
               <a:t>• 100% In-Site Video Playback: </a:t>
             </a:r>
             <a:r>
-              <a:rPr sz="1100">
-                <a:solidFill>
-                  <a:srgbClr val="CDD2DC"/>
-                </a:solidFill>
-              </a:rPr>
-              <a:t>Media streams directly inside PheW TuBe on the /watch/:id route with zero external redirects to YouTube.</a:t>
+              <a:rPr sz="1600" dirty="0">
+                <a:solidFill>
+                  <a:srgbClr val="CDD2DC"/>
+                </a:solidFill>
+              </a:rPr>
+              <a:t>Media streams directly inside </a:t>
+            </a:r>
+            <a:r>
+              <a:rPr sz="1600" dirty="0" err="1">
+                <a:solidFill>
+                  <a:srgbClr val="CDD2DC"/>
+                </a:solidFill>
+              </a:rPr>
+              <a:t>PheW</a:t>
+            </a:r>
+            <a:r>
+              <a:rPr sz="1600" dirty="0">
+                <a:solidFill>
+                  <a:srgbClr val="CDD2DC"/>
+                </a:solidFill>
+              </a:rPr>
+              <a:t> </a:t>
+            </a:r>
+            <a:r>
+              <a:rPr sz="1600" dirty="0" err="1">
+                <a:solidFill>
+                  <a:srgbClr val="CDD2DC"/>
+                </a:solidFill>
+              </a:rPr>
+              <a:t>TuBe</a:t>
+            </a:r>
+            <a:r>
+              <a:rPr sz="1600" dirty="0">
+                <a:solidFill>
+                  <a:srgbClr val="CDD2DC"/>
+                </a:solidFill>
+              </a:rPr>
+              <a:t> on the /watch/:id route with zero external redirects to YouTube.</a:t>
             </a:r>
           </a:p>
           <a:p>
@@ -7384,7 +7947,7 @@
               </a:spcAft>
             </a:pPr>
             <a:r>
-              <a:rPr sz="1100" b="1">
+              <a:rPr sz="1600" b="1" dirty="0">
                 <a:solidFill>
                   <a:srgbClr val="FFFFFF"/>
                 </a:solidFill>
@@ -7392,7 +7955,7 @@
               <a:t>• Working Interactive Controls: </a:t>
             </a:r>
             <a:r>
-              <a:rPr sz="1100">
+              <a:rPr sz="1600" dirty="0">
                 <a:solidFill>
                   <a:srgbClr val="CDD2DC"/>
                 </a:solidFill>
@@ -7407,7 +7970,7 @@
               </a:spcAft>
             </a:pPr>
             <a:r>
-              <a:rPr sz="1100" b="1">
+              <a:rPr sz="1600" b="1" dirty="0">
                 <a:solidFill>
                   <a:srgbClr val="FFFFFF"/>
                 </a:solidFill>
@@ -7415,7 +7978,7 @@
               <a:t>• Channel Subscription Engine: </a:t>
             </a:r>
             <a:r>
-              <a:rPr sz="1100">
+              <a:rPr sz="1600" dirty="0">
                 <a:solidFill>
                   <a:srgbClr val="CDD2DC"/>
                 </a:solidFill>
@@ -7430,7 +7993,7 @@
               </a:spcAft>
             </a:pPr>
             <a:r>
-              <a:rPr sz="1100" b="1">
+              <a:rPr sz="1600" b="1" dirty="0">
                 <a:solidFill>
                   <a:srgbClr val="FFFFFF"/>
                 </a:solidFill>
@@ -7438,7 +8001,7 @@
               <a:t>• Up-Next Recommendation Sidebar: </a:t>
             </a:r>
             <a:r>
-              <a:rPr sz="1100">
+              <a:rPr sz="1600" dirty="0">
                 <a:solidFill>
                   <a:srgbClr val="CDD2DC"/>
                 </a:solidFill>
@@ -7453,7 +8016,7 @@
               </a:spcAft>
             </a:pPr>
             <a:r>
-              <a:rPr sz="1100" b="1">
+              <a:rPr sz="1600" b="1" dirty="0">
                 <a:solidFill>
                   <a:srgbClr val="FFFFFF"/>
                 </a:solidFill>
@@ -7461,7 +8024,7 @@
               <a:t>• Full Video Metadata: </a:t>
             </a:r>
             <a:r>
-              <a:rPr sz="1100">
+              <a:rPr sz="1600" dirty="0">
                 <a:solidFill>
                   <a:srgbClr val="CDD2DC"/>
                 </a:solidFill>
@@ -7476,14 +8039,14 @@
   <p:clrMapOvr>
     <a:masterClrMapping/>
   </p:clrMapOvr>
-  <p:transition spd="fast">
-    <p:push dir="l"/>
+  <p:transition>
+    <p:push/>
   </p:transition>
 </p:sld>
 </file>
 
 <file path=ppt/slides/slide6.xml><?xml version="1.0" encoding="utf-8"?>
-<p:sld xmlns:a="http://schemas.openxmlformats.org/drawingml/2006/main" xmlns:p="http://schemas.openxmlformats.org/presentationml/2006/main" xmlns:r="http://schemas.openxmlformats.org/officeDocument/2006/relationships">
+<p:sld xmlns:a="http://schemas.openxmlformats.org/drawingml/2006/main" xmlns:r="http://schemas.openxmlformats.org/officeDocument/2006/relationships" xmlns:p="http://schemas.openxmlformats.org/presentationml/2006/main">
   <p:cSld>
     <p:spTree>
       <p:nvGrpSpPr>
@@ -7491,7 +8054,14 @@
         <p:cNvGrpSpPr/>
         <p:nvPr/>
       </p:nvGrpSpPr>
-      <p:grpSpPr/>
+      <p:grpSpPr>
+        <a:xfrm>
+          <a:off x="0" y="0"/>
+          <a:ext cx="0" cy="0"/>
+          <a:chOff x="0" y="0"/>
+          <a:chExt cx="0" cy="0"/>
+        </a:xfrm>
+      </p:grpSpPr>
       <p:sp>
         <p:nvSpPr>
           <p:cNvPr id="2" name="Rectangle 1"/>
@@ -7532,6 +8102,7 @@
           <a:lstStyle/>
           <a:p>
             <a:pPr algn="ctr"/>
+            <a:endParaRPr/>
           </a:p>
         </p:txBody>
       </p:sp>
@@ -7575,6 +8146,7 @@
           <a:lstStyle/>
           <a:p>
             <a:pPr algn="ctr"/>
+            <a:endParaRPr/>
           </a:p>
         </p:txBody>
       </p:sp>
@@ -7622,7 +8194,7 @@
         <p:spPr>
           <a:xfrm>
             <a:off x="731520" y="621792"/>
-            <a:ext cx="10728655" cy="594360"/>
+            <a:ext cx="10728655" cy="523220"/>
           </a:xfrm>
           <a:prstGeom prst="rect">
             <a:avLst/>
@@ -7643,7 +8215,16 @@
               </a:defRPr>
             </a:pPr>
             <a:r>
-              <a:t>Interactive Comments with useRef &amp; Voice Search Pulse</a:t>
+              <a:rPr sz="2800" i="1" u="sng" dirty="0"/>
+              <a:t>Interactive Comments with </a:t>
+            </a:r>
+            <a:r>
+              <a:rPr sz="2800" i="1" u="sng" dirty="0" err="1"/>
+              <a:t>useRef</a:t>
+            </a:r>
+            <a:r>
+              <a:rPr sz="2800" i="1" u="sng" dirty="0"/>
+              <a:t> &amp; Voice Search Pulse</a:t>
             </a:r>
           </a:p>
         </p:txBody>
@@ -7725,6 +8306,7 @@
           <a:lstStyle/>
           <a:p>
             <a:pPr algn="ctr"/>
+            <a:endParaRPr/>
           </a:p>
         </p:txBody>
       </p:sp>
@@ -7794,6 +8376,7 @@
           <a:lstStyle/>
           <a:p>
             <a:pPr algn="ctr"/>
+            <a:endParaRPr/>
           </a:p>
         </p:txBody>
       </p:sp>
@@ -7806,7 +8389,7 @@
         <p:spPr>
           <a:xfrm>
             <a:off x="6449263" y="1490472"/>
-            <a:ext cx="4809744" cy="4334255"/>
+            <a:ext cx="4809744" cy="3985706"/>
           </a:xfrm>
           <a:prstGeom prst="rect">
             <a:avLst/>
@@ -7814,12 +8397,12 @@
           <a:noFill/>
         </p:spPr>
         <p:txBody>
-          <a:bodyPr wrap="square" tIns="0" bIns="0" lIns="0" rIns="0">
+          <a:bodyPr wrap="square" lIns="0" tIns="0" rIns="0" bIns="0">
             <a:spAutoFit/>
           </a:bodyPr>
           <a:lstStyle/>
           <a:p>
-            <a:pPr>
+            <a:pPr algn="ctr">
               <a:spcAft>
                 <a:spcPts val="1000"/>
               </a:spcAft>
@@ -7830,6 +8413,7 @@
               </a:defRPr>
             </a:pPr>
             <a:r>
+              <a:rPr sz="1600" i="1" u="sng" dirty="0"/>
               <a:t>Comments Thread &amp; Speech API Specs</a:t>
             </a:r>
           </a:p>
@@ -7840,7 +8424,7 @@
               </a:spcAft>
             </a:pPr>
             <a:r>
-              <a:rPr sz="1100" b="1">
+              <a:rPr sz="1600" b="1" dirty="0">
                 <a:solidFill>
                   <a:srgbClr val="FFFFFF"/>
                 </a:solidFill>
@@ -7848,7 +8432,7 @@
               <a:t>• Native Web Speech API Mic: </a:t>
             </a:r>
             <a:r>
-              <a:rPr sz="1100">
+              <a:rPr sz="1600" dirty="0">
                 <a:solidFill>
                   <a:srgbClr val="CDD2DC"/>
                 </a:solidFill>
@@ -7863,15 +8447,31 @@
               </a:spcAft>
             </a:pPr>
             <a:r>
-              <a:rPr sz="1100" b="1">
+              <a:rPr sz="1600" b="1" dirty="0">
                 <a:solidFill>
                   <a:srgbClr val="FFFFFF"/>
                 </a:solidFill>
               </a:rPr>
-              <a:t>• DOM Control via useRef: </a:t>
-            </a:r>
-            <a:r>
-              <a:rPr sz="1100">
+              <a:t>• DOM Control via </a:t>
+            </a:r>
+            <a:r>
+              <a:rPr sz="1600" b="1" dirty="0" err="1">
+                <a:solidFill>
+                  <a:srgbClr val="FFFFFF"/>
+                </a:solidFill>
+              </a:rPr>
+              <a:t>useRef</a:t>
+            </a:r>
+            <a:r>
+              <a:rPr sz="1600" b="1" dirty="0">
+                <a:solidFill>
+                  <a:srgbClr val="FFFFFF"/>
+                </a:solidFill>
+              </a:rPr>
+              <a:t>: </a:t>
+            </a:r>
+            <a:r>
+              <a:rPr sz="1600" dirty="0">
                 <a:solidFill>
                   <a:srgbClr val="CDD2DC"/>
                 </a:solidFill>
@@ -7886,7 +8486,7 @@
               </a:spcAft>
             </a:pPr>
             <a:r>
-              <a:rPr sz="1100" b="1">
+              <a:rPr sz="1600" b="1" dirty="0">
                 <a:solidFill>
                   <a:srgbClr val="FFFFFF"/>
                 </a:solidFill>
@@ -7894,7 +8494,7 @@
               <a:t>• Real-Time Discussion Thread: </a:t>
             </a:r>
             <a:r>
-              <a:rPr sz="1100">
+              <a:rPr sz="1600" dirty="0">
                 <a:solidFill>
                   <a:srgbClr val="CDD2DC"/>
                 </a:solidFill>
@@ -7909,7 +8509,7 @@
               </a:spcAft>
             </a:pPr>
             <a:r>
-              <a:rPr sz="1100" b="1">
+              <a:rPr sz="1600" b="1" dirty="0">
                 <a:solidFill>
                   <a:srgbClr val="FFFFFF"/>
                 </a:solidFill>
@@ -7917,7 +8517,7 @@
               <a:t>• Sorting &amp; Filtering Engine: </a:t>
             </a:r>
             <a:r>
-              <a:rPr sz="1100">
+              <a:rPr sz="1600" dirty="0">
                 <a:solidFill>
                   <a:srgbClr val="CDD2DC"/>
                 </a:solidFill>
@@ -7932,7 +8532,7 @@
               </a:spcAft>
             </a:pPr>
             <a:r>
-              <a:rPr sz="1100" b="1">
+              <a:rPr sz="1600" b="1" dirty="0">
                 <a:solidFill>
                   <a:srgbClr val="FFFFFF"/>
                 </a:solidFill>
@@ -7940,7 +8540,7 @@
               <a:t>• Comment Engagement Metrics: </a:t>
             </a:r>
             <a:r>
-              <a:rPr sz="1100">
+              <a:rPr sz="1600" dirty="0">
                 <a:solidFill>
                   <a:srgbClr val="CDD2DC"/>
                 </a:solidFill>
@@ -7955,14 +8555,14 @@
   <p:clrMapOvr>
     <a:masterClrMapping/>
   </p:clrMapOvr>
-  <p:transition spd="fast">
-    <p:push dir="l"/>
+  <p:transition>
+    <p:push/>
   </p:transition>
 </p:sld>
 </file>
 
 <file path=ppt/slides/slide7.xml><?xml version="1.0" encoding="utf-8"?>
-<p:sld xmlns:a="http://schemas.openxmlformats.org/drawingml/2006/main" xmlns:p="http://schemas.openxmlformats.org/presentationml/2006/main" xmlns:r="http://schemas.openxmlformats.org/officeDocument/2006/relationships">
+<p:sld xmlns:a="http://schemas.openxmlformats.org/drawingml/2006/main" xmlns:r="http://schemas.openxmlformats.org/officeDocument/2006/relationships" xmlns:p="http://schemas.openxmlformats.org/presentationml/2006/main">
   <p:cSld>
     <p:spTree>
       <p:nvGrpSpPr>
@@ -7970,7 +8570,14 @@
         <p:cNvGrpSpPr/>
         <p:nvPr/>
       </p:nvGrpSpPr>
-      <p:grpSpPr/>
+      <p:grpSpPr>
+        <a:xfrm>
+          <a:off x="0" y="0"/>
+          <a:ext cx="0" cy="0"/>
+          <a:chOff x="0" y="0"/>
+          <a:chExt cx="0" cy="0"/>
+        </a:xfrm>
+      </p:grpSpPr>
       <p:sp>
         <p:nvSpPr>
           <p:cNvPr id="2" name="Rectangle 1"/>
@@ -8011,6 +8618,7 @@
           <a:lstStyle/>
           <a:p>
             <a:pPr algn="ctr"/>
+            <a:endParaRPr/>
           </a:p>
         </p:txBody>
       </p:sp>
@@ -8054,6 +8662,7 @@
           <a:lstStyle/>
           <a:p>
             <a:pPr algn="ctr"/>
+            <a:endParaRPr/>
           </a:p>
         </p:txBody>
       </p:sp>
@@ -8101,7 +8710,7 @@
         <p:spPr>
           <a:xfrm>
             <a:off x="731520" y="621792"/>
-            <a:ext cx="10728655" cy="594360"/>
+            <a:ext cx="10728655" cy="523220"/>
           </a:xfrm>
           <a:prstGeom prst="rect">
             <a:avLst/>
@@ -8122,6 +8731,7 @@
               </a:defRPr>
             </a:pPr>
             <a:r>
+              <a:rPr sz="2800" i="1" u="sng" dirty="0"/>
               <a:t>Protected Routing &amp; Guest Authentication Gatekeeper</a:t>
             </a:r>
           </a:p>
@@ -8204,6 +8814,7 @@
           <a:lstStyle/>
           <a:p>
             <a:pPr algn="ctr"/>
+            <a:endParaRPr/>
           </a:p>
         </p:txBody>
       </p:sp>
@@ -8273,6 +8884,7 @@
           <a:lstStyle/>
           <a:p>
             <a:pPr algn="ctr"/>
+            <a:endParaRPr/>
           </a:p>
         </p:txBody>
       </p:sp>
@@ -8285,7 +8897,7 @@
         <p:spPr>
           <a:xfrm>
             <a:off x="6449263" y="1490472"/>
-            <a:ext cx="4809744" cy="4334255"/>
+            <a:ext cx="4809744" cy="4231928"/>
           </a:xfrm>
           <a:prstGeom prst="rect">
             <a:avLst/>
@@ -8293,12 +8905,12 @@
           <a:noFill/>
         </p:spPr>
         <p:txBody>
-          <a:bodyPr wrap="square" tIns="0" bIns="0" lIns="0" rIns="0">
+          <a:bodyPr wrap="square" lIns="0" tIns="0" rIns="0" bIns="0">
             <a:spAutoFit/>
           </a:bodyPr>
           <a:lstStyle/>
           <a:p>
-            <a:pPr>
+            <a:pPr algn="ctr">
               <a:spcAft>
                 <a:spcPts val="1000"/>
               </a:spcAft>
@@ -8309,6 +8921,7 @@
               </a:defRPr>
             </a:pPr>
             <a:r>
+              <a:rPr sz="1600" i="1" u="sng" dirty="0"/>
               <a:t>Protected Routing &amp; Session Specs</a:t>
             </a:r>
           </a:p>
@@ -8319,7 +8932,7 @@
               </a:spcAft>
             </a:pPr>
             <a:r>
-              <a:rPr sz="1100" b="1">
+              <a:rPr sz="1600" b="1" dirty="0">
                 <a:solidFill>
                   <a:srgbClr val="FFFFFF"/>
                 </a:solidFill>
@@ -8327,7 +8940,7 @@
               <a:t>• Dedicated Auth Modal: </a:t>
             </a:r>
             <a:r>
-              <a:rPr sz="1100">
+              <a:rPr sz="1600" dirty="0">
                 <a:solidFill>
                   <a:srgbClr val="CDD2DC"/>
                 </a:solidFill>
@@ -8342,7 +8955,7 @@
               </a:spcAft>
             </a:pPr>
             <a:r>
-              <a:rPr sz="1100" b="1">
+              <a:rPr sz="1600" b="1" dirty="0">
                 <a:solidFill>
                   <a:srgbClr val="FFFFFF"/>
                 </a:solidFill>
@@ -8350,7 +8963,7 @@
               <a:t>• Strict Protected Route Gatekeeper: </a:t>
             </a:r>
             <a:r>
-              <a:rPr sz="1100">
+              <a:rPr sz="1600" dirty="0">
                 <a:solidFill>
                   <a:srgbClr val="CDD2DC"/>
                 </a:solidFill>
@@ -8365,7 +8978,7 @@
               </a:spcAft>
             </a:pPr>
             <a:r>
-              <a:rPr sz="1100" b="1">
+              <a:rPr sz="1600" b="1" dirty="0">
                 <a:solidFill>
                   <a:srgbClr val="FFFFFF"/>
                 </a:solidFill>
@@ -8373,7 +8986,7 @@
               <a:t>• Non-Disruptive Interception: </a:t>
             </a:r>
             <a:r>
-              <a:rPr sz="1100">
+              <a:rPr sz="1600" dirty="0">
                 <a:solidFill>
                   <a:srgbClr val="CDD2DC"/>
                 </a:solidFill>
@@ -8388,7 +9001,7 @@
               </a:spcAft>
             </a:pPr>
             <a:r>
-              <a:rPr sz="1100" b="1">
+              <a:rPr sz="1600" b="1" dirty="0">
                 <a:solidFill>
                   <a:srgbClr val="FFFFFF"/>
                 </a:solidFill>
@@ -8396,7 +9009,7 @@
               <a:t>• Automatic Session Hydration: </a:t>
             </a:r>
             <a:r>
-              <a:rPr sz="1100">
+              <a:rPr sz="1600" dirty="0">
                 <a:solidFill>
                   <a:srgbClr val="CDD2DC"/>
                 </a:solidFill>
@@ -8411,7 +9024,7 @@
               </a:spcAft>
             </a:pPr>
             <a:r>
-              <a:rPr sz="1100" b="1">
+              <a:rPr sz="1600" b="1" dirty="0">
                 <a:solidFill>
                   <a:srgbClr val="FFFFFF"/>
                 </a:solidFill>
@@ -8419,12 +9032,28 @@
               <a:t>• Session Persistence: </a:t>
             </a:r>
             <a:r>
-              <a:rPr sz="1100">
-                <a:solidFill>
-                  <a:srgbClr val="CDD2DC"/>
-                </a:solidFill>
-              </a:rPr>
-              <a:t>Stores encrypted session state in LocalStorage, preserving login across browser reloads.</a:t>
+              <a:rPr sz="1600" dirty="0">
+                <a:solidFill>
+                  <a:srgbClr val="CDD2DC"/>
+                </a:solidFill>
+              </a:rPr>
+              <a:t>Stores encrypted session state in </a:t>
+            </a:r>
+            <a:r>
+              <a:rPr sz="1600" dirty="0" err="1">
+                <a:solidFill>
+                  <a:srgbClr val="CDD2DC"/>
+                </a:solidFill>
+              </a:rPr>
+              <a:t>LocalStorage</a:t>
+            </a:r>
+            <a:r>
+              <a:rPr sz="1600" dirty="0">
+                <a:solidFill>
+                  <a:srgbClr val="CDD2DC"/>
+                </a:solidFill>
+              </a:rPr>
+              <a:t>, preserving login across browser reloads.</a:t>
             </a:r>
           </a:p>
         </p:txBody>
@@ -8434,14 +9063,14 @@
   <p:clrMapOvr>
     <a:masterClrMapping/>
   </p:clrMapOvr>
-  <p:transition spd="fast">
-    <p:push dir="l"/>
+  <p:transition>
+    <p:push/>
   </p:transition>
 </p:sld>
 </file>
 
 <file path=ppt/slides/slide8.xml><?xml version="1.0" encoding="utf-8"?>
-<p:sld xmlns:a="http://schemas.openxmlformats.org/drawingml/2006/main" xmlns:p="http://schemas.openxmlformats.org/presentationml/2006/main" xmlns:r="http://schemas.openxmlformats.org/officeDocument/2006/relationships">
+<p:sld xmlns:a="http://schemas.openxmlformats.org/drawingml/2006/main" xmlns:r="http://schemas.openxmlformats.org/officeDocument/2006/relationships" xmlns:p="http://schemas.openxmlformats.org/presentationml/2006/main">
   <p:cSld>
     <p:spTree>
       <p:nvGrpSpPr>
@@ -8449,7 +9078,14 @@
         <p:cNvGrpSpPr/>
         <p:nvPr/>
       </p:nvGrpSpPr>
-      <p:grpSpPr/>
+      <p:grpSpPr>
+        <a:xfrm>
+          <a:off x="0" y="0"/>
+          <a:ext cx="0" cy="0"/>
+          <a:chOff x="0" y="0"/>
+          <a:chExt cx="0" cy="0"/>
+        </a:xfrm>
+      </p:grpSpPr>
       <p:sp>
         <p:nvSpPr>
           <p:cNvPr id="2" name="Rectangle 1"/>
@@ -8490,6 +9126,7 @@
           <a:lstStyle/>
           <a:p>
             <a:pPr algn="ctr"/>
+            <a:endParaRPr/>
           </a:p>
         </p:txBody>
       </p:sp>
@@ -8533,6 +9170,7 @@
           <a:lstStyle/>
           <a:p>
             <a:pPr algn="ctr"/>
+            <a:endParaRPr/>
           </a:p>
         </p:txBody>
       </p:sp>
@@ -8580,7 +9218,7 @@
         <p:spPr>
           <a:xfrm>
             <a:off x="731520" y="621792"/>
-            <a:ext cx="10728655" cy="594360"/>
+            <a:ext cx="10728655" cy="492443"/>
           </a:xfrm>
           <a:prstGeom prst="rect">
             <a:avLst/>
@@ -8601,6 +9239,7 @@
               </a:defRPr>
             </a:pPr>
             <a:r>
+              <a:rPr sz="2600" i="1" u="sng" dirty="0"/>
               <a:t>Real YouTube Settings Panel &amp; Playback Preferences</a:t>
             </a:r>
           </a:p>
@@ -8683,6 +9322,7 @@
           <a:lstStyle/>
           <a:p>
             <a:pPr algn="ctr"/>
+            <a:endParaRPr/>
           </a:p>
         </p:txBody>
       </p:sp>
@@ -8752,6 +9392,7 @@
           <a:lstStyle/>
           <a:p>
             <a:pPr algn="ctr"/>
+            <a:endParaRPr/>
           </a:p>
         </p:txBody>
       </p:sp>
@@ -8764,7 +9405,7 @@
         <p:spPr>
           <a:xfrm>
             <a:off x="6449263" y="1490472"/>
-            <a:ext cx="4809744" cy="4334255"/>
+            <a:ext cx="4809744" cy="3985706"/>
           </a:xfrm>
           <a:prstGeom prst="rect">
             <a:avLst/>
@@ -8772,12 +9413,12 @@
           <a:noFill/>
         </p:spPr>
         <p:txBody>
-          <a:bodyPr wrap="square" tIns="0" bIns="0" lIns="0" rIns="0">
+          <a:bodyPr wrap="square" lIns="0" tIns="0" rIns="0" bIns="0">
             <a:spAutoFit/>
           </a:bodyPr>
           <a:lstStyle/>
           <a:p>
-            <a:pPr>
+            <a:pPr algn="ctr">
               <a:spcAft>
                 <a:spcPts val="1000"/>
               </a:spcAft>
@@ -8788,6 +9429,7 @@
               </a:defRPr>
             </a:pPr>
             <a:r>
+              <a:rPr sz="1600" i="1" u="sng" dirty="0"/>
               <a:t>Settings Architecture &amp; Controls</a:t>
             </a:r>
           </a:p>
@@ -8798,7 +9440,7 @@
               </a:spcAft>
             </a:pPr>
             <a:r>
-              <a:rPr sz="1100" b="1">
+              <a:rPr sz="1600" b="1" dirty="0">
                 <a:solidFill>
                   <a:srgbClr val="FFFFFF"/>
                 </a:solidFill>
@@ -8806,7 +9448,7 @@
               <a:t>• Authentic YouTube Settings UI: </a:t>
             </a:r>
             <a:r>
-              <a:rPr sz="1100">
+              <a:rPr sz="1600" dirty="0">
                 <a:solidFill>
                   <a:srgbClr val="CDD2DC"/>
                 </a:solidFill>
@@ -8821,7 +9463,7 @@
               </a:spcAft>
             </a:pPr>
             <a:r>
-              <a:rPr sz="1100" b="1">
+              <a:rPr sz="1600" b="1" dirty="0">
                 <a:solidFill>
                   <a:srgbClr val="FFFFFF"/>
                 </a:solidFill>
@@ -8829,7 +9471,7 @@
               <a:t>• Display Theme Engine: </a:t>
             </a:r>
             <a:r>
-              <a:rPr sz="1100">
+              <a:rPr sz="1600" dirty="0">
                 <a:solidFill>
                   <a:srgbClr val="CDD2DC"/>
                 </a:solidFill>
@@ -8844,7 +9486,7 @@
               </a:spcAft>
             </a:pPr>
             <a:r>
-              <a:rPr sz="1100" b="1">
+              <a:rPr sz="1600" b="1" dirty="0">
                 <a:solidFill>
                   <a:srgbClr val="FFFFFF"/>
                 </a:solidFill>
@@ -8852,7 +9494,7 @@
               <a:t>• Autoplay Next Video: </a:t>
             </a:r>
             <a:r>
-              <a:rPr sz="1100">
+              <a:rPr sz="1600" dirty="0">
                 <a:solidFill>
                   <a:srgbClr val="CDD2DC"/>
                 </a:solidFill>
@@ -8867,7 +9509,7 @@
               </a:spcAft>
             </a:pPr>
             <a:r>
-              <a:rPr sz="1100" b="1">
+              <a:rPr sz="1600" b="1" dirty="0">
                 <a:solidFill>
                   <a:srgbClr val="FFFFFF"/>
                 </a:solidFill>
@@ -8875,7 +9517,7 @@
               <a:t>• HD 1080p Stream Quality: </a:t>
             </a:r>
             <a:r>
-              <a:rPr sz="1100">
+              <a:rPr sz="1600" dirty="0">
                 <a:solidFill>
                   <a:srgbClr val="CDD2DC"/>
                 </a:solidFill>
@@ -8890,7 +9532,7 @@
               </a:spcAft>
             </a:pPr>
             <a:r>
-              <a:rPr sz="1100" b="1">
+              <a:rPr sz="1600" b="1" dirty="0">
                 <a:solidFill>
                   <a:srgbClr val="FFFFFF"/>
                 </a:solidFill>
@@ -8898,7 +9540,7 @@
               <a:t>• Storage &amp; Cache Controls: </a:t>
             </a:r>
             <a:r>
-              <a:rPr sz="1100">
+              <a:rPr sz="1600" dirty="0">
                 <a:solidFill>
                   <a:srgbClr val="CDD2DC"/>
                 </a:solidFill>
@@ -8913,14 +9555,14 @@
   <p:clrMapOvr>
     <a:masterClrMapping/>
   </p:clrMapOvr>
-  <p:transition spd="fast">
-    <p:push dir="l"/>
+  <p:transition>
+    <p:push/>
   </p:transition>
 </p:sld>
 </file>
 
 <file path=ppt/slides/slide9.xml><?xml version="1.0" encoding="utf-8"?>
-<p:sld xmlns:a="http://schemas.openxmlformats.org/drawingml/2006/main" xmlns:p="http://schemas.openxmlformats.org/presentationml/2006/main" xmlns:r="http://schemas.openxmlformats.org/officeDocument/2006/relationships">
+<p:sld xmlns:a="http://schemas.openxmlformats.org/drawingml/2006/main" xmlns:r="http://schemas.openxmlformats.org/officeDocument/2006/relationships" xmlns:p="http://schemas.openxmlformats.org/presentationml/2006/main">
   <p:cSld>
     <p:spTree>
       <p:nvGrpSpPr>
@@ -8928,7 +9570,14 @@
         <p:cNvGrpSpPr/>
         <p:nvPr/>
       </p:nvGrpSpPr>
-      <p:grpSpPr/>
+      <p:grpSpPr>
+        <a:xfrm>
+          <a:off x="0" y="0"/>
+          <a:ext cx="0" cy="0"/>
+          <a:chOff x="0" y="0"/>
+          <a:chExt cx="0" cy="0"/>
+        </a:xfrm>
+      </p:grpSpPr>
       <p:sp>
         <p:nvSpPr>
           <p:cNvPr id="2" name="Rectangle 1"/>
@@ -8969,6 +9618,7 @@
           <a:lstStyle/>
           <a:p>
             <a:pPr algn="ctr"/>
+            <a:endParaRPr/>
           </a:p>
         </p:txBody>
       </p:sp>
@@ -9012,6 +9662,7 @@
           <a:lstStyle/>
           <a:p>
             <a:pPr algn="ctr"/>
+            <a:endParaRPr/>
           </a:p>
         </p:txBody>
       </p:sp>
@@ -9059,7 +9710,7 @@
         <p:spPr>
           <a:xfrm>
             <a:off x="731520" y="621792"/>
-            <a:ext cx="10728655" cy="594360"/>
+            <a:ext cx="10728655" cy="523220"/>
           </a:xfrm>
           <a:prstGeom prst="rect">
             <a:avLst/>
@@ -9080,6 +9731,7 @@
               </a:defRPr>
             </a:pPr>
             <a:r>
+              <a:rPr sz="2800" i="1" u="sng" dirty="0"/>
               <a:t>Infinite Scroll Feed &amp; YouTube Data API v3 Engine</a:t>
             </a:r>
           </a:p>
@@ -9162,6 +9814,7 @@
           <a:lstStyle/>
           <a:p>
             <a:pPr algn="ctr"/>
+            <a:endParaRPr/>
           </a:p>
         </p:txBody>
       </p:sp>
@@ -9174,7 +9827,7 @@
         <p:spPr>
           <a:xfrm>
             <a:off x="932688" y="1490472"/>
-            <a:ext cx="4809744" cy="4334255"/>
+            <a:ext cx="4809744" cy="3349635"/>
           </a:xfrm>
           <a:prstGeom prst="rect">
             <a:avLst/>
@@ -9182,12 +9835,12 @@
           <a:noFill/>
         </p:spPr>
         <p:txBody>
-          <a:bodyPr wrap="square" tIns="0" bIns="0" lIns="0" rIns="0">
+          <a:bodyPr wrap="square" lIns="0" tIns="0" rIns="0" bIns="0">
             <a:spAutoFit/>
           </a:bodyPr>
           <a:lstStyle/>
           <a:p>
-            <a:pPr>
+            <a:pPr algn="ctr">
               <a:spcAft>
                 <a:spcPts val="1000"/>
               </a:spcAft>
@@ -9198,6 +9851,7 @@
               </a:defRPr>
             </a:pPr>
             <a:r>
+              <a:rPr sz="1600" i="1" u="sng" dirty="0"/>
               <a:t>Infinite Scroll Feed Pagination</a:t>
             </a:r>
           </a:p>
@@ -9208,7 +9862,7 @@
               </a:spcAft>
             </a:pPr>
             <a:r>
-              <a:rPr sz="1150" b="1">
+              <a:rPr sz="2000" b="1" dirty="0">
                 <a:solidFill>
                   <a:srgbClr val="FFFFFF"/>
                 </a:solidFill>
@@ -9216,7 +9870,7 @@
               <a:t>• react-infinite-scroll-component: </a:t>
             </a:r>
             <a:r>
-              <a:rPr sz="1150">
+              <a:rPr sz="2000" dirty="0">
                 <a:solidFill>
                   <a:srgbClr val="CDD2DC"/>
                 </a:solidFill>
@@ -9231,7 +9885,7 @@
               </a:spcAft>
             </a:pPr>
             <a:r>
-              <a:rPr sz="1150" b="1">
+              <a:rPr sz="2000" b="1" dirty="0">
                 <a:solidFill>
                   <a:srgbClr val="FFFFFF"/>
                 </a:solidFill>
@@ -9239,7 +9893,7 @@
               <a:t>• Zero Churn Reconciliation: </a:t>
             </a:r>
             <a:r>
-              <a:rPr sz="1150">
+              <a:rPr sz="2000" dirty="0">
                 <a:solidFill>
                   <a:srgbClr val="CDD2DC"/>
                 </a:solidFill>
@@ -9254,7 +9908,7 @@
               </a:spcAft>
             </a:pPr>
             <a:r>
-              <a:rPr sz="1150" b="1">
+              <a:rPr sz="2000" b="1" dirty="0">
                 <a:solidFill>
                   <a:srgbClr val="FFFFFF"/>
                 </a:solidFill>
@@ -9262,7 +9916,7 @@
               <a:t>• Scroll Trigger Geometry: </a:t>
             </a:r>
             <a:r>
-              <a:rPr sz="1150">
+              <a:rPr sz="2000" dirty="0">
                 <a:solidFill>
                   <a:srgbClr val="CDD2DC"/>
                 </a:solidFill>
@@ -9314,6 +9968,7 @@
           <a:lstStyle/>
           <a:p>
             <a:pPr algn="ctr"/>
+            <a:endParaRPr/>
           </a:p>
         </p:txBody>
       </p:sp>
@@ -9326,7 +9981,7 @@
         <p:spPr>
           <a:xfrm>
             <a:off x="6449263" y="1490472"/>
-            <a:ext cx="4809744" cy="4334255"/>
+            <a:ext cx="4809744" cy="3349635"/>
           </a:xfrm>
           <a:prstGeom prst="rect">
             <a:avLst/>
@@ -9334,12 +9989,12 @@
           <a:noFill/>
         </p:spPr>
         <p:txBody>
-          <a:bodyPr wrap="square" tIns="0" bIns="0" lIns="0" rIns="0">
+          <a:bodyPr wrap="square" lIns="0" tIns="0" rIns="0" bIns="0">
             <a:spAutoFit/>
           </a:bodyPr>
           <a:lstStyle/>
           <a:p>
-            <a:pPr>
+            <a:pPr algn="ctr">
               <a:spcAft>
                 <a:spcPts val="1000"/>
               </a:spcAft>
@@ -9350,6 +10005,7 @@
               </a:defRPr>
             </a:pPr>
             <a:r>
+              <a:rPr sz="1600" i="1" u="sng" dirty="0"/>
               <a:t>YouTube Data API v3 Live Integration</a:t>
             </a:r>
           </a:p>
@@ -9360,7 +10016,7 @@
               </a:spcAft>
             </a:pPr>
             <a:r>
-              <a:rPr sz="1150" b="1">
+              <a:rPr sz="2000" b="1" dirty="0">
                 <a:solidFill>
                   <a:srgbClr val="FFFFFF"/>
                 </a:solidFill>
@@ -9368,7 +10024,7 @@
               <a:t>• Google Cloud YouTube API v3: </a:t>
             </a:r>
             <a:r>
-              <a:rPr sz="1150">
+              <a:rPr sz="2000" dirty="0">
                 <a:solidFill>
                   <a:srgbClr val="CDD2DC"/>
                 </a:solidFill>
@@ -9383,7 +10039,7 @@
               </a:spcAft>
             </a:pPr>
             <a:r>
-              <a:rPr sz="1150" b="1">
+              <a:rPr sz="2000" b="1" dirty="0">
                 <a:solidFill>
                   <a:srgbClr val="FFFFFF"/>
                 </a:solidFill>
@@ -9391,7 +10047,7 @@
               <a:t>• Live Key Manager: </a:t>
             </a:r>
             <a:r>
-              <a:rPr sz="1150">
+              <a:rPr sz="2000" dirty="0">
                 <a:solidFill>
                   <a:srgbClr val="CDD2DC"/>
                 </a:solidFill>
@@ -9406,7 +10062,7 @@
               </a:spcAft>
             </a:pPr>
             <a:r>
-              <a:rPr sz="1150" b="1">
+              <a:rPr sz="2000" b="1" dirty="0">
                 <a:solidFill>
                   <a:srgbClr val="FFFFFF"/>
                 </a:solidFill>
@@ -9414,7 +10070,7 @@
               <a:t>• Resilient Offline Fallback: </a:t>
             </a:r>
             <a:r>
-              <a:rPr sz="1150">
+              <a:rPr sz="2000" dirty="0">
                 <a:solidFill>
                   <a:srgbClr val="CDD2DC"/>
                 </a:solidFill>
@@ -9429,8 +10085,8 @@
   <p:clrMapOvr>
     <a:masterClrMapping/>
   </p:clrMapOvr>
-  <p:transition spd="fast">
-    <p:push dir="l"/>
+  <p:transition>
+    <p:push/>
   </p:transition>
 </p:sld>
 </file>

</xml_diff>